<commit_message>
docs(phase1): focus pitch on team decisions and delivery
</commit_message>
<xml_diff>
--- a/docs/phase1/presentation/ITS_Phase1_Team_Pitch.pptx
+++ b/docs/phase1/presentation/ITS_Phase1_Team_Pitch.pptx
@@ -2,19 +2,18 @@
 <file path=ppt/presentation.xml><?xml version="1.0" encoding="utf-8"?>
 <p:presentation xmlns:p="http://schemas.openxmlformats.org/presentationml/2006/main">
   <p:sldMasterIdLst>
-    <p:sldMasterId xmlns:r="http://schemas.openxmlformats.org/officeDocument/2006/relationships" id="2147483648" r:id="R244f1015c9b64eca"/>
+    <p:sldMasterId xmlns:r="http://schemas.openxmlformats.org/officeDocument/2006/relationships" id="2147483648" r:id="R38e6ed99daff42a5"/>
   </p:sldMasterIdLst>
   <p:notesMasterIdLst>
-    <p:notesMasterId xmlns:r="http://schemas.openxmlformats.org/officeDocument/2006/relationships" r:id="Rdf17bbf93e844c16"/>
+    <p:notesMasterId xmlns:r="http://schemas.openxmlformats.org/officeDocument/2006/relationships" r:id="R5c160953cf3e4190"/>
   </p:notesMasterIdLst>
   <p:sldIdLst>
-    <p:sldId xmlns:r="http://schemas.openxmlformats.org/officeDocument/2006/relationships" id="256" r:id="R4faf2ad0bb944a35"/>
-    <p:sldId xmlns:r="http://schemas.openxmlformats.org/officeDocument/2006/relationships" id="257" r:id="R6601ab601f604c26"/>
-    <p:sldId xmlns:r="http://schemas.openxmlformats.org/officeDocument/2006/relationships" id="258" r:id="Rc1d02cb75a374411"/>
-    <p:sldId xmlns:r="http://schemas.openxmlformats.org/officeDocument/2006/relationships" id="259" r:id="Ra27cca3286db4904"/>
-    <p:sldId xmlns:r="http://schemas.openxmlformats.org/officeDocument/2006/relationships" id="260" r:id="R4533f0bc979a4ea1"/>
-    <p:sldId xmlns:r="http://schemas.openxmlformats.org/officeDocument/2006/relationships" id="261" r:id="R2352278874704816"/>
-    <p:sldId xmlns:r="http://schemas.openxmlformats.org/officeDocument/2006/relationships" id="262" r:id="R3911391752d1433f"/>
+    <p:sldId xmlns:r="http://schemas.openxmlformats.org/officeDocument/2006/relationships" id="256" r:id="Rcef7dada8350451f"/>
+    <p:sldId xmlns:r="http://schemas.openxmlformats.org/officeDocument/2006/relationships" id="257" r:id="Redf0a2b2af3049d2"/>
+    <p:sldId xmlns:r="http://schemas.openxmlformats.org/officeDocument/2006/relationships" id="258" r:id="Rae9bc93029e14712"/>
+    <p:sldId xmlns:r="http://schemas.openxmlformats.org/officeDocument/2006/relationships" id="259" r:id="R2b121a4acd6f4f69"/>
+    <p:sldId xmlns:r="http://schemas.openxmlformats.org/officeDocument/2006/relationships" id="260" r:id="R442d29c8fe124872"/>
+    <p:sldId xmlns:r="http://schemas.openxmlformats.org/officeDocument/2006/relationships" id="261" r:id="R2a3e005584e24837"/>
   </p:sldIdLst>
   <p:sldSz cx="12192000" cy="6858000"/>
   <p:notesSz cx="6858000" cy="9144000"/>
@@ -448,7 +447,7 @@
           <a:lstStyle xmlns:a="http://schemas.openxmlformats.org/drawingml/2006/main"/>
           <a:p xmlns:a="http://schemas.openxmlformats.org/drawingml/2006/main">
             <a:r>
-              <a:t>Sultan — 15 seconds</a:t>
+              <a:t>Sultan - 50 seconds</a:t>
             </a:r>
           </a:p>
           <a:p xmlns:a="http://schemas.openxmlformats.org/drawingml/2006/main">
@@ -458,7 +457,7 @@
           </a:p>
           <a:p xmlns:a="http://schemas.openxmlformats.org/drawingml/2006/main">
             <a:r>
-              <a:t>Good morning. We are Group Four. Our project proposes a campus resource exchange system that helps departments reuse existing equipment. Today we will explain the problem and what we established in Phase One.</a:t>
+              <a:t>Good morning. We will focus on the decisions Group Four made in Phase One and what we will do next. We scoped a hosted web application using free resources and synthetic data. Our plan is to build the Must-have baseline first: asset records, requests, approvals, transfers, maintenance, AI classification and matching, and basic reporting. Then we complete the planned Should-have work, including the assistant and sustainable-action recommendations. Hosting and deployment remain in scope. We have not selected the framework, database, AI provider or host yet. We will compare those choices during feasibility, before committing to the design.</a:t>
             </a:r>
           </a:p>
           <a:p xmlns:a="http://schemas.openxmlformats.org/drawingml/2006/main">
@@ -468,7 +467,7 @@
           </a:p>
           <a:p xmlns:a="http://schemas.openxmlformats.org/drawingml/2006/main">
             <a:r>
-              <a:t>Official title: Intelligent, AI-Powered Circular Campus Resource Exchange and Asset Life Cycle Management System. The photograph shows UNC Chapel Hill, not Khalifa University. It is illustrative and provides no evidence of surplus assets.</a:t>
+              <a:t>COSC336, Khalifa University, Fall 2026. Official project title: Intelligent, AI-Powered Circular Campus Resource Exchange and Asset Life Cycle Management System. This is a Phase 1 planning presentation. The baseline also includes all other Must requirements such as access control, audit history, sustainability indicators and conventional/AI reports; visible examples are not the full scope. Deployment is planned Should NFR-13, in semester scope, with hosting choice in Phase 2, hosted draft in Phase 6 and final URL/instructions in Phase 8. Any course-scope deferral needs instructor agreement. Photo by Ildar Sagdejev (Specious), 30 September 2003, UNC Chapel Hill, not Khalifa University. CC BY-SA 3.0 https://creativecommons.org/licenses/by-sa/3.0 . Resized proportionally without cropping or other edits.</a:t>
             </a:r>
           </a:p>
           <a:p xmlns:a="http://schemas.openxmlformats.org/drawingml/2006/main">
@@ -483,22 +482,22 @@
           </a:p>
           <a:p xmlns:a="http://schemas.openxmlformats.org/drawingml/2006/main">
             <a:r>
-              <a:t>https://github.com/duqins/ITS/blob/main/docs/phase1/sections/00-title.md</a:t>
-            </a:r>
-          </a:p>
-          <a:p xmlns:a="http://schemas.openxmlformats.org/drawingml/2006/main">
-            <a:r>
-              <a:t>https://github.com/duqins/ITS/blob/main/docs/phase1/sections/01-introduction.md</a:t>
-            </a:r>
-          </a:p>
-          <a:p xmlns:a="http://schemas.openxmlformats.org/drawingml/2006/main">
-            <a:r>
-              <a:t>Photo: https://commons.wikimedia.org/wiki/File:2003-09-30_UNC-CH_Phillips_classroom_1.jpg</a:t>
-            </a:r>
-          </a:p>
-          <a:p xmlns:a="http://schemas.openxmlformats.org/drawingml/2006/main">
-            <a:r>
-              <a:t>Photo by Ildar Sagdejev (Specious), 30 September 2003. CC BY-SA 3.0: https://creativecommons.org/licenses/by-sa/3.0 . Image resized proportionally, no cropping or other edits.</a:t>
+              <a:t>https://github.com/duqins/ITS/blob/main/docs/phase1/sections/02-project-overview.md</a:t>
+            </a:r>
+          </a:p>
+          <a:p xmlns:a="http://schemas.openxmlformats.org/drawingml/2006/main">
+            <a:r>
+              <a:t>https://github.com/duqins/ITS/blob/main/docs/phase1/sections/05-requirements-gathering.md</a:t>
+            </a:r>
+          </a:p>
+          <a:p xmlns:a="http://schemas.openxmlformats.org/drawingml/2006/main">
+            <a:r>
+              <a:t>https://github.com/duqins/ITS/blob/main/docs/phase1/sections/08-project-plan.md</a:t>
+            </a:r>
+          </a:p>
+          <a:p xmlns:a="http://schemas.openxmlformats.org/drawingml/2006/main">
+            <a:r>
+              <a:t>https://commons.wikimedia.org/wiki/File:2003-09-30_UNC-CH_Phillips_classroom_1.jpg</a:t>
             </a:r>
           </a:p>
         </p:txBody>
@@ -568,7 +567,7 @@
           <a:lstStyle xmlns:a="http://schemas.openxmlformats.org/drawingml/2006/main"/>
           <a:p xmlns:a="http://schemas.openxmlformats.org/drawingml/2006/main">
             <a:r>
-              <a:t>Sultan — 35 seconds</a:t>
+              <a:t>Zayed - 50 seconds</a:t>
             </a:r>
           </a:p>
           <a:p xmlns:a="http://schemas.openxmlformats.org/drawingml/2006/main">
@@ -578,7 +577,7 @@
           </a:p>
           <a:p xmlns:a="http://schemas.openxmlformats.org/drawingml/2006/main">
             <a:r>
-              <a:t>The assignment describes departments buying equipment while similar usable items sit idle elsewhere. Imagine one department has five unused chairs and another needs seating for five people. This is a hypothetical example. The problem is that people may not know what is available or who can approve a transfer. We want to connect that information, so departments can consider reuse before buying new equipment and keep items useful for longer.</a:t>
+              <a:t>We translated the user roles in the brief into specific responsibilities and approval owners. For a transfer, the custodian keeps the asset record accurate and confirms handover. The releasing and receiving department representatives provide the required approvals, with finance or procurement involved where policy requires it. We also separated technical access from business authority: a system administrator does not gain permission to approve a transfer simply because they manage the software. These rules are documented in our nine-role mapping. Financial thresholds and the final end-of-life approval sequence remain open questions that we will confirm with the client.</a:t>
             </a:r>
           </a:p>
           <a:p xmlns:a="http://schemas.openxmlformats.org/drawingml/2006/main">
@@ -588,7 +587,7 @@
           </a:p>
           <a:p xmlns:a="http://schemas.openxmlformats.org/drawingml/2006/main">
             <a:r>
-              <a:t>The university process is an initial course-scenario analysis. Real stakeholder interviews and process validation are planned. Do not present the chair example as measured campus activity.</a:t>
+              <a:t>Initial proposed requirements, not an implemented or institutionally validated workflow. FR-10 routes approvals and records decision maker, time and reason. FR-11 requires releasing/receiving department approval plus finance/procurement when needed. System roles are distinct from all project stakeholders.</a:t>
             </a:r>
           </a:p>
           <a:p xmlns:a="http://schemas.openxmlformats.org/drawingml/2006/main">
@@ -603,12 +602,17 @@
           </a:p>
           <a:p xmlns:a="http://schemas.openxmlformats.org/drawingml/2006/main">
             <a:r>
-              <a:t>https://github.com/duqins/ITS/blob/main/docs/phase1/sections/01-introduction.md</a:t>
-            </a:r>
-          </a:p>
-          <a:p xmlns:a="http://schemas.openxmlformats.org/drawingml/2006/main">
-            <a:r>
-              <a:t>https://github.com/duqins/ITS/blob/main/docs/phase1/sections/04-as-is-process.md</a:t>
+              <a:t>https://github.com/duqins/ITS/blob/main/docs/phase1/sections/03-stakeholder-analysis.md</a:t>
+            </a:r>
+          </a:p>
+          <a:p xmlns:a="http://schemas.openxmlformats.org/drawingml/2006/main">
+            <a:r>
+              <a:t>https://github.com/duqins/ITS/blob/main/docs/phase1/sections/06-requirements-specification.md</a:t>
+            </a:r>
+          </a:p>
+          <a:p xmlns:a="http://schemas.openxmlformats.org/drawingml/2006/main">
+            <a:r>
+              <a:t>https://github.com/duqins/ITS/blob/main/docs/phase1/sections/10-open-questions-references.md</a:t>
             </a:r>
           </a:p>
         </p:txBody>
@@ -678,7 +682,7 @@
           <a:lstStyle xmlns:a="http://schemas.openxmlformats.org/drawingml/2006/main"/>
           <a:p xmlns:a="http://schemas.openxmlformats.org/drawingml/2006/main">
             <a:r>
-              <a:t>Sultan — 45 seconds</a:t>
+              <a:t>Zayed - 50 seconds</a:t>
             </a:r>
           </a:p>
           <a:p xmlns:a="http://schemas.openxmlformats.org/drawingml/2006/main">
@@ -688,7 +692,7 @@
           </a:p>
           <a:p xmlns:a="http://schemas.openxmlformats.org/drawingml/2006/main">
             <a:r>
-              <a:t>Our proposed web application connects the whole process. A custodian records an asset and publishes it when available. Another department can find it, request it and get the necessary approvals. After the transfer, the system keeps the new location, custodian and maintenance history. AI can help connect a request for seating with a listing called office chairs, but authorised people still approve the transfer. Hosting and deployment are included in our scope. Live finance-system integration and payments are excluded. Zayed will now explain how we established the initial requirements.</a:t>
+              <a:t>Our Phase One output is an initial specification with fifty-two numbered requirements: eighteen classic functional, thirteen AI, eight sustainability and thirteen non-functional requirements. We assigned forty-seven Must and five Should priorities to make the implementation order explicit. We gathered the initial information through course-document analysis and a desk walkthrough of the scenario. We have not conducted stakeholder interviews yet. Next, we will use interviews, a short survey and a process workshop to check assumptions and approval rules. We will record the source of each finding and update the requirements. A requirement becomes validated when the client or an appropriate stakeholder confirms it.</a:t>
             </a:r>
           </a:p>
           <a:p xmlns:a="http://schemas.openxmlformats.org/drawingml/2006/main">
@@ -698,7 +702,7 @@
           </a:p>
           <a:p xmlns:a="http://schemas.openxmlformats.org/drawingml/2006/main">
             <a:r>
-              <a:t>Scope also includes AI services and sustainability reporting. Other exclusions include physical transport/RFID hardware, native mobile apps and custom model training. Deployment is NFR-13, a planned Should-have item after the initial Must-have baseline, with instructor agreement needed for any course-scope deferral.</a:t>
+              <a:t>52 is a requirement count, not an implemented feature count. Should requirements are AI-06, AI-07, AI-08, NFR-11 and NFR-13. Priorities are subject to feasibility/client review. Phase 1 plan and requirements are completed documentation; application, interviews, testing and deployment are future work.</a:t>
             </a:r>
           </a:p>
           <a:p xmlns:a="http://schemas.openxmlformats.org/drawingml/2006/main">
@@ -713,7 +717,12 @@
           </a:p>
           <a:p xmlns:a="http://schemas.openxmlformats.org/drawingml/2006/main">
             <a:r>
-              <a:t>https://github.com/duqins/ITS/blob/main/docs/phase1/sections/02-project-overview.md</a:t>
+              <a:t>https://github.com/duqins/ITS/blob/main/docs/phase1/sections/04-as-is-process.md</a:t>
+            </a:r>
+          </a:p>
+          <a:p xmlns:a="http://schemas.openxmlformats.org/drawingml/2006/main">
+            <a:r>
+              <a:t>https://github.com/duqins/ITS/blob/main/docs/phase1/sections/05-requirements-gathering.md</a:t>
             </a:r>
           </a:p>
           <a:p xmlns:a="http://schemas.openxmlformats.org/drawingml/2006/main">
@@ -788,7 +797,7 @@
           <a:lstStyle xmlns:a="http://schemas.openxmlformats.org/drawingml/2006/main"/>
           <a:p xmlns:a="http://schemas.openxmlformats.org/drawingml/2006/main">
             <a:r>
-              <a:t>Zayed — 55 seconds</a:t>
+              <a:t>Ghith - 50 seconds</a:t>
             </a:r>
           </a:p>
           <a:p xmlns:a="http://schemas.openxmlformats.org/drawingml/2006/main">
@@ -798,7 +807,7 @@
           </a:p>
           <a:p xmlns:a="http://schemas.openxmlformats.org/drawingml/2006/main">
             <a:r>
-              <a:t>For Phase One, we analysed the project description and lab slides, then walked through the assignment scenario. We identified nine system roles and mapped their responsibilities. A requester searches for an asset, a custodian keeps its record, and the releasing and receiving departments approve its transfer. Finance or procurement reviews apply where required. We also documented the current process, its gaps and the initial requirements. This is a preliminary analysis based on the supplied documents. Interviews, a short survey and a process workshop are planned to validate assumptions and detailed approval rules. These outputs gave Ghith a starting point for the specification and success criteria.</a:t>
+              <a:t>Our proposed approach is to check mandatory eligibility before asking AI to rank assets. An unavailable item, an item with the wrong specifications, or a record the requester cannot access must not become an actionable recommendation. AI then ranks eligible candidates and explains the main matching factors. We will distinguish compatibility with the request from the model confidence information, because neither is an approval or a guarantee of correctness. The user chooses an eligible option and the normal approval process still applies. If AI fails, we preserve the entered information and provide classic search. We will test these boundaries as well as match quality.</a:t>
             </a:r>
           </a:p>
           <a:p xmlns:a="http://schemas.openxmlformats.org/drawingml/2006/main">
@@ -808,7 +817,7 @@
           </a:p>
           <a:p xmlns:a="http://schemas.openxmlformats.org/drawingml/2006/main">
             <a:r>
-              <a:t>Nine operational roles: department representative, asset custodian, requester, administrator, procurement officer, finance officer, maintenance staff, sustainability officer and system administrator. Instructors, university management and the team are additional stakeholders. Technical administration does not automatically grant business approval rights.</a:t>
+              <a:t>Proposed approach; no final architecture or model chosen. AI-03 mandatory constraints, AI-04 explanation/compatibility/confidence, AI-05 ranking, AI-13 classic fallback. NFR-07 targets availability of classic alternative within 15 seconds. Final factor weights and AI service are still to be selected and evaluated.</a:t>
             </a:r>
           </a:p>
           <a:p xmlns:a="http://schemas.openxmlformats.org/drawingml/2006/main">
@@ -823,17 +832,12 @@
           </a:p>
           <a:p xmlns:a="http://schemas.openxmlformats.org/drawingml/2006/main">
             <a:r>
-              <a:t>https://github.com/duqins/ITS/blob/main/docs/phase1/sections/03-stakeholder-analysis.md</a:t>
-            </a:r>
-          </a:p>
-          <a:p xmlns:a="http://schemas.openxmlformats.org/drawingml/2006/main">
-            <a:r>
-              <a:t>https://github.com/duqins/ITS/blob/main/docs/phase1/sections/04-as-is-process.md</a:t>
-            </a:r>
-          </a:p>
-          <a:p xmlns:a="http://schemas.openxmlformats.org/drawingml/2006/main">
-            <a:r>
-              <a:t>https://github.com/duqins/ITS/blob/main/docs/phase1/sections/05-requirements-gathering.md</a:t>
+              <a:t>https://github.com/duqins/ITS/blob/main/docs/phase1/sections/06-requirements-specification.md</a:t>
+            </a:r>
+          </a:p>
+          <a:p xmlns:a="http://schemas.openxmlformats.org/drawingml/2006/main">
+            <a:r>
+              <a:t>https://github.com/duqins/ITS/blob/main/docs/phase1/sections/09-classic-vs-ai.md</a:t>
             </a:r>
           </a:p>
         </p:txBody>
@@ -903,7 +907,7 @@
           <a:lstStyle xmlns:a="http://schemas.openxmlformats.org/drawingml/2006/main"/>
           <a:p xmlns:a="http://schemas.openxmlformats.org/drawingml/2006/main">
             <a:r>
-              <a:t>Ghith — 55 seconds</a:t>
+              <a:t>Ghith - 50 seconds</a:t>
             </a:r>
           </a:p>
           <a:p xmlns:a="http://schemas.openxmlformats.org/drawingml/2006/main">
@@ -913,7 +917,7 @@
           </a:p>
           <a:p xmlns:a="http://schemas.openxmlformats.org/drawingml/2006/main">
             <a:r>
-              <a:t>Our initial specification contains fifty-two requirements across classic functions, AI, sustainability and quality. The classic baseline handles records, availability, permissions, approvals and asset history. AI adds classification, matching and draft reports. For example, semantic matching should understand that seating and office chairs may refer to the same need. It must still respect quantity, specifications and permissions, and show why an item was suggested. Classic search remains available if the AI service fails. We also plan an assistant and sustainable-action recommendations after the first baseline. Every requirement has an identifier and priority, so we can trace it into design and testing. The important control is that AI recommends and authorised people approve.</a:t>
+              <a:t>We will compare AI matching with keyword search on the same twenty requests and asset snapshot. Two team members will independently label useful assets, then resolve disagreements using one checklist. Our proposed target is a useful item in the top three AI results for at least sixteen requests, and at least two more successful requests than keyword search. This tests whether AI adds value on our dataset. We will also test approval permissions, attempts to reserve the same item, sustainability calculations and a fresh hosted deployment with AI unavailable. These are planned checks and targets. We do not have measured results yet.</a:t>
             </a:r>
           </a:p>
           <a:p xmlns:a="http://schemas.openxmlformats.org/drawingml/2006/main">
@@ -923,7 +927,7 @@
           </a:p>
           <a:p xmlns:a="http://schemas.openxmlformats.org/drawingml/2006/main">
             <a:r>
-              <a:t>52 is the initial requirement count, not a completed feature count: 18 classic functional, 13 AI, 8 sustainability, 13 non-functional. 47 Must and 5 Should. Should items: AI-06, AI-07, AI-08, NFR-11 and NFR-13. AI recommendations never bypass permission or business approval checks.</a:t>
+              <a:t>Main synthetic dataset: 500 assets, 10 departments, 50 requests. The 20-request evaluation subset has suitable assets. Matching target is top-three request usefulness, not model accuracy. Data-integrity test: 10 two-user attempts to reserve the same single unit, exactly one success each time. Sustainability: 10 hand-calculated cases, missing data, negative net benefit, no duplicate benefits. Count avoided purchase after fulfilled/reviewed demand, subtract attributable costs. Deployment: one teammate performs fresh documented deployment and checks hosted registration/search/request/approval and fallback. Also test 95/100 classic searches within 2 seconds at 5 concurrent users and 4/5 role-appropriate user-task completion.</a:t>
             </a:r>
           </a:p>
           <a:p xmlns:a="http://schemas.openxmlformats.org/drawingml/2006/main">
@@ -938,12 +942,7 @@
           </a:p>
           <a:p xmlns:a="http://schemas.openxmlformats.org/drawingml/2006/main">
             <a:r>
-              <a:t>https://github.com/duqins/ITS/blob/main/docs/phase1/sections/06-requirements-specification.md</a:t>
-            </a:r>
-          </a:p>
-          <a:p xmlns:a="http://schemas.openxmlformats.org/drawingml/2006/main">
-            <a:r>
-              <a:t>https://github.com/duqins/ITS/blob/main/docs/phase1/sections/09-classic-vs-ai.md</a:t>
+              <a:t>https://github.com/duqins/ITS/blob/main/docs/phase1/sections/07-success-criteria.md</a:t>
             </a:r>
           </a:p>
         </p:txBody>
@@ -1013,7 +1012,7 @@
           <a:lstStyle xmlns:a="http://schemas.openxmlformats.org/drawingml/2006/main"/>
           <a:p xmlns:a="http://schemas.openxmlformats.org/drawingml/2006/main">
             <a:r>
-              <a:t>Ghith — 40 seconds</a:t>
+              <a:t>Sultan - 50 seconds</a:t>
             </a:r>
           </a:p>
           <a:p xmlns:a="http://schemas.openxmlformats.org/drawingml/2006/main">
@@ -1023,7 +1022,7 @@
           </a:p>
           <a:p xmlns:a="http://schemas.openxmlformats.org/drawingml/2006/main">
             <a:r>
-              <a:t>These are proposed targets that we will test on synthetic data. We want at least one useful item in the top three matches for sixteen of twenty labelled requests. We will compare AI with keyword search on the same requests. We also want four of five test users to complete the main tasks without help. For classic search, ninety-five of one hundred searches should finish within two seconds with five hundred assets and five concurrent users. These targets give us evidence to judge the prototype.</a:t>
+              <a:t>Our next step is the feasibility study. Ghith will evaluate two AI providers and propose the technology stack and hosting. Zayed will draft the feasibility document and plan the stakeholder validation. I will coordinate the work and the backend dependencies, and we will review the choices together. We chose short work cycles within the course milestones so we can check uncertain choices early and adjust. After feasibility, we refine the requirements, design the system and implement it. The plan includes a hosted draft, testing, and a final deployed application with setup instructions. That is how we will turn our Phase One decisions into a working prototype.</a:t>
             </a:r>
           </a:p>
           <a:p xmlns:a="http://schemas.openxmlformats.org/drawingml/2006/main">
@@ -1033,112 +1032,7 @@
           </a:p>
           <a:p xmlns:a="http://schemas.openxmlformats.org/drawingml/2006/main">
             <a:r>
-              <a:t>These are future acceptance criteria, not measured results. The matching metric is request success within the top three, not model accuracy. Tasks are appropriate to each test user role. Classic search timing excludes AI latency. The report also defines approval, fallback, sustainability and hosted-workflow tests. Compare AI with the keyword baseline; the planned target is at least two additional successful requests out of twenty.</a:t>
-            </a:r>
-          </a:p>
-          <a:p xmlns:a="http://schemas.openxmlformats.org/drawingml/2006/main">
-            <a:r>
-              <a:t/>
-            </a:r>
-          </a:p>
-          <a:p xmlns:a="http://schemas.openxmlformats.org/drawingml/2006/main">
-            <a:r>
-              <a:t>Sources:</a:t>
-            </a:r>
-          </a:p>
-          <a:p xmlns:a="http://schemas.openxmlformats.org/drawingml/2006/main">
-            <a:r>
-              <a:t>https://github.com/duqins/ITS/blob/main/docs/phase1/sections/07-success-criteria.md</a:t>
-            </a:r>
-          </a:p>
-        </p:txBody>
-      </p:sp>
-      <p:sp>
-        <p:nvSpPr>
-          <p:cNvPr id="4" name="Slide Number Placeholder 3"/>
-          <p:cNvSpPr>
-            <a:spLocks xmlns:a="http://schemas.openxmlformats.org/drawingml/2006/main" noGrp="1"/>
-          </p:cNvSpPr>
-          <p:nvPr>
-            <p:ph type="sldNum" idx="5"/>
-          </p:nvPr>
-        </p:nvSpPr>
-        <p:spPr/>
-        <p:txBody>
-          <a:bodyPr xmlns:a="http://schemas.openxmlformats.org/drawingml/2006/main"/>
-          <a:lstStyle xmlns:a="http://schemas.openxmlformats.org/drawingml/2006/main"/>
-          <a:p xmlns:a="http://schemas.openxmlformats.org/drawingml/2006/main"/>
-        </p:txBody>
-      </p:sp>
-    </p:spTree>
-  </p:cSld>
-  <p:clrMapOvr>
-    <a:masterClrMapping xmlns:a="http://schemas.openxmlformats.org/drawingml/2006/main"/>
-  </p:clrMapOvr>
-</p:notes>
-</file>
-
-<file path=ppt/notesSlides/notesSlide7.xml><?xml version="1.0" encoding="utf-8"?>
-<p:notes xmlns:p="http://schemas.openxmlformats.org/presentationml/2006/main">
-  <p:cSld>
-    <p:spTree>
-      <p:nvGrpSpPr>
-        <p:cNvPr id="1" name=""/>
-        <p:cNvGrpSpPr/>
-        <p:nvPr/>
-      </p:nvGrpSpPr>
-      <p:grpSpPr>
-        <a:xfrm xmlns:a="http://schemas.openxmlformats.org/drawingml/2006/main"/>
-      </p:grpSpPr>
-      <p:sp>
-        <p:nvSpPr>
-          <p:cNvPr id="2" name="Slide Image Placeholder 1"/>
-          <p:cNvSpPr>
-            <a:spLocks xmlns:a="http://schemas.openxmlformats.org/drawingml/2006/main" noGrp="1"/>
-          </p:cNvSpPr>
-          <p:nvPr>
-            <p:ph type="sldImg" idx="0"/>
-          </p:nvPr>
-        </p:nvSpPr>
-        <p:spPr/>
-      </p:sp>
-      <p:sp>
-        <p:nvSpPr>
-          <p:cNvPr id="3" name="Notes Placeholder 2"/>
-          <p:cNvSpPr>
-            <a:spLocks xmlns:a="http://schemas.openxmlformats.org/drawingml/2006/main" noGrp="1"/>
-          </p:cNvSpPr>
-          <p:nvPr>
-            <p:ph type="body" idx="1"/>
-          </p:nvPr>
-        </p:nvSpPr>
-        <p:spPr/>
-        <p:txBody>
-          <a:bodyPr xmlns:a="http://schemas.openxmlformats.org/drawingml/2006/main"/>
-          <a:lstStyle xmlns:a="http://schemas.openxmlformats.org/drawingml/2006/main"/>
-          <a:p xmlns:a="http://schemas.openxmlformats.org/drawingml/2006/main">
-            <a:r>
-              <a:t>Sultan — 55 seconds</a:t>
-            </a:r>
-          </a:p>
-          <a:p xmlns:a="http://schemas.openxmlformats.org/drawingml/2006/main">
-            <a:r>
-              <a:t/>
-            </a:r>
-          </a:p>
-          <a:p xmlns:a="http://schemas.openxmlformats.org/drawingml/2006/main">
-            <a:r>
-              <a:t>Those requirements and tests lead to our delivery plan. We use short work cycles within the course phases: plan a small piece, complete it, review it and adjust. Our next step is the feasibility study, where we check our technology, AI access, hosting and available time. Then we refine requirements, design the system, build and deploy it, and test it before the final demonstration. I coordinate the project and backend integration. Zayed leads requirements, user experience and testing. Ghith leads architecture, AI and deployment, with my support. We will test uncertain choices early and keep classic workflows available if AI fails. Phase One gives us the scope, responsibilities and testable requirements to start that work. Thank you.</a:t>
-            </a:r>
-          </a:p>
-          <a:p xmlns:a="http://schemas.openxmlformats.org/drawingml/2006/main">
-            <a:r>
-              <a:t/>
-            </a:r>
-          </a:p>
-          <a:p xmlns:a="http://schemas.openxmlformats.org/drawingml/2006/main">
-            <a:r>
-              <a:t>Hosting selection is planned for Phase 2, an initial hosted version for Phase 6 and the final HTTPS URL with deployment instructions for Phase 8. Calendar dates are provisional because course sources differ, so the pitch uses phases. No application has been implemented or deployed in Phase 1.</a:t>
+              <a:t>Proposed ownership and next steps, not completed feasibility work. AI-provider comparison comes from risk R1. Framework, relational database, AI/embedding API and host are unchosen. Hosting selected in Phase 2, initial hosted draft in Phase 6, final HTTPS URL/restart instructions in Phase 8. Ghith leads deployment with Sultan supporting configuration/integration. Dates remain provisional because course documents differ. Team timing: Sultan slides 1 and 6, Zayed 2 and 3, Ghith 4 and 5. Each 100 seconds, total 300 seconds.</a:t>
             </a:r>
           </a:p>
           <a:p xmlns:a="http://schemas.openxmlformats.org/drawingml/2006/main">
@@ -1226,7 +1120,7 @@
   </p:cSld>
   <p:clrMap bg1="lt1" tx1="dk1" bg2="lt2" tx2="dk2" accent1="accent1" accent2="accent2" accent3="accent3" accent4="accent4" accent5="accent5" accent6="accent6" hlink="hlink" folHlink="folHlink"/>
   <p:sldLayoutIdLst>
-    <p:sldLayoutId xmlns:r="http://schemas.openxmlformats.org/officeDocument/2006/relationships" id="2147483649" r:id="R7c487ad5f8a5487a"/>
+    <p:sldLayoutId xmlns:r="http://schemas.openxmlformats.org/officeDocument/2006/relationships" id="2147483649" r:id="R7a2418248d744fdd"/>
   </p:sldLayoutIdLst>
   <p:txStyles>
     <p:titleStyle>
@@ -1774,10 +1668,10 @@
       </p:grpSpPr>
       <p:sp>
         <p:nvSpPr>
-          <p:cNvPr id="8" name="phase-label">
+          <p:cNvPr id="10" name="project-label">
             <a:extLst xmlns:a="http://schemas.openxmlformats.org/drawingml/2006/main">
               <a:ext uri="{FF2B5EF4-FFF2-40B4-BE49-F238E27FC236}">
-                <a16:creationId xmlns:a16="http://schemas.microsoft.com/office/drawing/2014/main" id="{C037F4D0-BA6A-4D5B-9D11-97038BD49DD1}"/>
+                <a16:creationId xmlns:a16="http://schemas.microsoft.com/office/drawing/2014/main" id="{CDE87D20-A765-46C3-835F-CBC7F14AB7D4}"/>
               </a:ext>
             </a:extLst>
           </p:cNvPr>
@@ -1788,8 +1682,8 @@
         </p:nvSpPr>
         <p:spPr>
           <a:xfrm xmlns:a="http://schemas.openxmlformats.org/drawingml/2006/main">
-            <a:off x="685800" y="866775"/>
-            <a:ext cx="5953125" cy="419100"/>
+            <a:off x="685800" y="685800"/>
+            <a:ext cx="6286500" cy="428625"/>
           </a:xfrm>
           <a:prstGeom xmlns:a="http://schemas.openxmlformats.org/drawingml/2006/main" prst="rect">
             <a:avLst/>
@@ -1824,7 +1718,7 @@
                 <a:ea typeface="Arial"/>
                 <a:cs typeface="Arial"/>
               </a:rPr>
-              <a:t>Phase 1 project pitch</a:t>
+              <a:t>Campus Resource Exchange</a:t>
             </a:r>
           </a:p>
         </p:txBody>
@@ -1834,7 +1728,7 @@
           <p:cNvPr id="2" name="cover-title">
             <a:extLst xmlns:a="http://schemas.openxmlformats.org/drawingml/2006/main">
               <a:ext uri="{FF2B5EF4-FFF2-40B4-BE49-F238E27FC236}">
-                <a16:creationId xmlns:a16="http://schemas.microsoft.com/office/drawing/2014/main" id="{C0CA46A2-7E09-44BB-8368-976B56EB0730}"/>
+                <a16:creationId xmlns:a16="http://schemas.microsoft.com/office/drawing/2014/main" id="{0C6D1AB5-73E4-4260-A396-46E3FF5C2EF9}"/>
               </a:ext>
             </a:extLst>
           </p:cNvPr>
@@ -1845,8 +1739,8 @@
         </p:nvSpPr>
         <p:spPr>
           <a:xfrm xmlns:a="http://schemas.openxmlformats.org/drawingml/2006/main">
-            <a:off x="685800" y="1790700"/>
-            <a:ext cx="6286500" cy="1619250"/>
+            <a:off x="685800" y="1438275"/>
+            <a:ext cx="6238875" cy="1533525"/>
           </a:xfrm>
           <a:prstGeom xmlns:a="http://schemas.openxmlformats.org/drawingml/2006/main" prst="rect">
             <a:avLst/>
@@ -1863,58 +1757,58 @@
           <a:lstStyle xmlns:a="http://schemas.openxmlformats.org/drawingml/2006/main"/>
           <a:p xmlns:a="http://schemas.openxmlformats.org/drawingml/2006/main">
             <a:pPr algn="l">
-              <a:defRPr sz="4800" b="1">
-                <a:solidFill>
-                  <a:srgbClr val="17343C"/>
-                </a:solidFill>
-                <a:latin typeface="Arial"/>
-                <a:ea typeface="Arial"/>
-                <a:cs typeface="Arial"/>
-              </a:defRPr>
-            </a:pPr>
-            <a:r>
-              <a:rPr sz="4800" b="1">
-                <a:solidFill>
-                  <a:srgbClr val="17343C"/>
-                </a:solidFill>
-                <a:latin typeface="Arial"/>
-                <a:ea typeface="Arial"/>
-                <a:cs typeface="Arial"/>
-              </a:rPr>
-              <a:t>Campus</a:t>
-            </a:r>
-          </a:p>
-          <a:p xmlns:a="http://schemas.openxmlformats.org/drawingml/2006/main">
-            <a:pPr algn="l">
-              <a:defRPr sz="4800" b="1">
-                <a:solidFill>
-                  <a:srgbClr val="17343C"/>
-                </a:solidFill>
-                <a:latin typeface="Arial"/>
-                <a:ea typeface="Arial"/>
-                <a:cs typeface="Arial"/>
-              </a:defRPr>
-            </a:pPr>
-            <a:r>
-              <a:rPr sz="4800" b="1">
-                <a:solidFill>
-                  <a:srgbClr val="17343C"/>
-                </a:solidFill>
-                <a:latin typeface="Arial"/>
-                <a:ea typeface="Arial"/>
-                <a:cs typeface="Arial"/>
-              </a:rPr>
-              <a:t>Resource Exchange</a:t>
-            </a:r>
-          </a:p>
-        </p:txBody>
-      </p:sp>
-      <p:sp>
-        <p:nvSpPr>
-          <p:cNvPr id="3" name="cover-purpose">
+              <a:defRPr sz="4500" b="1">
+                <a:solidFill>
+                  <a:srgbClr val="17343C"/>
+                </a:solidFill>
+                <a:latin typeface="Arial"/>
+                <a:ea typeface="Arial"/>
+                <a:cs typeface="Arial"/>
+              </a:defRPr>
+            </a:pPr>
+            <a:r>
+              <a:rPr sz="4500" b="1">
+                <a:solidFill>
+                  <a:srgbClr val="17343C"/>
+                </a:solidFill>
+                <a:latin typeface="Arial"/>
+                <a:ea typeface="Arial"/>
+                <a:cs typeface="Arial"/>
+              </a:rPr>
+              <a:t>Our scope</a:t>
+            </a:r>
+          </a:p>
+          <a:p xmlns:a="http://schemas.openxmlformats.org/drawingml/2006/main">
+            <a:pPr algn="l">
+              <a:defRPr sz="4500" b="1">
+                <a:solidFill>
+                  <a:srgbClr val="17343C"/>
+                </a:solidFill>
+                <a:latin typeface="Arial"/>
+                <a:ea typeface="Arial"/>
+                <a:cs typeface="Arial"/>
+              </a:defRPr>
+            </a:pPr>
+            <a:r>
+              <a:rPr sz="4500" b="1">
+                <a:solidFill>
+                  <a:srgbClr val="17343C"/>
+                </a:solidFill>
+                <a:latin typeface="Arial"/>
+                <a:ea typeface="Arial"/>
+                <a:cs typeface="Arial"/>
+              </a:rPr>
+              <a:t>and priorities</a:t>
+            </a:r>
+          </a:p>
+        </p:txBody>
+      </p:sp>
+      <p:sp>
+        <p:nvSpPr>
+          <p:cNvPr id="3" name="scope">
             <a:extLst xmlns:a="http://schemas.openxmlformats.org/drawingml/2006/main">
               <a:ext uri="{FF2B5EF4-FFF2-40B4-BE49-F238E27FC236}">
-                <a16:creationId xmlns:a16="http://schemas.microsoft.com/office/drawing/2014/main" id="{9C542DBF-3B6A-4683-A11B-BB22D43D8BAA}"/>
+                <a16:creationId xmlns:a16="http://schemas.microsoft.com/office/drawing/2014/main" id="{6CAF67DD-3307-47FF-96C8-B632C90BC8B9}"/>
               </a:ext>
             </a:extLst>
           </p:cNvPr>
@@ -1925,8 +1819,8 @@
         </p:nvSpPr>
         <p:spPr>
           <a:xfrm xmlns:a="http://schemas.openxmlformats.org/drawingml/2006/main">
-            <a:off x="685800" y="3724275"/>
-            <a:ext cx="6096000" cy="933450"/>
+            <a:off x="685800" y="3286125"/>
+            <a:ext cx="6191250" cy="495300"/>
           </a:xfrm>
           <a:prstGeom xmlns:a="http://schemas.openxmlformats.org/drawingml/2006/main" prst="rect">
             <a:avLst/>
@@ -1943,62 +1837,153 @@
           <a:lstStyle xmlns:a="http://schemas.openxmlformats.org/drawingml/2006/main"/>
           <a:p xmlns:a="http://schemas.openxmlformats.org/drawingml/2006/main">
             <a:pPr algn="l">
-              <a:defRPr sz="2175" b="0">
-                <a:solidFill>
-                  <a:srgbClr val="17343C"/>
-                </a:solidFill>
-                <a:latin typeface="Arial"/>
-                <a:ea typeface="Arial"/>
-                <a:cs typeface="Arial"/>
-              </a:defRPr>
-            </a:pPr>
-            <a:r>
-              <a:rPr sz="2175" b="0">
-                <a:solidFill>
-                  <a:srgbClr val="17343C"/>
-                </a:solidFill>
-                <a:latin typeface="Arial"/>
-                <a:ea typeface="Arial"/>
-                <a:cs typeface="Arial"/>
-              </a:rPr>
-              <a:t>Reusing university assets with</a:t>
-            </a:r>
-          </a:p>
-          <a:p xmlns:a="http://schemas.openxmlformats.org/drawingml/2006/main">
-            <a:pPr algn="l">
-              <a:defRPr sz="2175" b="0">
-                <a:solidFill>
-                  <a:srgbClr val="17343C"/>
-                </a:solidFill>
-                <a:latin typeface="Arial"/>
-                <a:ea typeface="Arial"/>
-                <a:cs typeface="Arial"/>
-              </a:defRPr>
-            </a:pPr>
-            <a:r>
-              <a:rPr sz="2175" b="0">
-                <a:solidFill>
-                  <a:srgbClr val="17343C"/>
-                </a:solidFill>
-                <a:latin typeface="Arial"/>
-                <a:ea typeface="Arial"/>
-                <a:cs typeface="Arial"/>
-              </a:rPr>
-              <a:t>AI support and human approvals</a:t>
+              <a:defRPr sz="2250" b="1">
+                <a:solidFill>
+                  <a:srgbClr val="17343C"/>
+                </a:solidFill>
+                <a:latin typeface="Arial"/>
+                <a:ea typeface="Arial"/>
+                <a:cs typeface="Arial"/>
+              </a:defRPr>
+            </a:pPr>
+            <a:r>
+              <a:rPr sz="2250" b="1">
+                <a:solidFill>
+                  <a:srgbClr val="17343C"/>
+                </a:solidFill>
+                <a:latin typeface="Arial"/>
+                <a:ea typeface="Arial"/>
+                <a:cs typeface="Arial"/>
+              </a:rPr>
+              <a:t>Hosted web application</a:t>
+            </a:r>
+          </a:p>
+        </p:txBody>
+      </p:sp>
+      <p:sp>
+        <p:nvSpPr>
+          <p:cNvPr id="4" name="priority">
+            <a:extLst xmlns:a="http://schemas.openxmlformats.org/drawingml/2006/main">
+              <a:ext uri="{FF2B5EF4-FFF2-40B4-BE49-F238E27FC236}">
+                <a16:creationId xmlns:a16="http://schemas.microsoft.com/office/drawing/2014/main" id="{F753C79C-E3F2-460C-B573-1287FBA1383D}"/>
+              </a:ext>
+            </a:extLst>
+          </p:cNvPr>
+          <p:cNvSpPr>
+            <a:spLocks xmlns:a="http://schemas.openxmlformats.org/drawingml/2006/main" noGrp="1"/>
+          </p:cNvSpPr>
+          <p:nvPr/>
+        </p:nvSpPr>
+        <p:spPr>
+          <a:xfrm xmlns:a="http://schemas.openxmlformats.org/drawingml/2006/main">
+            <a:off x="685800" y="3914775"/>
+            <a:ext cx="6191250" cy="619125"/>
+          </a:xfrm>
+          <a:prstGeom xmlns:a="http://schemas.openxmlformats.org/drawingml/2006/main" prst="rect">
+            <a:avLst/>
+          </a:prstGeom>
+          <a:noFill xmlns:a="http://schemas.openxmlformats.org/drawingml/2006/main"/>
+          <a:ln xmlns:a="http://schemas.openxmlformats.org/drawingml/2006/main" w="0">
+            <a:noFill/>
+          </a:ln>
+        </p:spPr>
+        <p:txBody>
+          <a:bodyPr xmlns:a="http://schemas.openxmlformats.org/drawingml/2006/main" wrap="square" lIns="0" tIns="0" rIns="0" bIns="0" anchor="t">
+            <a:noAutofit/>
+          </a:bodyPr>
+          <a:lstStyle xmlns:a="http://schemas.openxmlformats.org/drawingml/2006/main"/>
+          <a:p xmlns:a="http://schemas.openxmlformats.org/drawingml/2006/main">
+            <a:pPr algn="l">
+              <a:defRPr sz="2100" b="0">
+                <a:solidFill>
+                  <a:srgbClr val="17343C"/>
+                </a:solidFill>
+                <a:latin typeface="Arial"/>
+                <a:ea typeface="Arial"/>
+                <a:cs typeface="Arial"/>
+              </a:defRPr>
+            </a:pPr>
+            <a:r>
+              <a:rPr sz="2100" b="0">
+                <a:solidFill>
+                  <a:srgbClr val="17343C"/>
+                </a:solidFill>
+                <a:latin typeface="Arial"/>
+                <a:ea typeface="Arial"/>
+                <a:cs typeface="Arial"/>
+              </a:rPr>
+              <a:t>Must baseline before planned extensions</a:t>
+            </a:r>
+          </a:p>
+        </p:txBody>
+      </p:sp>
+      <p:sp>
+        <p:nvSpPr>
+          <p:cNvPr id="5" name="resources">
+            <a:extLst xmlns:a="http://schemas.openxmlformats.org/drawingml/2006/main">
+              <a:ext uri="{FF2B5EF4-FFF2-40B4-BE49-F238E27FC236}">
+                <a16:creationId xmlns:a16="http://schemas.microsoft.com/office/drawing/2014/main" id="{08F552D2-7B33-48CF-9094-BB17B45E7159}"/>
+              </a:ext>
+            </a:extLst>
+          </p:cNvPr>
+          <p:cNvSpPr>
+            <a:spLocks xmlns:a="http://schemas.openxmlformats.org/drawingml/2006/main" noGrp="1"/>
+          </p:cNvSpPr>
+          <p:nvPr/>
+        </p:nvSpPr>
+        <p:spPr>
+          <a:xfrm xmlns:a="http://schemas.openxmlformats.org/drawingml/2006/main">
+            <a:off x="685800" y="4610100"/>
+            <a:ext cx="6191250" cy="476250"/>
+          </a:xfrm>
+          <a:prstGeom xmlns:a="http://schemas.openxmlformats.org/drawingml/2006/main" prst="rect">
+            <a:avLst/>
+          </a:prstGeom>
+          <a:noFill xmlns:a="http://schemas.openxmlformats.org/drawingml/2006/main"/>
+          <a:ln xmlns:a="http://schemas.openxmlformats.org/drawingml/2006/main" w="0">
+            <a:noFill/>
+          </a:ln>
+        </p:spPr>
+        <p:txBody>
+          <a:bodyPr xmlns:a="http://schemas.openxmlformats.org/drawingml/2006/main" wrap="square" lIns="0" tIns="0" rIns="0" bIns="0" anchor="t">
+            <a:noAutofit/>
+          </a:bodyPr>
+          <a:lstStyle xmlns:a="http://schemas.openxmlformats.org/drawingml/2006/main"/>
+          <a:p xmlns:a="http://schemas.openxmlformats.org/drawingml/2006/main">
+            <a:pPr algn="l">
+              <a:defRPr sz="2100" b="0">
+                <a:solidFill>
+                  <a:srgbClr val="17343C"/>
+                </a:solidFill>
+                <a:latin typeface="Arial"/>
+                <a:ea typeface="Arial"/>
+                <a:cs typeface="Arial"/>
+              </a:defRPr>
+            </a:pPr>
+            <a:r>
+              <a:rPr sz="2100" b="0">
+                <a:solidFill>
+                  <a:srgbClr val="17343C"/>
+                </a:solidFill>
+                <a:latin typeface="Arial"/>
+                <a:ea typeface="Arial"/>
+                <a:cs typeface="Arial"/>
+              </a:rPr>
+              <a:t>Free resources and synthetic data</a:t>
             </a:r>
           </a:p>
         </p:txBody>
       </p:sp>
       <p:pic>
         <p:nvPicPr>
-          <p:cNvPr id="11" name=""/>
+          <p:cNvPr id="15" name=""/>
           <p:cNvPicPr>
             <a:picLocks xmlns:a="http://schemas.openxmlformats.org/drawingml/2006/main" noChangeAspect="1"/>
           </p:cNvPicPr>
           <p:nvPr/>
         </p:nvPicPr>
         <p:blipFill>
-          <a:blip xmlns:r="http://schemas.openxmlformats.org/officeDocument/2006/relationships" xmlns:a="http://schemas.openxmlformats.org/drawingml/2006/main" r:embed="Reb82d8a44ae54fa1"/>
+          <a:blip xmlns:r="http://schemas.openxmlformats.org/officeDocument/2006/relationships" xmlns:a="http://schemas.openxmlformats.org/drawingml/2006/main" r:embed="R79ebd1c319294e10"/>
           <a:stretch xmlns:a="http://schemas.openxmlformats.org/drawingml/2006/main"/>
         </p:blipFill>
         <p:spPr>
@@ -2013,10 +1998,10 @@
       </p:pic>
       <p:sp>
         <p:nvSpPr>
-          <p:cNvPr id="5" name="photo-caption">
+          <p:cNvPr id="7" name="photo-caption">
             <a:extLst xmlns:a="http://schemas.openxmlformats.org/drawingml/2006/main">
               <a:ext uri="{FF2B5EF4-FFF2-40B4-BE49-F238E27FC236}">
-                <a16:creationId xmlns:a16="http://schemas.microsoft.com/office/drawing/2014/main" id="{66F8A7BA-7FC2-4A68-9B7D-3069F570E64A}"/>
+                <a16:creationId xmlns:a16="http://schemas.microsoft.com/office/drawing/2014/main" id="{08F95238-A368-40D8-A6DA-A68438CC44BA}"/>
               </a:ext>
             </a:extLst>
           </p:cNvPr>
@@ -2070,10 +2055,10 @@
       </p:sp>
       <p:sp>
         <p:nvSpPr>
-          <p:cNvPr id="6" name="team">
+          <p:cNvPr id="8" name="open-decision">
             <a:extLst xmlns:a="http://schemas.openxmlformats.org/drawingml/2006/main">
               <a:ext uri="{FF2B5EF4-FFF2-40B4-BE49-F238E27FC236}">
-                <a16:creationId xmlns:a16="http://schemas.microsoft.com/office/drawing/2014/main" id="{244D87D7-B640-4E70-B759-03970CD79C56}"/>
+                <a16:creationId xmlns:a16="http://schemas.microsoft.com/office/drawing/2014/main" id="{174A1724-1D35-4D6E-8DF0-A08EE147D106}"/>
               </a:ext>
             </a:extLst>
           </p:cNvPr>
@@ -2084,8 +2069,8 @@
         </p:nvSpPr>
         <p:spPr>
           <a:xfrm xmlns:a="http://schemas.openxmlformats.org/drawingml/2006/main">
-            <a:off x="685800" y="5600700"/>
-            <a:ext cx="10820400" cy="400050"/>
+            <a:off x="685800" y="5572125"/>
+            <a:ext cx="10820400" cy="457200"/>
           </a:xfrm>
           <a:prstGeom xmlns:a="http://schemas.openxmlformats.org/drawingml/2006/main" prst="rect">
             <a:avLst/>
@@ -2104,7 +2089,7 @@
             <a:pPr algn="l">
               <a:defRPr sz="1875" b="0">
                 <a:solidFill>
-                  <a:srgbClr val="17343C"/>
+                  <a:srgbClr val="536466"/>
                 </a:solidFill>
                 <a:latin typeface="Arial"/>
                 <a:ea typeface="Arial"/>
@@ -2114,23 +2099,23 @@
             <a:r>
               <a:rPr sz="1875" b="0">
                 <a:solidFill>
-                  <a:srgbClr val="17343C"/>
-                </a:solidFill>
-                <a:latin typeface="Arial"/>
-                <a:ea typeface="Arial"/>
-                <a:cs typeface="Arial"/>
-              </a:rPr>
-              <a:t>Sultan Almheiri, Zayed Alfadli and Ghith Alhinaai</a:t>
-            </a:r>
-          </a:p>
-        </p:txBody>
-      </p:sp>
-      <p:sp>
-        <p:nvSpPr>
-          <p:cNvPr id="7" name="course">
+                  <a:srgbClr val="536466"/>
+                </a:solidFill>
+                <a:latin typeface="Arial"/>
+                <a:ea typeface="Arial"/>
+                <a:cs typeface="Arial"/>
+              </a:rPr>
+              <a:t>Stack, database, AI service and hosting provider: Phase 2 decisions</a:t>
+            </a:r>
+          </a:p>
+        </p:txBody>
+      </p:sp>
+      <p:sp>
+        <p:nvSpPr>
+          <p:cNvPr id="9" name="team">
             <a:extLst xmlns:a="http://schemas.openxmlformats.org/drawingml/2006/main">
               <a:ext uri="{FF2B5EF4-FFF2-40B4-BE49-F238E27FC236}">
-                <a16:creationId xmlns:a16="http://schemas.microsoft.com/office/drawing/2014/main" id="{DF1B20CC-1CC4-4B07-AE2A-D4F3B9C44DF7}"/>
+                <a16:creationId xmlns:a16="http://schemas.microsoft.com/office/drawing/2014/main" id="{7E4ADC7D-7A2A-4279-A989-0EBA0284AC2E}"/>
               </a:ext>
             </a:extLst>
           </p:cNvPr>
@@ -2141,7 +2126,7 @@
         </p:nvSpPr>
         <p:spPr>
           <a:xfrm xmlns:a="http://schemas.openxmlformats.org/drawingml/2006/main">
-            <a:off x="685800" y="6105525"/>
+            <a:off x="685800" y="6153150"/>
             <a:ext cx="10820400" cy="285750"/>
           </a:xfrm>
           <a:prstGeom xmlns:a="http://schemas.openxmlformats.org/drawingml/2006/main" prst="rect">
@@ -2159,25 +2144,25 @@
           <a:lstStyle xmlns:a="http://schemas.openxmlformats.org/drawingml/2006/main"/>
           <a:p xmlns:a="http://schemas.openxmlformats.org/drawingml/2006/main">
             <a:pPr algn="l">
-              <a:defRPr sz="1575" b="0">
-                <a:solidFill>
-                  <a:srgbClr val="536466"/>
-                </a:solidFill>
-                <a:latin typeface="Arial"/>
-                <a:ea typeface="Arial"/>
-                <a:cs typeface="Arial"/>
-              </a:defRPr>
-            </a:pPr>
-            <a:r>
-              <a:rPr sz="1575" b="0">
-                <a:solidFill>
-                  <a:srgbClr val="536466"/>
-                </a:solidFill>
-                <a:latin typeface="Arial"/>
-                <a:ea typeface="Arial"/>
-                <a:cs typeface="Arial"/>
-              </a:rPr>
-              <a:t>COSC336  •  Khalifa University  •  Group 4</a:t>
+              <a:defRPr sz="1650" b="0">
+                <a:solidFill>
+                  <a:srgbClr val="17343C"/>
+                </a:solidFill>
+                <a:latin typeface="Arial"/>
+                <a:ea typeface="Arial"/>
+                <a:cs typeface="Arial"/>
+              </a:defRPr>
+            </a:pPr>
+            <a:r>
+              <a:rPr sz="1650" b="0">
+                <a:solidFill>
+                  <a:srgbClr val="17343C"/>
+                </a:solidFill>
+                <a:latin typeface="Arial"/>
+                <a:ea typeface="Arial"/>
+                <a:cs typeface="Arial"/>
+              </a:rPr>
+              <a:t>Group 4   Sultan Almheiri, Zayed Alfadli and Ghith Alhinaai</a:t>
             </a:r>
           </a:p>
         </p:txBody>
@@ -2185,7 +2170,7 @@
     </p:spTree>
     <p:extLst>
       <p:ext uri="{BB962C8B-B14F-4D97-AF65-F5344CB8AC3E}">
-        <p14:creationId xmlns:p14="http://schemas.microsoft.com/office/powerpoint/2010/main" val="604531973"/>
+        <p14:creationId xmlns:p14="http://schemas.microsoft.com/office/powerpoint/2010/main" val="2129965451"/>
       </p:ext>
     </p:extLst>
   </p:cSld>
@@ -2213,10 +2198,10 @@
       </p:grpSpPr>
       <p:sp>
         <p:nvSpPr>
-          <p:cNvPr id="9" name="slide-title">
+          <p:cNvPr id="6" name="slide-title">
             <a:extLst xmlns:a="http://schemas.openxmlformats.org/drawingml/2006/main">
               <a:ext uri="{FF2B5EF4-FFF2-40B4-BE49-F238E27FC236}">
-                <a16:creationId xmlns:a16="http://schemas.microsoft.com/office/drawing/2014/main" id="{F1081673-05A5-4B83-952E-1B9EEA074E76}"/>
+                <a16:creationId xmlns:a16="http://schemas.microsoft.com/office/drawing/2014/main" id="{1226D71C-6F0F-4AF7-9B98-77E7E6F88696}"/>
               </a:ext>
             </a:extLst>
           </p:cNvPr>
@@ -2263,7 +2248,7 @@
                 <a:ea typeface="Arial"/>
                 <a:cs typeface="Arial"/>
               </a:rPr>
-              <a:t>The reuse problem</a:t>
+              <a:t>Who approves each step</a:t>
             </a:r>
           </a:p>
         </p:txBody>
@@ -2273,7 +2258,7 @@
           <p:cNvPr id="2" name="page-number">
             <a:extLst xmlns:a="http://schemas.openxmlformats.org/drawingml/2006/main">
               <a:ext uri="{FF2B5EF4-FFF2-40B4-BE49-F238E27FC236}">
-                <a16:creationId xmlns:a16="http://schemas.microsoft.com/office/drawing/2014/main" id="{34AC8E64-BD8D-4F7C-B073-33B0ED2F8579}"/>
+                <a16:creationId xmlns:a16="http://schemas.microsoft.com/office/drawing/2014/main" id="{DEF66004-1091-463C-B48F-22C1A68DED05}"/>
               </a:ext>
             </a:extLst>
           </p:cNvPr>
@@ -2327,10 +2312,10 @@
       </p:sp>
       <p:sp>
         <p:nvSpPr>
-          <p:cNvPr id="3" name="example-label">
+          <p:cNvPr id="3" name="mapping">
             <a:extLst xmlns:a="http://schemas.openxmlformats.org/drawingml/2006/main">
               <a:ext uri="{FF2B5EF4-FFF2-40B4-BE49-F238E27FC236}">
-                <a16:creationId xmlns:a16="http://schemas.microsoft.com/office/drawing/2014/main" id="{8F48E114-F702-48F5-A778-C76E67B15E35}"/>
+                <a16:creationId xmlns:a16="http://schemas.microsoft.com/office/drawing/2014/main" id="{A074DDA3-D178-44ED-A4F8-64D834862DE5}"/>
               </a:ext>
             </a:extLst>
           </p:cNvPr>
@@ -2342,7 +2327,7 @@
         <p:spPr>
           <a:xfrm xmlns:a="http://schemas.openxmlformats.org/drawingml/2006/main">
             <a:off x="685800" y="1438275"/>
-            <a:ext cx="10820400" cy="400050"/>
+            <a:ext cx="10820400" cy="647700"/>
           </a:xfrm>
           <a:prstGeom xmlns:a="http://schemas.openxmlformats.org/drawingml/2006/main" prst="rect">
             <a:avLst/>
@@ -2359,7 +2344,7 @@
           <a:lstStyle xmlns:a="http://schemas.openxmlformats.org/drawingml/2006/main"/>
           <a:p xmlns:a="http://schemas.openxmlformats.org/drawingml/2006/main">
             <a:pPr algn="l">
-              <a:defRPr sz="1875" b="0">
+              <a:defRPr sz="2100" b="0">
                 <a:solidFill>
                   <a:srgbClr val="536466"/>
                 </a:solidFill>
@@ -2369,7 +2354,7 @@
               </a:defRPr>
             </a:pPr>
             <a:r>
-              <a:rPr sz="1875" b="0">
+              <a:rPr sz="2100" b="0">
                 <a:solidFill>
                   <a:srgbClr val="536466"/>
                 </a:solidFill>
@@ -2377,17 +2362,268 @@
                 <a:ea typeface="Arial"/>
                 <a:cs typeface="Arial"/>
               </a:rPr>
-              <a:t>A hypothetical example</a:t>
-            </a:r>
-          </a:p>
-        </p:txBody>
-      </p:sp>
-      <p:sp>
-        <p:nvSpPr>
-          <p:cNvPr id="4" name="department-a">
+              <a:t>We mapped 9 system roles to permissions and approval owners</a:t>
+            </a:r>
+          </a:p>
+        </p:txBody>
+      </p:sp>
+      <p:graphicFrame>
+        <p:nvGraphicFramePr>
+          <p:cNvPr id="9" name=""/>
+          <p:cNvGraphicFramePr/>
+          <p:nvPr/>
+        </p:nvGraphicFramePr>
+        <p:xfrm>
+          <a:off xmlns:a="http://schemas.openxmlformats.org/drawingml/2006/main" x="685800" y="2190750"/>
+          <a:ext xmlns:a="http://schemas.openxmlformats.org/drawingml/2006/main" cx="10820400" cy="2895600"/>
+        </p:xfrm>
+        <a:graphic xmlns:a="http://schemas.openxmlformats.org/drawingml/2006/main">
+          <a:graphicData uri="http://schemas.openxmlformats.org/drawingml/2006/table">
+            <a:tbl>
+              <a:tblPr firstRow="0" firstCol="0" bandRow="0"/>
+              <a:tblGrid>
+                <a:gridCol w="4029075"/>
+                <a:gridCol w="6791325"/>
+              </a:tblGrid>
+              <a:tr h="533400">
+                <a:tc>
+                  <a:txBody>
+                    <a:bodyPr lIns="76200" tIns="57150" rIns="114300" bIns="57150">
+                      <a:noAutofit/>
+                    </a:bodyPr>
+                    <a:lstStyle/>
+                    <a:p>
+                      <a:r>
+                        <a:rPr sz="1875" b="1">
+                          <a:solidFill>
+                            <a:srgbClr val="26746D"/>
+                          </a:solidFill>
+                          <a:latin typeface="Arial"/>
+                          <a:ea typeface="Arial"/>
+                          <a:cs typeface="Arial"/>
+                        </a:rPr>
+                        <a:t>Role</a:t>
+                      </a:r>
+                    </a:p>
+                  </a:txBody>
+                  <a:tcPr marL="91440" marR="91440" marT="45720" marB="45720" anchor="ctr">
+                    <a:solidFill>
+                      <a:srgbClr val="FAFAF7"/>
+                    </a:solidFill>
+                  </a:tcPr>
+                </a:tc>
+                <a:tc>
+                  <a:txBody>
+                    <a:bodyPr lIns="76200" tIns="57150" rIns="114300" bIns="57150">
+                      <a:noAutofit/>
+                    </a:bodyPr>
+                    <a:lstStyle/>
+                    <a:p>
+                      <a:r>
+                        <a:rPr sz="1875" b="1">
+                          <a:solidFill>
+                            <a:srgbClr val="26746D"/>
+                          </a:solidFill>
+                          <a:latin typeface="Arial"/>
+                          <a:ea typeface="Arial"/>
+                          <a:cs typeface="Arial"/>
+                        </a:rPr>
+                        <a:t>Defined responsibility</a:t>
+                      </a:r>
+                    </a:p>
+                  </a:txBody>
+                  <a:tcPr marL="91440" marR="91440" marT="45720" marB="45720" anchor="ctr">
+                    <a:solidFill>
+                      <a:srgbClr val="FAFAF7"/>
+                    </a:solidFill>
+                  </a:tcPr>
+                </a:tc>
+              </a:tr>
+              <a:tr h="723900">
+                <a:tc>
+                  <a:txBody>
+                    <a:bodyPr lIns="76200" tIns="57150" rIns="114300" bIns="57150">
+                      <a:noAutofit/>
+                    </a:bodyPr>
+                    <a:lstStyle/>
+                    <a:p>
+                      <a:r>
+                        <a:rPr sz="2025" b="0">
+                          <a:solidFill>
+                            <a:srgbClr val="17343C"/>
+                          </a:solidFill>
+                          <a:latin typeface="Arial"/>
+                          <a:ea typeface="Arial"/>
+                          <a:cs typeface="Arial"/>
+                        </a:rPr>
+                        <a:t>Asset custodian</a:t>
+                      </a:r>
+                    </a:p>
+                  </a:txBody>
+                  <a:tcPr marL="91440" marR="91440" marT="45720" marB="45720" anchor="ctr">
+                    <a:solidFill>
+                      <a:srgbClr val="FAFAF7"/>
+                    </a:solidFill>
+                  </a:tcPr>
+                </a:tc>
+                <a:tc>
+                  <a:txBody>
+                    <a:bodyPr lIns="76200" tIns="57150" rIns="114300" bIns="57150">
+                      <a:noAutofit/>
+                    </a:bodyPr>
+                    <a:lstStyle/>
+                    <a:p>
+                      <a:r>
+                        <a:rPr sz="2025" b="0">
+                          <a:solidFill>
+                            <a:srgbClr val="17343C"/>
+                          </a:solidFill>
+                          <a:latin typeface="Arial"/>
+                          <a:ea typeface="Arial"/>
+                          <a:cs typeface="Arial"/>
+                        </a:rPr>
+                        <a:t>Maintain the record and confirm handover</a:t>
+                      </a:r>
+                    </a:p>
+                  </a:txBody>
+                  <a:tcPr marL="91440" marR="91440" marT="45720" marB="45720" anchor="ctr">
+                    <a:solidFill>
+                      <a:srgbClr val="FAFAF7"/>
+                    </a:solidFill>
+                  </a:tcPr>
+                </a:tc>
+              </a:tr>
+              <a:tr h="723900">
+                <a:tc>
+                  <a:txBody>
+                    <a:bodyPr lIns="76200" tIns="57150" rIns="114300" bIns="57150">
+                      <a:noAutofit/>
+                    </a:bodyPr>
+                    <a:lstStyle/>
+                    <a:p>
+                      <a:r>
+                        <a:rPr sz="2025" b="0">
+                          <a:solidFill>
+                            <a:srgbClr val="17343C"/>
+                          </a:solidFill>
+                          <a:latin typeface="Arial"/>
+                          <a:ea typeface="Arial"/>
+                          <a:cs typeface="Arial"/>
+                        </a:rPr>
+                        <a:t>Department representatives</a:t>
+                      </a:r>
+                    </a:p>
+                  </a:txBody>
+                  <a:tcPr marL="91440" marR="91440" marT="45720" marB="45720" anchor="ctr">
+                    <a:solidFill>
+                      <a:srgbClr val="FAFAF7"/>
+                    </a:solidFill>
+                  </a:tcPr>
+                </a:tc>
+                <a:tc>
+                  <a:txBody>
+                    <a:bodyPr lIns="76200" tIns="57150" rIns="114300" bIns="57150">
+                      <a:noAutofit/>
+                    </a:bodyPr>
+                    <a:lstStyle/>
+                    <a:p>
+                      <a:r>
+                        <a:rPr sz="2025" b="0">
+                          <a:solidFill>
+                            <a:srgbClr val="17343C"/>
+                          </a:solidFill>
+                          <a:latin typeface="Arial"/>
+                          <a:ea typeface="Arial"/>
+                          <a:cs typeface="Arial"/>
+                        </a:rPr>
+                        <a:t>Approve release and receipt</a:t>
+                      </a:r>
+                    </a:p>
+                  </a:txBody>
+                  <a:tcPr marL="91440" marR="91440" marT="45720" marB="45720" anchor="ctr">
+                    <a:solidFill>
+                      <a:srgbClr val="FAFAF7"/>
+                    </a:solidFill>
+                  </a:tcPr>
+                </a:tc>
+              </a:tr>
+              <a:tr h="914400">
+                <a:tc>
+                  <a:txBody>
+                    <a:bodyPr lIns="76200" tIns="57150" rIns="114300" bIns="57150">
+                      <a:noAutofit/>
+                    </a:bodyPr>
+                    <a:lstStyle/>
+                    <a:p>
+                      <a:r>
+                        <a:rPr sz="2025" b="0">
+                          <a:solidFill>
+                            <a:srgbClr val="17343C"/>
+                          </a:solidFill>
+                          <a:latin typeface="Arial"/>
+                          <a:ea typeface="Arial"/>
+                          <a:cs typeface="Arial"/>
+                        </a:rPr>
+                        <a:t>System administrator</a:t>
+                      </a:r>
+                    </a:p>
+                  </a:txBody>
+                  <a:tcPr marL="91440" marR="91440" marT="45720" marB="45720" anchor="ctr">
+                    <a:solidFill>
+                      <a:srgbClr val="FAFAF7"/>
+                    </a:solidFill>
+                  </a:tcPr>
+                </a:tc>
+                <a:tc>
+                  <a:txBody>
+                    <a:bodyPr lIns="76200" tIns="57150" rIns="114300" bIns="57150">
+                      <a:noAutofit/>
+                    </a:bodyPr>
+                    <a:lstStyle/>
+                    <a:p>
+                      <a:r>
+                        <a:rPr sz="2025" b="0">
+                          <a:solidFill>
+                            <a:srgbClr val="17343C"/>
+                          </a:solidFill>
+                          <a:latin typeface="Arial"/>
+                          <a:ea typeface="Arial"/>
+                          <a:cs typeface="Arial"/>
+                        </a:rPr>
+                        <a:t>Manage technical access, without automatic</a:t>
+                      </a:r>
+                    </a:p>
+                    <a:p>
+                      <a:r>
+                        <a:rPr sz="2025" b="0">
+                          <a:solidFill>
+                            <a:srgbClr val="17343C"/>
+                          </a:solidFill>
+                          <a:latin typeface="Arial"/>
+                          <a:ea typeface="Arial"/>
+                          <a:cs typeface="Arial"/>
+                        </a:rPr>
+                        <a:t>business approval rights</a:t>
+                      </a:r>
+                    </a:p>
+                  </a:txBody>
+                  <a:tcPr marL="91440" marR="91440" marT="45720" marB="45720" anchor="ctr">
+                    <a:solidFill>
+                      <a:srgbClr val="FAFAF7"/>
+                    </a:solidFill>
+                  </a:tcPr>
+                </a:tc>
+              </a:tr>
+            </a:tbl>
+          </a:graphicData>
+        </a:graphic>
+      </p:graphicFrame>
+      <p:sp>
+        <p:nvSpPr>
+          <p:cNvPr id="5" name="open-rules">
             <a:extLst xmlns:a="http://schemas.openxmlformats.org/drawingml/2006/main">
               <a:ext uri="{FF2B5EF4-FFF2-40B4-BE49-F238E27FC236}">
-                <a16:creationId xmlns:a16="http://schemas.microsoft.com/office/drawing/2014/main" id="{DDFF3BAD-D05B-445E-9899-7EB2005AF532}"/>
+                <a16:creationId xmlns:a16="http://schemas.microsoft.com/office/drawing/2014/main" id="{6BC35503-95EF-4224-9BC9-94DA7DAA826B}"/>
               </a:ext>
             </a:extLst>
           </p:cNvPr>
@@ -2398,8 +2634,8 @@
         </p:nvSpPr>
         <p:spPr>
           <a:xfrm xmlns:a="http://schemas.openxmlformats.org/drawingml/2006/main">
-            <a:off x="685800" y="2305050"/>
-            <a:ext cx="4905375" cy="400050"/>
+            <a:off x="685800" y="5448300"/>
+            <a:ext cx="10820400" cy="742950"/>
           </a:xfrm>
           <a:prstGeom xmlns:a="http://schemas.openxmlformats.org/drawingml/2006/main" prst="rect">
             <a:avLst/>
@@ -2416,299 +2652,48 @@
           <a:lstStyle xmlns:a="http://schemas.openxmlformats.org/drawingml/2006/main"/>
           <a:p xmlns:a="http://schemas.openxmlformats.org/drawingml/2006/main">
             <a:pPr algn="l">
-              <a:defRPr sz="2100" b="0">
-                <a:solidFill>
-                  <a:srgbClr val="26746D"/>
-                </a:solidFill>
-                <a:latin typeface="Arial"/>
-                <a:ea typeface="Arial"/>
-                <a:cs typeface="Arial"/>
-              </a:defRPr>
-            </a:pPr>
-            <a:r>
-              <a:rPr sz="2100" b="0">
-                <a:solidFill>
-                  <a:srgbClr val="26746D"/>
-                </a:solidFill>
-                <a:latin typeface="Arial"/>
-                <a:ea typeface="Arial"/>
-                <a:cs typeface="Arial"/>
-              </a:rPr>
-              <a:t>Department A</a:t>
-            </a:r>
-          </a:p>
-        </p:txBody>
-      </p:sp>
-      <p:sp>
-        <p:nvSpPr>
-          <p:cNvPr id="5" name="available">
-            <a:extLst xmlns:a="http://schemas.openxmlformats.org/drawingml/2006/main">
-              <a:ext uri="{FF2B5EF4-FFF2-40B4-BE49-F238E27FC236}">
-                <a16:creationId xmlns:a16="http://schemas.microsoft.com/office/drawing/2014/main" id="{5E7B61DF-E044-4BA9-98D9-2A232166BEDA}"/>
-              </a:ext>
-            </a:extLst>
-          </p:cNvPr>
-          <p:cNvSpPr>
-            <a:spLocks xmlns:a="http://schemas.openxmlformats.org/drawingml/2006/main" noGrp="1"/>
-          </p:cNvSpPr>
-          <p:nvPr/>
-        </p:nvSpPr>
-        <p:spPr>
-          <a:xfrm xmlns:a="http://schemas.openxmlformats.org/drawingml/2006/main">
-            <a:off x="685800" y="2895600"/>
-            <a:ext cx="5095875" cy="895350"/>
-          </a:xfrm>
-          <a:prstGeom xmlns:a="http://schemas.openxmlformats.org/drawingml/2006/main" prst="rect">
-            <a:avLst/>
-          </a:prstGeom>
-          <a:noFill xmlns:a="http://schemas.openxmlformats.org/drawingml/2006/main"/>
-          <a:ln xmlns:a="http://schemas.openxmlformats.org/drawingml/2006/main" w="0">
-            <a:noFill/>
-          </a:ln>
-        </p:spPr>
-        <p:txBody>
-          <a:bodyPr xmlns:a="http://schemas.openxmlformats.org/drawingml/2006/main" wrap="square" lIns="0" tIns="0" rIns="0" bIns="0" anchor="t">
-            <a:noAutofit/>
-          </a:bodyPr>
-          <a:lstStyle xmlns:a="http://schemas.openxmlformats.org/drawingml/2006/main"/>
-          <a:p xmlns:a="http://schemas.openxmlformats.org/drawingml/2006/main">
-            <a:pPr algn="l">
-              <a:defRPr sz="3600" b="1">
-                <a:solidFill>
-                  <a:srgbClr val="17343C"/>
-                </a:solidFill>
-                <a:latin typeface="Arial"/>
-                <a:ea typeface="Arial"/>
-                <a:cs typeface="Arial"/>
-              </a:defRPr>
-            </a:pPr>
-            <a:r>
-              <a:rPr sz="3600" b="1">
-                <a:solidFill>
-                  <a:srgbClr val="17343C"/>
-                </a:solidFill>
-                <a:latin typeface="Arial"/>
-                <a:ea typeface="Arial"/>
-                <a:cs typeface="Arial"/>
-              </a:rPr>
-              <a:t>5 unused chairs</a:t>
-            </a:r>
-          </a:p>
-        </p:txBody>
-      </p:sp>
-      <p:sp>
-        <p:nvSpPr>
-          <p:cNvPr id="6" name="department-b">
-            <a:extLst xmlns:a="http://schemas.openxmlformats.org/drawingml/2006/main">
-              <a:ext uri="{FF2B5EF4-FFF2-40B4-BE49-F238E27FC236}">
-                <a16:creationId xmlns:a16="http://schemas.microsoft.com/office/drawing/2014/main" id="{0D64B1DC-C46F-4527-84A9-31ACB2F6D91B}"/>
-              </a:ext>
-            </a:extLst>
-          </p:cNvPr>
-          <p:cNvSpPr>
-            <a:spLocks xmlns:a="http://schemas.openxmlformats.org/drawingml/2006/main" noGrp="1"/>
-          </p:cNvSpPr>
-          <p:nvPr/>
-        </p:nvSpPr>
-        <p:spPr>
-          <a:xfrm xmlns:a="http://schemas.openxmlformats.org/drawingml/2006/main">
-            <a:off x="6572250" y="2305050"/>
-            <a:ext cx="4933950" cy="400050"/>
-          </a:xfrm>
-          <a:prstGeom xmlns:a="http://schemas.openxmlformats.org/drawingml/2006/main" prst="rect">
-            <a:avLst/>
-          </a:prstGeom>
-          <a:noFill xmlns:a="http://schemas.openxmlformats.org/drawingml/2006/main"/>
-          <a:ln xmlns:a="http://schemas.openxmlformats.org/drawingml/2006/main" w="0">
-            <a:noFill/>
-          </a:ln>
-        </p:spPr>
-        <p:txBody>
-          <a:bodyPr xmlns:a="http://schemas.openxmlformats.org/drawingml/2006/main" wrap="square" lIns="0" tIns="0" rIns="0" bIns="0" anchor="t">
-            <a:noAutofit/>
-          </a:bodyPr>
-          <a:lstStyle xmlns:a="http://schemas.openxmlformats.org/drawingml/2006/main"/>
-          <a:p xmlns:a="http://schemas.openxmlformats.org/drawingml/2006/main">
-            <a:pPr algn="l">
-              <a:defRPr sz="2100" b="0">
-                <a:solidFill>
-                  <a:srgbClr val="26746D"/>
-                </a:solidFill>
-                <a:latin typeface="Arial"/>
-                <a:ea typeface="Arial"/>
-                <a:cs typeface="Arial"/>
-              </a:defRPr>
-            </a:pPr>
-            <a:r>
-              <a:rPr sz="2100" b="0">
-                <a:solidFill>
-                  <a:srgbClr val="26746D"/>
-                </a:solidFill>
-                <a:latin typeface="Arial"/>
-                <a:ea typeface="Arial"/>
-                <a:cs typeface="Arial"/>
-              </a:rPr>
-              <a:t>Department B</a:t>
-            </a:r>
-          </a:p>
-        </p:txBody>
-      </p:sp>
-      <p:sp>
-        <p:nvSpPr>
-          <p:cNvPr id="7" name="needed">
-            <a:extLst xmlns:a="http://schemas.openxmlformats.org/drawingml/2006/main">
-              <a:ext uri="{FF2B5EF4-FFF2-40B4-BE49-F238E27FC236}">
-                <a16:creationId xmlns:a16="http://schemas.microsoft.com/office/drawing/2014/main" id="{6597BB4C-00B9-481A-9B81-06396182BD1D}"/>
-              </a:ext>
-            </a:extLst>
-          </p:cNvPr>
-          <p:cNvSpPr>
-            <a:spLocks xmlns:a="http://schemas.openxmlformats.org/drawingml/2006/main" noGrp="1"/>
-          </p:cNvSpPr>
-          <p:nvPr/>
-        </p:nvSpPr>
-        <p:spPr>
-          <a:xfrm xmlns:a="http://schemas.openxmlformats.org/drawingml/2006/main">
-            <a:off x="6572250" y="2895600"/>
-            <a:ext cx="4933950" cy="1276350"/>
-          </a:xfrm>
-          <a:prstGeom xmlns:a="http://schemas.openxmlformats.org/drawingml/2006/main" prst="rect">
-            <a:avLst/>
-          </a:prstGeom>
-          <a:noFill xmlns:a="http://schemas.openxmlformats.org/drawingml/2006/main"/>
-          <a:ln xmlns:a="http://schemas.openxmlformats.org/drawingml/2006/main" w="0">
-            <a:noFill/>
-          </a:ln>
-        </p:spPr>
-        <p:txBody>
-          <a:bodyPr xmlns:a="http://schemas.openxmlformats.org/drawingml/2006/main" wrap="square" lIns="0" tIns="0" rIns="0" bIns="0" anchor="t">
-            <a:noAutofit/>
-          </a:bodyPr>
-          <a:lstStyle xmlns:a="http://schemas.openxmlformats.org/drawingml/2006/main"/>
-          <a:p xmlns:a="http://schemas.openxmlformats.org/drawingml/2006/main">
-            <a:pPr algn="l">
-              <a:defRPr sz="3450" b="1">
-                <a:solidFill>
-                  <a:srgbClr val="17343C"/>
-                </a:solidFill>
-                <a:latin typeface="Arial"/>
-                <a:ea typeface="Arial"/>
-                <a:cs typeface="Arial"/>
-              </a:defRPr>
-            </a:pPr>
-            <a:r>
-              <a:rPr sz="3450" b="1">
-                <a:solidFill>
-                  <a:srgbClr val="17343C"/>
-                </a:solidFill>
-                <a:latin typeface="Arial"/>
-                <a:ea typeface="Arial"/>
-                <a:cs typeface="Arial"/>
-              </a:rPr>
-              <a:t>Seating needed</a:t>
-            </a:r>
-          </a:p>
-          <a:p xmlns:a="http://schemas.openxmlformats.org/drawingml/2006/main">
-            <a:pPr algn="l">
-              <a:defRPr sz="3450" b="1">
-                <a:solidFill>
-                  <a:srgbClr val="17343C"/>
-                </a:solidFill>
-                <a:latin typeface="Arial"/>
-                <a:ea typeface="Arial"/>
-                <a:cs typeface="Arial"/>
-              </a:defRPr>
-            </a:pPr>
-            <a:r>
-              <a:rPr sz="3450" b="1">
-                <a:solidFill>
-                  <a:srgbClr val="17343C"/>
-                </a:solidFill>
-                <a:latin typeface="Arial"/>
-                <a:ea typeface="Arial"/>
-                <a:cs typeface="Arial"/>
-              </a:rPr>
-              <a:t>for 5 people</a:t>
-            </a:r>
-          </a:p>
-        </p:txBody>
-      </p:sp>
-      <p:sp>
-        <p:nvSpPr>
-          <p:cNvPr id="8" name="gap">
-            <a:extLst xmlns:a="http://schemas.openxmlformats.org/drawingml/2006/main">
-              <a:ext uri="{FF2B5EF4-FFF2-40B4-BE49-F238E27FC236}">
-                <a16:creationId xmlns:a16="http://schemas.microsoft.com/office/drawing/2014/main" id="{7BD6991D-0BA5-4FAB-A368-E91FF0D7ED82}"/>
-              </a:ext>
-            </a:extLst>
-          </p:cNvPr>
-          <p:cNvSpPr>
-            <a:spLocks xmlns:a="http://schemas.openxmlformats.org/drawingml/2006/main" noGrp="1"/>
-          </p:cNvSpPr>
-          <p:nvPr/>
-        </p:nvSpPr>
-        <p:spPr>
-          <a:xfrm xmlns:a="http://schemas.openxmlformats.org/drawingml/2006/main">
-            <a:off x="685800" y="5105400"/>
-            <a:ext cx="10820400" cy="1019175"/>
-          </a:xfrm>
-          <a:prstGeom xmlns:a="http://schemas.openxmlformats.org/drawingml/2006/main" prst="rect">
-            <a:avLst/>
-          </a:prstGeom>
-          <a:noFill xmlns:a="http://schemas.openxmlformats.org/drawingml/2006/main"/>
-          <a:ln xmlns:a="http://schemas.openxmlformats.org/drawingml/2006/main" w="0">
-            <a:noFill/>
-          </a:ln>
-        </p:spPr>
-        <p:txBody>
-          <a:bodyPr xmlns:a="http://schemas.openxmlformats.org/drawingml/2006/main" wrap="square" lIns="0" tIns="0" rIns="0" bIns="0" anchor="t">
-            <a:noAutofit/>
-          </a:bodyPr>
-          <a:lstStyle xmlns:a="http://schemas.openxmlformats.org/drawingml/2006/main"/>
-          <a:p xmlns:a="http://schemas.openxmlformats.org/drawingml/2006/main">
-            <a:pPr algn="l">
-              <a:defRPr sz="2400" b="0">
-                <a:solidFill>
-                  <a:srgbClr val="17343C"/>
-                </a:solidFill>
-                <a:latin typeface="Arial"/>
-                <a:ea typeface="Arial"/>
-                <a:cs typeface="Arial"/>
-              </a:defRPr>
-            </a:pPr>
-            <a:r>
-              <a:rPr sz="2400" b="0">
-                <a:solidFill>
-                  <a:srgbClr val="17343C"/>
-                </a:solidFill>
-                <a:latin typeface="Arial"/>
-                <a:ea typeface="Arial"/>
-                <a:cs typeface="Arial"/>
-              </a:rPr>
-              <a:t>Reuse needs a shared view of available items</a:t>
-            </a:r>
-          </a:p>
-          <a:p xmlns:a="http://schemas.openxmlformats.org/drawingml/2006/main">
-            <a:pPr algn="l">
-              <a:defRPr sz="2400" b="0">
-                <a:solidFill>
-                  <a:srgbClr val="17343C"/>
-                </a:solidFill>
-                <a:latin typeface="Arial"/>
-                <a:ea typeface="Arial"/>
-                <a:cs typeface="Arial"/>
-              </a:defRPr>
-            </a:pPr>
-            <a:r>
-              <a:rPr sz="2400" b="0">
-                <a:solidFill>
-                  <a:srgbClr val="17343C"/>
-                </a:solidFill>
-                <a:latin typeface="Arial"/>
-                <a:ea typeface="Arial"/>
-                <a:cs typeface="Arial"/>
-              </a:rPr>
-              <a:t>and a clear way to approve transfers.</a:t>
+              <a:defRPr sz="2025" b="0">
+                <a:solidFill>
+                  <a:srgbClr val="17343C"/>
+                </a:solidFill>
+                <a:latin typeface="Arial"/>
+                <a:ea typeface="Arial"/>
+                <a:cs typeface="Arial"/>
+              </a:defRPr>
+            </a:pPr>
+            <a:r>
+              <a:rPr sz="2025" b="0">
+                <a:solidFill>
+                  <a:srgbClr val="17343C"/>
+                </a:solidFill>
+                <a:latin typeface="Arial"/>
+                <a:ea typeface="Arial"/>
+                <a:cs typeface="Arial"/>
+              </a:rPr>
+              <a:t>Client confirmation needed: financial thresholds and the final</a:t>
+            </a:r>
+          </a:p>
+          <a:p xmlns:a="http://schemas.openxmlformats.org/drawingml/2006/main">
+            <a:pPr algn="l">
+              <a:defRPr sz="2025" b="0">
+                <a:solidFill>
+                  <a:srgbClr val="17343C"/>
+                </a:solidFill>
+                <a:latin typeface="Arial"/>
+                <a:ea typeface="Arial"/>
+                <a:cs typeface="Arial"/>
+              </a:defRPr>
+            </a:pPr>
+            <a:r>
+              <a:rPr sz="2025" b="0">
+                <a:solidFill>
+                  <a:srgbClr val="17343C"/>
+                </a:solidFill>
+                <a:latin typeface="Arial"/>
+                <a:ea typeface="Arial"/>
+                <a:cs typeface="Arial"/>
+              </a:rPr>
+              <a:t>approval sequence for donation, recycling and disposal</a:t>
             </a:r>
           </a:p>
         </p:txBody>
@@ -2716,7 +2701,7 @@
     </p:spTree>
     <p:extLst>
       <p:ext uri="{BB962C8B-B14F-4D97-AF65-F5344CB8AC3E}">
-        <p14:creationId xmlns:p14="http://schemas.microsoft.com/office/powerpoint/2010/main" val="1844202102"/>
+        <p14:creationId xmlns:p14="http://schemas.microsoft.com/office/powerpoint/2010/main" val="27573420"/>
       </p:ext>
     </p:extLst>
   </p:cSld>
@@ -2744,10 +2729,10 @@
       </p:grpSpPr>
       <p:sp>
         <p:nvSpPr>
-          <p:cNvPr id="12" name="slide-title">
+          <p:cNvPr id="11" name="slide-title">
             <a:extLst xmlns:a="http://schemas.openxmlformats.org/drawingml/2006/main">
               <a:ext uri="{FF2B5EF4-FFF2-40B4-BE49-F238E27FC236}">
-                <a16:creationId xmlns:a16="http://schemas.microsoft.com/office/drawing/2014/main" id="{827CB3E9-F46F-437C-A40D-F6CC721EF31A}"/>
+                <a16:creationId xmlns:a16="http://schemas.microsoft.com/office/drawing/2014/main" id="{373D7018-5DDB-4645-BE3C-8CDB9BF4667B}"/>
               </a:ext>
             </a:extLst>
           </p:cNvPr>
@@ -2794,7 +2779,7 @@
                 <a:ea typeface="Arial"/>
                 <a:cs typeface="Arial"/>
               </a:rPr>
-              <a:t>The proposed service</a:t>
+              <a:t>What we established in Phase 1</a:t>
             </a:r>
           </a:p>
         </p:txBody>
@@ -2804,7 +2789,7 @@
           <p:cNvPr id="2" name="page-number">
             <a:extLst xmlns:a="http://schemas.openxmlformats.org/drawingml/2006/main">
               <a:ext uri="{FF2B5EF4-FFF2-40B4-BE49-F238E27FC236}">
-                <a16:creationId xmlns:a16="http://schemas.microsoft.com/office/drawing/2014/main" id="{406F2139-1697-4204-8E9E-7756612B9437}"/>
+                <a16:creationId xmlns:a16="http://schemas.microsoft.com/office/drawing/2014/main" id="{478AB4AA-50DE-4620-AE62-F2FCA46A3736}"/>
               </a:ext>
             </a:extLst>
           </p:cNvPr>
@@ -2858,10 +2843,10 @@
       </p:sp>
       <p:sp>
         <p:nvSpPr>
-          <p:cNvPr id="3" name="step-0">
+          <p:cNvPr id="3" name="count">
             <a:extLst xmlns:a="http://schemas.openxmlformats.org/drawingml/2006/main">
               <a:ext uri="{FF2B5EF4-FFF2-40B4-BE49-F238E27FC236}">
-                <a16:creationId xmlns:a16="http://schemas.microsoft.com/office/drawing/2014/main" id="{42E5D4B7-28BE-49E9-8203-32A373980103}"/>
+                <a16:creationId xmlns:a16="http://schemas.microsoft.com/office/drawing/2014/main" id="{C01EEF6C-1906-41A9-9D54-16D24FD0A3CF}"/>
               </a:ext>
             </a:extLst>
           </p:cNvPr>
@@ -2872,8 +2857,8 @@
         </p:nvSpPr>
         <p:spPr>
           <a:xfrm xmlns:a="http://schemas.openxmlformats.org/drawingml/2006/main">
-            <a:off x="685800" y="1781175"/>
-            <a:ext cx="3286125" cy="533400"/>
+            <a:off x="685800" y="2057400"/>
+            <a:ext cx="3190875" cy="1257300"/>
           </a:xfrm>
           <a:prstGeom xmlns:a="http://schemas.openxmlformats.org/drawingml/2006/main" prst="rect">
             <a:avLst/>
@@ -2890,7 +2875,7 @@
           <a:lstStyle xmlns:a="http://schemas.openxmlformats.org/drawingml/2006/main"/>
           <a:p xmlns:a="http://schemas.openxmlformats.org/drawingml/2006/main">
             <a:pPr algn="l">
-              <a:defRPr sz="2175" b="1">
+              <a:defRPr sz="7500" b="1">
                 <a:solidFill>
                   <a:srgbClr val="26746D"/>
                 </a:solidFill>
@@ -2900,7 +2885,7 @@
               </a:defRPr>
             </a:pPr>
             <a:r>
-              <a:rPr sz="2175" b="1">
+              <a:rPr sz="7500" b="1">
                 <a:solidFill>
                   <a:srgbClr val="26746D"/>
                 </a:solidFill>
@@ -2908,17 +2893,17 @@
                 <a:ea typeface="Arial"/>
                 <a:cs typeface="Arial"/>
               </a:rPr>
-              <a:t>Publish</a:t>
-            </a:r>
-          </a:p>
-        </p:txBody>
-      </p:sp>
-      <p:sp>
-        <p:nvSpPr>
-          <p:cNvPr id="4" name="detail-0">
+              <a:t>52</a:t>
+            </a:r>
+          </a:p>
+        </p:txBody>
+      </p:sp>
+      <p:sp>
+        <p:nvSpPr>
+          <p:cNvPr id="4" name="count-label">
             <a:extLst xmlns:a="http://schemas.openxmlformats.org/drawingml/2006/main">
               <a:ext uri="{FF2B5EF4-FFF2-40B4-BE49-F238E27FC236}">
-                <a16:creationId xmlns:a16="http://schemas.microsoft.com/office/drawing/2014/main" id="{5DD6EF61-C355-4031-AF6F-2F160F762A8B}"/>
+                <a16:creationId xmlns:a16="http://schemas.microsoft.com/office/drawing/2014/main" id="{AE4260E5-3948-4AD6-9D47-64B6C5482A1E}"/>
               </a:ext>
             </a:extLst>
           </p:cNvPr>
@@ -2929,8 +2914,8 @@
         </p:nvSpPr>
         <p:spPr>
           <a:xfrm xmlns:a="http://schemas.openxmlformats.org/drawingml/2006/main">
-            <a:off x="4276725" y="1781175"/>
-            <a:ext cx="7229475" cy="666750"/>
+            <a:off x="685800" y="3400425"/>
+            <a:ext cx="3962400" cy="476250"/>
           </a:xfrm>
           <a:prstGeom xmlns:a="http://schemas.openxmlformats.org/drawingml/2006/main" prst="rect">
             <a:avLst/>
@@ -2947,35 +2932,35 @@
           <a:lstStyle xmlns:a="http://schemas.openxmlformats.org/drawingml/2006/main"/>
           <a:p xmlns:a="http://schemas.openxmlformats.org/drawingml/2006/main">
             <a:pPr algn="l">
-              <a:defRPr sz="2175" b="0">
-                <a:solidFill>
-                  <a:srgbClr val="17343C"/>
-                </a:solidFill>
-                <a:latin typeface="Arial"/>
-                <a:ea typeface="Arial"/>
-                <a:cs typeface="Arial"/>
-              </a:defRPr>
-            </a:pPr>
-            <a:r>
-              <a:rPr sz="2175" b="0">
-                <a:solidFill>
-                  <a:srgbClr val="17343C"/>
-                </a:solidFill>
-                <a:latin typeface="Arial"/>
-                <a:ea typeface="Arial"/>
-                <a:cs typeface="Arial"/>
-              </a:rPr>
-              <a:t>Record available assets and their condition</a:t>
-            </a:r>
-          </a:p>
-        </p:txBody>
-      </p:sp>
-      <p:sp>
-        <p:nvSpPr>
-          <p:cNvPr id="5" name="step-1">
+              <a:defRPr sz="2250" b="1">
+                <a:solidFill>
+                  <a:srgbClr val="17343C"/>
+                </a:solidFill>
+                <a:latin typeface="Arial"/>
+                <a:ea typeface="Arial"/>
+                <a:cs typeface="Arial"/>
+              </a:defRPr>
+            </a:pPr>
+            <a:r>
+              <a:rPr sz="2250" b="1">
+                <a:solidFill>
+                  <a:srgbClr val="17343C"/>
+                </a:solidFill>
+                <a:latin typeface="Arial"/>
+                <a:ea typeface="Arial"/>
+                <a:cs typeface="Arial"/>
+              </a:rPr>
+              <a:t>initial requirements</a:t>
+            </a:r>
+          </a:p>
+        </p:txBody>
+      </p:sp>
+      <p:sp>
+        <p:nvSpPr>
+          <p:cNvPr id="5" name="priorities">
             <a:extLst xmlns:a="http://schemas.openxmlformats.org/drawingml/2006/main">
               <a:ext uri="{FF2B5EF4-FFF2-40B4-BE49-F238E27FC236}">
-                <a16:creationId xmlns:a16="http://schemas.microsoft.com/office/drawing/2014/main" id="{258119E0-6ACF-4788-9438-DA790AD70B2C}"/>
+                <a16:creationId xmlns:a16="http://schemas.microsoft.com/office/drawing/2014/main" id="{03759676-1029-4382-B7A5-0793FDFA6D8D}"/>
               </a:ext>
             </a:extLst>
           </p:cNvPr>
@@ -2986,8 +2971,8 @@
         </p:nvSpPr>
         <p:spPr>
           <a:xfrm xmlns:a="http://schemas.openxmlformats.org/drawingml/2006/main">
-            <a:off x="685800" y="2609850"/>
-            <a:ext cx="3286125" cy="533400"/>
+            <a:off x="685800" y="4057650"/>
+            <a:ext cx="4095750" cy="495300"/>
           </a:xfrm>
           <a:prstGeom xmlns:a="http://schemas.openxmlformats.org/drawingml/2006/main" prst="rect">
             <a:avLst/>
@@ -3004,35 +2989,35 @@
           <a:lstStyle xmlns:a="http://schemas.openxmlformats.org/drawingml/2006/main"/>
           <a:p xmlns:a="http://schemas.openxmlformats.org/drawingml/2006/main">
             <a:pPr algn="l">
-              <a:defRPr sz="2175" b="1">
-                <a:solidFill>
-                  <a:srgbClr val="26746D"/>
-                </a:solidFill>
-                <a:latin typeface="Arial"/>
-                <a:ea typeface="Arial"/>
-                <a:cs typeface="Arial"/>
-              </a:defRPr>
-            </a:pPr>
-            <a:r>
-              <a:rPr sz="2175" b="1">
-                <a:solidFill>
-                  <a:srgbClr val="26746D"/>
-                </a:solidFill>
-                <a:latin typeface="Arial"/>
-                <a:ea typeface="Arial"/>
-                <a:cs typeface="Arial"/>
-              </a:rPr>
-              <a:t>Find and request</a:t>
-            </a:r>
-          </a:p>
-        </p:txBody>
-      </p:sp>
-      <p:sp>
-        <p:nvSpPr>
-          <p:cNvPr id="6" name="detail-1">
+              <a:defRPr sz="2100" b="0">
+                <a:solidFill>
+                  <a:srgbClr val="17343C"/>
+                </a:solidFill>
+                <a:latin typeface="Arial"/>
+                <a:ea typeface="Arial"/>
+                <a:cs typeface="Arial"/>
+              </a:defRPr>
+            </a:pPr>
+            <a:r>
+              <a:rPr sz="2100" b="0">
+                <a:solidFill>
+                  <a:srgbClr val="17343C"/>
+                </a:solidFill>
+                <a:latin typeface="Arial"/>
+                <a:ea typeface="Arial"/>
+                <a:cs typeface="Arial"/>
+              </a:rPr>
+              <a:t>47 Must and 5 Should</a:t>
+            </a:r>
+          </a:p>
+        </p:txBody>
+      </p:sp>
+      <p:sp>
+        <p:nvSpPr>
+          <p:cNvPr id="6" name="completed-label">
             <a:extLst xmlns:a="http://schemas.openxmlformats.org/drawingml/2006/main">
               <a:ext uri="{FF2B5EF4-FFF2-40B4-BE49-F238E27FC236}">
-                <a16:creationId xmlns:a16="http://schemas.microsoft.com/office/drawing/2014/main" id="{7D14C4AB-33E9-45EC-BBF6-599E24EC223F}"/>
+                <a16:creationId xmlns:a16="http://schemas.microsoft.com/office/drawing/2014/main" id="{839F8C82-DC4D-47BD-B262-F79D06CF877E}"/>
               </a:ext>
             </a:extLst>
           </p:cNvPr>
@@ -3043,8 +3028,8 @@
         </p:nvSpPr>
         <p:spPr>
           <a:xfrm xmlns:a="http://schemas.openxmlformats.org/drawingml/2006/main">
-            <a:off x="4276725" y="2609850"/>
-            <a:ext cx="7229475" cy="666750"/>
+            <a:off x="5553075" y="1819275"/>
+            <a:ext cx="5953125" cy="495300"/>
           </a:xfrm>
           <a:prstGeom xmlns:a="http://schemas.openxmlformats.org/drawingml/2006/main" prst="rect">
             <a:avLst/>
@@ -3061,35 +3046,35 @@
           <a:lstStyle xmlns:a="http://schemas.openxmlformats.org/drawingml/2006/main"/>
           <a:p xmlns:a="http://schemas.openxmlformats.org/drawingml/2006/main">
             <a:pPr algn="l">
-              <a:defRPr sz="2175" b="0">
-                <a:solidFill>
-                  <a:srgbClr val="17343C"/>
-                </a:solidFill>
-                <a:latin typeface="Arial"/>
-                <a:ea typeface="Arial"/>
-                <a:cs typeface="Arial"/>
-              </a:defRPr>
-            </a:pPr>
-            <a:r>
-              <a:rPr sz="2175" b="0">
-                <a:solidFill>
-                  <a:srgbClr val="17343C"/>
-                </a:solidFill>
-                <a:latin typeface="Arial"/>
-                <a:ea typeface="Arial"/>
-                <a:cs typeface="Arial"/>
-              </a:rPr>
-              <a:t>Search for an item and submit a request</a:t>
-            </a:r>
-          </a:p>
-        </p:txBody>
-      </p:sp>
-      <p:sp>
-        <p:nvSpPr>
-          <p:cNvPr id="7" name="step-2">
+              <a:defRPr sz="2325" b="1">
+                <a:solidFill>
+                  <a:srgbClr val="26746D"/>
+                </a:solidFill>
+                <a:latin typeface="Arial"/>
+                <a:ea typeface="Arial"/>
+                <a:cs typeface="Arial"/>
+              </a:defRPr>
+            </a:pPr>
+            <a:r>
+              <a:rPr sz="2325" b="1">
+                <a:solidFill>
+                  <a:srgbClr val="26746D"/>
+                </a:solidFill>
+                <a:latin typeface="Arial"/>
+                <a:ea typeface="Arial"/>
+                <a:cs typeface="Arial"/>
+              </a:rPr>
+              <a:t>Completed</a:t>
+            </a:r>
+          </a:p>
+        </p:txBody>
+      </p:sp>
+      <p:sp>
+        <p:nvSpPr>
+          <p:cNvPr id="7" name="completed">
             <a:extLst xmlns:a="http://schemas.openxmlformats.org/drawingml/2006/main">
               <a:ext uri="{FF2B5EF4-FFF2-40B4-BE49-F238E27FC236}">
-                <a16:creationId xmlns:a16="http://schemas.microsoft.com/office/drawing/2014/main" id="{2C1FECCE-B5F1-4157-B1FC-7A513D4C1CC1}"/>
+                <a16:creationId xmlns:a16="http://schemas.microsoft.com/office/drawing/2014/main" id="{39F69EF6-C6CF-46F7-86EF-B43860CE212B}"/>
               </a:ext>
             </a:extLst>
           </p:cNvPr>
@@ -3100,8 +3085,8 @@
         </p:nvSpPr>
         <p:spPr>
           <a:xfrm xmlns:a="http://schemas.openxmlformats.org/drawingml/2006/main">
-            <a:off x="685800" y="3438525"/>
-            <a:ext cx="3286125" cy="533400"/>
+            <a:off x="5553075" y="2466975"/>
+            <a:ext cx="5953125" cy="1428750"/>
           </a:xfrm>
           <a:prstGeom xmlns:a="http://schemas.openxmlformats.org/drawingml/2006/main" prst="rect">
             <a:avLst/>
@@ -3118,35 +3103,81 @@
           <a:lstStyle xmlns:a="http://schemas.openxmlformats.org/drawingml/2006/main"/>
           <a:p xmlns:a="http://schemas.openxmlformats.org/drawingml/2006/main">
             <a:pPr algn="l">
-              <a:defRPr sz="2175" b="1">
-                <a:solidFill>
-                  <a:srgbClr val="26746D"/>
-                </a:solidFill>
-                <a:latin typeface="Arial"/>
-                <a:ea typeface="Arial"/>
-                <a:cs typeface="Arial"/>
-              </a:defRPr>
-            </a:pPr>
-            <a:r>
-              <a:rPr sz="2175" b="1">
-                <a:solidFill>
-                  <a:srgbClr val="26746D"/>
-                </a:solidFill>
-                <a:latin typeface="Arial"/>
-                <a:ea typeface="Arial"/>
-                <a:cs typeface="Arial"/>
-              </a:rPr>
-              <a:t>Approve and transfer</a:t>
-            </a:r>
-          </a:p>
-        </p:txBody>
-      </p:sp>
-      <p:sp>
-        <p:nvSpPr>
-          <p:cNvPr id="8" name="detail-2">
+              <a:defRPr sz="2100" b="0">
+                <a:solidFill>
+                  <a:srgbClr val="17343C"/>
+                </a:solidFill>
+                <a:latin typeface="Arial"/>
+                <a:ea typeface="Arial"/>
+                <a:cs typeface="Arial"/>
+              </a:defRPr>
+            </a:pPr>
+            <a:r>
+              <a:rPr sz="2100" b="0">
+                <a:solidFill>
+                  <a:srgbClr val="17343C"/>
+                </a:solidFill>
+                <a:latin typeface="Arial"/>
+                <a:ea typeface="Arial"/>
+                <a:cs typeface="Arial"/>
+              </a:rPr>
+              <a:t>Course document analysis</a:t>
+            </a:r>
+          </a:p>
+          <a:p xmlns:a="http://schemas.openxmlformats.org/drawingml/2006/main">
+            <a:pPr algn="l">
+              <a:defRPr sz="2100" b="0">
+                <a:solidFill>
+                  <a:srgbClr val="17343C"/>
+                </a:solidFill>
+                <a:latin typeface="Arial"/>
+                <a:ea typeface="Arial"/>
+                <a:cs typeface="Arial"/>
+              </a:defRPr>
+            </a:pPr>
+            <a:r>
+              <a:rPr sz="2100" b="0">
+                <a:solidFill>
+                  <a:srgbClr val="17343C"/>
+                </a:solidFill>
+                <a:latin typeface="Arial"/>
+                <a:ea typeface="Arial"/>
+                <a:cs typeface="Arial"/>
+              </a:rPr>
+              <a:t>Desk walkthrough of the process</a:t>
+            </a:r>
+          </a:p>
+          <a:p xmlns:a="http://schemas.openxmlformats.org/drawingml/2006/main">
+            <a:pPr algn="l">
+              <a:defRPr sz="2100" b="0">
+                <a:solidFill>
+                  <a:srgbClr val="17343C"/>
+                </a:solidFill>
+                <a:latin typeface="Arial"/>
+                <a:ea typeface="Arial"/>
+                <a:cs typeface="Arial"/>
+              </a:defRPr>
+            </a:pPr>
+            <a:r>
+              <a:rPr sz="2100" b="0">
+                <a:solidFill>
+                  <a:srgbClr val="17343C"/>
+                </a:solidFill>
+                <a:latin typeface="Arial"/>
+                <a:ea typeface="Arial"/>
+                <a:cs typeface="Arial"/>
+              </a:rPr>
+              <a:t>Numbered requirements and priorities</a:t>
+            </a:r>
+          </a:p>
+        </p:txBody>
+      </p:sp>
+      <p:sp>
+        <p:nvSpPr>
+          <p:cNvPr id="8" name="planned-label">
             <a:extLst xmlns:a="http://schemas.openxmlformats.org/drawingml/2006/main">
               <a:ext uri="{FF2B5EF4-FFF2-40B4-BE49-F238E27FC236}">
-                <a16:creationId xmlns:a16="http://schemas.microsoft.com/office/drawing/2014/main" id="{336B358A-C44D-479A-B7DC-BA4F4B7D66D2}"/>
+                <a16:creationId xmlns:a16="http://schemas.microsoft.com/office/drawing/2014/main" id="{D9005555-4FDE-4419-A212-DBB725C9D212}"/>
               </a:ext>
             </a:extLst>
           </p:cNvPr>
@@ -3157,8 +3188,8 @@
         </p:nvSpPr>
         <p:spPr>
           <a:xfrm xmlns:a="http://schemas.openxmlformats.org/drawingml/2006/main">
-            <a:off x="4276725" y="3438525"/>
-            <a:ext cx="7229475" cy="666750"/>
+            <a:off x="5553075" y="4295775"/>
+            <a:ext cx="5953125" cy="457200"/>
           </a:xfrm>
           <a:prstGeom xmlns:a="http://schemas.openxmlformats.org/drawingml/2006/main" prst="rect">
             <a:avLst/>
@@ -3175,35 +3206,35 @@
           <a:lstStyle xmlns:a="http://schemas.openxmlformats.org/drawingml/2006/main"/>
           <a:p xmlns:a="http://schemas.openxmlformats.org/drawingml/2006/main">
             <a:pPr algn="l">
-              <a:defRPr sz="2175" b="0">
-                <a:solidFill>
-                  <a:srgbClr val="17343C"/>
-                </a:solidFill>
-                <a:latin typeface="Arial"/>
-                <a:ea typeface="Arial"/>
-                <a:cs typeface="Arial"/>
-              </a:defRPr>
-            </a:pPr>
-            <a:r>
-              <a:rPr sz="2175" b="0">
-                <a:solidFill>
-                  <a:srgbClr val="17343C"/>
-                </a:solidFill>
-                <a:latin typeface="Arial"/>
-                <a:ea typeface="Arial"/>
-                <a:cs typeface="Arial"/>
-              </a:rPr>
-              <a:t>Authorised people confirm release and receipt</a:t>
-            </a:r>
-          </a:p>
-        </p:txBody>
-      </p:sp>
-      <p:sp>
-        <p:nvSpPr>
-          <p:cNvPr id="9" name="step-3">
+              <a:defRPr sz="2325" b="1">
+                <a:solidFill>
+                  <a:srgbClr val="26746D"/>
+                </a:solidFill>
+                <a:latin typeface="Arial"/>
+                <a:ea typeface="Arial"/>
+                <a:cs typeface="Arial"/>
+              </a:defRPr>
+            </a:pPr>
+            <a:r>
+              <a:rPr sz="2325" b="1">
+                <a:solidFill>
+                  <a:srgbClr val="26746D"/>
+                </a:solidFill>
+                <a:latin typeface="Arial"/>
+                <a:ea typeface="Arial"/>
+                <a:cs typeface="Arial"/>
+              </a:rPr>
+              <a:t>Validation next</a:t>
+            </a:r>
+          </a:p>
+        </p:txBody>
+      </p:sp>
+      <p:sp>
+        <p:nvSpPr>
+          <p:cNvPr id="9" name="planned">
             <a:extLst xmlns:a="http://schemas.openxmlformats.org/drawingml/2006/main">
               <a:ext uri="{FF2B5EF4-FFF2-40B4-BE49-F238E27FC236}">
-                <a16:creationId xmlns:a16="http://schemas.microsoft.com/office/drawing/2014/main" id="{DCA3A95B-D96D-43B7-9D1E-27460C98F900}"/>
+                <a16:creationId xmlns:a16="http://schemas.microsoft.com/office/drawing/2014/main" id="{A9A32016-14B3-4484-AF50-5025BFFD5EB5}"/>
               </a:ext>
             </a:extLst>
           </p:cNvPr>
@@ -3214,8 +3245,8 @@
         </p:nvSpPr>
         <p:spPr>
           <a:xfrm xmlns:a="http://schemas.openxmlformats.org/drawingml/2006/main">
-            <a:off x="685800" y="4267200"/>
-            <a:ext cx="3286125" cy="533400"/>
+            <a:off x="5553075" y="4933950"/>
+            <a:ext cx="5953125" cy="771525"/>
           </a:xfrm>
           <a:prstGeom xmlns:a="http://schemas.openxmlformats.org/drawingml/2006/main" prst="rect">
             <a:avLst/>
@@ -3232,35 +3263,35 @@
           <a:lstStyle xmlns:a="http://schemas.openxmlformats.org/drawingml/2006/main"/>
           <a:p xmlns:a="http://schemas.openxmlformats.org/drawingml/2006/main">
             <a:pPr algn="l">
-              <a:defRPr sz="2175" b="1">
-                <a:solidFill>
-                  <a:srgbClr val="26746D"/>
-                </a:solidFill>
-                <a:latin typeface="Arial"/>
-                <a:ea typeface="Arial"/>
-                <a:cs typeface="Arial"/>
-              </a:defRPr>
-            </a:pPr>
-            <a:r>
-              <a:rPr sz="2175" b="1">
-                <a:solidFill>
-                  <a:srgbClr val="26746D"/>
-                </a:solidFill>
-                <a:latin typeface="Arial"/>
-                <a:ea typeface="Arial"/>
-                <a:cs typeface="Arial"/>
-              </a:rPr>
-              <a:t>Maintain and report</a:t>
-            </a:r>
-          </a:p>
-        </p:txBody>
-      </p:sp>
-      <p:sp>
-        <p:nvSpPr>
-          <p:cNvPr id="10" name="detail-3">
+              <a:defRPr sz="2100" b="0">
+                <a:solidFill>
+                  <a:srgbClr val="17343C"/>
+                </a:solidFill>
+                <a:latin typeface="Arial"/>
+                <a:ea typeface="Arial"/>
+                <a:cs typeface="Arial"/>
+              </a:defRPr>
+            </a:pPr>
+            <a:r>
+              <a:rPr sz="2100" b="0">
+                <a:solidFill>
+                  <a:srgbClr val="17343C"/>
+                </a:solidFill>
+                <a:latin typeface="Arial"/>
+                <a:ea typeface="Arial"/>
+                <a:cs typeface="Arial"/>
+              </a:rPr>
+              <a:t>Interviews, survey and a process workshop</a:t>
+            </a:r>
+          </a:p>
+        </p:txBody>
+      </p:sp>
+      <p:sp>
+        <p:nvSpPr>
+          <p:cNvPr id="10" name="categories">
             <a:extLst xmlns:a="http://schemas.openxmlformats.org/drawingml/2006/main">
               <a:ext uri="{FF2B5EF4-FFF2-40B4-BE49-F238E27FC236}">
-                <a16:creationId xmlns:a16="http://schemas.microsoft.com/office/drawing/2014/main" id="{870B8BBF-9332-4FF1-B429-8B9E1462D037}"/>
+                <a16:creationId xmlns:a16="http://schemas.microsoft.com/office/drawing/2014/main" id="{EF195C1B-22C3-4A9B-A47A-DABA896B2AE3}"/>
               </a:ext>
             </a:extLst>
           </p:cNvPr>
@@ -3271,8 +3302,8 @@
         </p:nvSpPr>
         <p:spPr>
           <a:xfrm xmlns:a="http://schemas.openxmlformats.org/drawingml/2006/main">
-            <a:off x="4276725" y="4267200"/>
-            <a:ext cx="7229475" cy="666750"/>
+            <a:off x="685800" y="6000750"/>
+            <a:ext cx="10820400" cy="333375"/>
           </a:xfrm>
           <a:prstGeom xmlns:a="http://schemas.openxmlformats.org/drawingml/2006/main" prst="rect">
             <a:avLst/>
@@ -3289,82 +3320,25 @@
           <a:lstStyle xmlns:a="http://schemas.openxmlformats.org/drawingml/2006/main"/>
           <a:p xmlns:a="http://schemas.openxmlformats.org/drawingml/2006/main">
             <a:pPr algn="l">
-              <a:defRPr sz="2175" b="0">
-                <a:solidFill>
-                  <a:srgbClr val="17343C"/>
-                </a:solidFill>
-                <a:latin typeface="Arial"/>
-                <a:ea typeface="Arial"/>
-                <a:cs typeface="Arial"/>
-              </a:defRPr>
-            </a:pPr>
-            <a:r>
-              <a:rPr sz="2175" b="0">
-                <a:solidFill>
-                  <a:srgbClr val="17343C"/>
-                </a:solidFill>
-                <a:latin typeface="Arial"/>
-                <a:ea typeface="Arial"/>
-                <a:cs typeface="Arial"/>
-              </a:rPr>
-              <a:t>Track custody, repairs and reuse outcomes</a:t>
-            </a:r>
-          </a:p>
-        </p:txBody>
-      </p:sp>
-      <p:sp>
-        <p:nvSpPr>
-          <p:cNvPr id="11" name="hosting">
-            <a:extLst xmlns:a="http://schemas.openxmlformats.org/drawingml/2006/main">
-              <a:ext uri="{FF2B5EF4-FFF2-40B4-BE49-F238E27FC236}">
-                <a16:creationId xmlns:a16="http://schemas.microsoft.com/office/drawing/2014/main" id="{EF884241-8898-4DAE-BB99-7DD611B57878}"/>
-              </a:ext>
-            </a:extLst>
-          </p:cNvPr>
-          <p:cNvSpPr>
-            <a:spLocks xmlns:a="http://schemas.openxmlformats.org/drawingml/2006/main" noGrp="1"/>
-          </p:cNvSpPr>
-          <p:nvPr/>
-        </p:nvSpPr>
-        <p:spPr>
-          <a:xfrm xmlns:a="http://schemas.openxmlformats.org/drawingml/2006/main">
-            <a:off x="685800" y="5553075"/>
-            <a:ext cx="10820400" cy="495300"/>
-          </a:xfrm>
-          <a:prstGeom xmlns:a="http://schemas.openxmlformats.org/drawingml/2006/main" prst="rect">
-            <a:avLst/>
-          </a:prstGeom>
-          <a:noFill xmlns:a="http://schemas.openxmlformats.org/drawingml/2006/main"/>
-          <a:ln xmlns:a="http://schemas.openxmlformats.org/drawingml/2006/main" w="0">
-            <a:noFill/>
-          </a:ln>
-        </p:spPr>
-        <p:txBody>
-          <a:bodyPr xmlns:a="http://schemas.openxmlformats.org/drawingml/2006/main" wrap="square" lIns="0" tIns="0" rIns="0" bIns="0" anchor="t">
-            <a:noAutofit/>
-          </a:bodyPr>
-          <a:lstStyle xmlns:a="http://schemas.openxmlformats.org/drawingml/2006/main"/>
-          <a:p xmlns:a="http://schemas.openxmlformats.org/drawingml/2006/main">
-            <a:pPr algn="l">
-              <a:defRPr sz="2175" b="1">
-                <a:solidFill>
-                  <a:srgbClr val="17343C"/>
-                </a:solidFill>
-                <a:latin typeface="Arial"/>
-                <a:ea typeface="Arial"/>
-                <a:cs typeface="Arial"/>
-              </a:defRPr>
-            </a:pPr>
-            <a:r>
-              <a:rPr sz="2175" b="1">
-                <a:solidFill>
-                  <a:srgbClr val="17343C"/>
-                </a:solidFill>
-                <a:latin typeface="Arial"/>
-                <a:ea typeface="Arial"/>
-                <a:cs typeface="Arial"/>
-              </a:rPr>
-              <a:t>A hosted web application, with deployment in scope</a:t>
+              <a:defRPr sz="1725" b="0">
+                <a:solidFill>
+                  <a:srgbClr val="536466"/>
+                </a:solidFill>
+                <a:latin typeface="Arial"/>
+                <a:ea typeface="Arial"/>
+                <a:cs typeface="Arial"/>
+              </a:defRPr>
+            </a:pPr>
+            <a:r>
+              <a:rPr sz="1725" b="0">
+                <a:solidFill>
+                  <a:srgbClr val="536466"/>
+                </a:solidFill>
+                <a:latin typeface="Arial"/>
+                <a:ea typeface="Arial"/>
+                <a:cs typeface="Arial"/>
+              </a:rPr>
+              <a:t>18 classic functional, 13 AI, 8 sustainability and 13 non-functional requirements</a:t>
             </a:r>
           </a:p>
         </p:txBody>
@@ -3372,7 +3346,7 @@
     </p:spTree>
     <p:extLst>
       <p:ext uri="{BB962C8B-B14F-4D97-AF65-F5344CB8AC3E}">
-        <p14:creationId xmlns:p14="http://schemas.microsoft.com/office/powerpoint/2010/main" val="1398928180"/>
+        <p14:creationId xmlns:p14="http://schemas.microsoft.com/office/powerpoint/2010/main" val="731583401"/>
       </p:ext>
     </p:extLst>
   </p:cSld>
@@ -3400,10 +3374,10 @@
       </p:grpSpPr>
       <p:sp>
         <p:nvSpPr>
-          <p:cNvPr id="10" name="slide-title">
+          <p:cNvPr id="11" name="slide-title">
             <a:extLst xmlns:a="http://schemas.openxmlformats.org/drawingml/2006/main">
               <a:ext uri="{FF2B5EF4-FFF2-40B4-BE49-F238E27FC236}">
-                <a16:creationId xmlns:a16="http://schemas.microsoft.com/office/drawing/2014/main" id="{516FA2C7-FEDD-4DEC-8CE7-48B9203EF772}"/>
+                <a16:creationId xmlns:a16="http://schemas.microsoft.com/office/drawing/2014/main" id="{06FA9382-6924-4D85-ACB3-E1478BC21046}"/>
               </a:ext>
             </a:extLst>
           </p:cNvPr>
@@ -3450,7 +3424,7 @@
                 <a:ea typeface="Arial"/>
                 <a:cs typeface="Arial"/>
               </a:rPr>
-              <a:t>What Phase 1 established</a:t>
+              <a:t>Our AI matching approach</a:t>
             </a:r>
           </a:p>
         </p:txBody>
@@ -3460,7 +3434,7 @@
           <p:cNvPr id="2" name="page-number">
             <a:extLst xmlns:a="http://schemas.openxmlformats.org/drawingml/2006/main">
               <a:ext uri="{FF2B5EF4-FFF2-40B4-BE49-F238E27FC236}">
-                <a16:creationId xmlns:a16="http://schemas.microsoft.com/office/drawing/2014/main" id="{EAA78940-C15F-446C-B4E6-6D15175DB0A7}"/>
+                <a16:creationId xmlns:a16="http://schemas.microsoft.com/office/drawing/2014/main" id="{497DD343-FA2C-4405-9623-FDC7616EF4DB}"/>
               </a:ext>
             </a:extLst>
           </p:cNvPr>
@@ -3514,10 +3488,10 @@
       </p:sp>
       <p:sp>
         <p:nvSpPr>
-          <p:cNvPr id="3" name="role-count">
+          <p:cNvPr id="3" name="step-0">
             <a:extLst xmlns:a="http://schemas.openxmlformats.org/drawingml/2006/main">
               <a:ext uri="{FF2B5EF4-FFF2-40B4-BE49-F238E27FC236}">
-                <a16:creationId xmlns:a16="http://schemas.microsoft.com/office/drawing/2014/main" id="{E88DDB5A-8DA1-4D7D-9DBA-54EC2BD1D4B8}"/>
+                <a16:creationId xmlns:a16="http://schemas.microsoft.com/office/drawing/2014/main" id="{26103332-3B7C-4390-8261-38E8E0369280}"/>
               </a:ext>
             </a:extLst>
           </p:cNvPr>
@@ -3528,8 +3502,8 @@
         </p:nvSpPr>
         <p:spPr>
           <a:xfrm xmlns:a="http://schemas.openxmlformats.org/drawingml/2006/main">
-            <a:off x="685800" y="1895475"/>
-            <a:ext cx="2381250" cy="1114425"/>
+            <a:off x="685800" y="1676400"/>
+            <a:ext cx="3429000" cy="704850"/>
           </a:xfrm>
           <a:prstGeom xmlns:a="http://schemas.openxmlformats.org/drawingml/2006/main" prst="rect">
             <a:avLst/>
@@ -3546,7 +3520,7 @@
           <a:lstStyle xmlns:a="http://schemas.openxmlformats.org/drawingml/2006/main"/>
           <a:p xmlns:a="http://schemas.openxmlformats.org/drawingml/2006/main">
             <a:pPr algn="l">
-              <a:defRPr sz="7500" b="1">
+              <a:defRPr sz="2325" b="1">
                 <a:solidFill>
                   <a:srgbClr val="26746D"/>
                 </a:solidFill>
@@ -3556,7 +3530,7 @@
               </a:defRPr>
             </a:pPr>
             <a:r>
-              <a:rPr sz="7500" b="1">
+              <a:rPr sz="2325" b="1">
                 <a:solidFill>
                   <a:srgbClr val="26746D"/>
                 </a:solidFill>
@@ -3564,17 +3538,17 @@
                 <a:ea typeface="Arial"/>
                 <a:cs typeface="Arial"/>
               </a:rPr>
-              <a:t>9</a:t>
-            </a:r>
-          </a:p>
-        </p:txBody>
-      </p:sp>
-      <p:sp>
-        <p:nvSpPr>
-          <p:cNvPr id="4" name="role-count-label">
+              <a:t>Eligibility first</a:t>
+            </a:r>
+          </a:p>
+        </p:txBody>
+      </p:sp>
+      <p:sp>
+        <p:nvSpPr>
+          <p:cNvPr id="4" name="detail-0">
             <a:extLst xmlns:a="http://schemas.openxmlformats.org/drawingml/2006/main">
               <a:ext uri="{FF2B5EF4-FFF2-40B4-BE49-F238E27FC236}">
-                <a16:creationId xmlns:a16="http://schemas.microsoft.com/office/drawing/2014/main" id="{2A1C302A-71FC-4908-8480-DA1E41F60AC7}"/>
+                <a16:creationId xmlns:a16="http://schemas.microsoft.com/office/drawing/2014/main" id="{5503219B-9545-4642-B141-F9C5DF8838B2}"/>
               </a:ext>
             </a:extLst>
           </p:cNvPr>
@@ -3585,8 +3559,8 @@
         </p:nvSpPr>
         <p:spPr>
           <a:xfrm xmlns:a="http://schemas.openxmlformats.org/drawingml/2006/main">
-            <a:off x="685800" y="3143250"/>
-            <a:ext cx="2667000" cy="552450"/>
+            <a:off x="4476750" y="1676400"/>
+            <a:ext cx="7029450" cy="895350"/>
           </a:xfrm>
           <a:prstGeom xmlns:a="http://schemas.openxmlformats.org/drawingml/2006/main" prst="rect">
             <a:avLst/>
@@ -3603,35 +3577,58 @@
           <a:lstStyle xmlns:a="http://schemas.openxmlformats.org/drawingml/2006/main"/>
           <a:p xmlns:a="http://schemas.openxmlformats.org/drawingml/2006/main">
             <a:pPr algn="l">
-              <a:defRPr sz="2325" b="1">
-                <a:solidFill>
-                  <a:srgbClr val="17343C"/>
-                </a:solidFill>
-                <a:latin typeface="Arial"/>
-                <a:ea typeface="Arial"/>
-                <a:cs typeface="Arial"/>
-              </a:defRPr>
-            </a:pPr>
-            <a:r>
-              <a:rPr sz="2325" b="1">
-                <a:solidFill>
-                  <a:srgbClr val="17343C"/>
-                </a:solidFill>
-                <a:latin typeface="Arial"/>
-                <a:ea typeface="Arial"/>
-                <a:cs typeface="Arial"/>
-              </a:rPr>
-              <a:t>system roles</a:t>
-            </a:r>
-          </a:p>
-        </p:txBody>
-      </p:sp>
-      <p:sp>
-        <p:nvSpPr>
-          <p:cNvPr id="5" name="roles-example">
+              <a:defRPr sz="2175" b="0">
+                <a:solidFill>
+                  <a:srgbClr val="17343C"/>
+                </a:solidFill>
+                <a:latin typeface="Arial"/>
+                <a:ea typeface="Arial"/>
+                <a:cs typeface="Arial"/>
+              </a:defRPr>
+            </a:pPr>
+            <a:r>
+              <a:rPr sz="2175" b="0">
+                <a:solidFill>
+                  <a:srgbClr val="17343C"/>
+                </a:solidFill>
+                <a:latin typeface="Arial"/>
+                <a:ea typeface="Arial"/>
+                <a:cs typeface="Arial"/>
+              </a:rPr>
+              <a:t>Check permissions, quantity, specifications</a:t>
+            </a:r>
+          </a:p>
+          <a:p xmlns:a="http://schemas.openxmlformats.org/drawingml/2006/main">
+            <a:pPr algn="l">
+              <a:defRPr sz="2175" b="0">
+                <a:solidFill>
+                  <a:srgbClr val="17343C"/>
+                </a:solidFill>
+                <a:latin typeface="Arial"/>
+                <a:ea typeface="Arial"/>
+                <a:cs typeface="Arial"/>
+              </a:defRPr>
+            </a:pPr>
+            <a:r>
+              <a:rPr sz="2175" b="0">
+                <a:solidFill>
+                  <a:srgbClr val="17343C"/>
+                </a:solidFill>
+                <a:latin typeface="Arial"/>
+                <a:ea typeface="Arial"/>
+                <a:cs typeface="Arial"/>
+              </a:rPr>
+              <a:t>and required dates</a:t>
+            </a:r>
+          </a:p>
+        </p:txBody>
+      </p:sp>
+      <p:sp>
+        <p:nvSpPr>
+          <p:cNvPr id="5" name="step-1">
             <a:extLst xmlns:a="http://schemas.openxmlformats.org/drawingml/2006/main">
               <a:ext uri="{FF2B5EF4-FFF2-40B4-BE49-F238E27FC236}">
-                <a16:creationId xmlns:a16="http://schemas.microsoft.com/office/drawing/2014/main" id="{0011BEE2-D2E8-4CFC-8A82-430D4A733547}"/>
+                <a16:creationId xmlns:a16="http://schemas.microsoft.com/office/drawing/2014/main" id="{6061B702-AFDF-4745-AF64-98D0EF55FA70}"/>
               </a:ext>
             </a:extLst>
           </p:cNvPr>
@@ -3642,8 +3639,8 @@
         </p:nvSpPr>
         <p:spPr>
           <a:xfrm xmlns:a="http://schemas.openxmlformats.org/drawingml/2006/main">
-            <a:off x="685800" y="3876675"/>
-            <a:ext cx="4000500" cy="1028700"/>
+            <a:off x="685800" y="2733675"/>
+            <a:ext cx="3429000" cy="704850"/>
           </a:xfrm>
           <a:prstGeom xmlns:a="http://schemas.openxmlformats.org/drawingml/2006/main" prst="rect">
             <a:avLst/>
@@ -3660,58 +3657,35 @@
           <a:lstStyle xmlns:a="http://schemas.openxmlformats.org/drawingml/2006/main"/>
           <a:p xmlns:a="http://schemas.openxmlformats.org/drawingml/2006/main">
             <a:pPr algn="l">
-              <a:defRPr sz="2025" b="0">
-                <a:solidFill>
-                  <a:srgbClr val="17343C"/>
-                </a:solidFill>
-                <a:latin typeface="Arial"/>
-                <a:ea typeface="Arial"/>
-                <a:cs typeface="Arial"/>
-              </a:defRPr>
-            </a:pPr>
-            <a:r>
-              <a:rPr sz="2025" b="0">
-                <a:solidFill>
-                  <a:srgbClr val="17343C"/>
-                </a:solidFill>
-                <a:latin typeface="Arial"/>
-                <a:ea typeface="Arial"/>
-                <a:cs typeface="Arial"/>
-              </a:rPr>
-              <a:t>Requesters, custodians,</a:t>
-            </a:r>
-          </a:p>
-          <a:p xmlns:a="http://schemas.openxmlformats.org/drawingml/2006/main">
-            <a:pPr algn="l">
-              <a:defRPr sz="2025" b="0">
-                <a:solidFill>
-                  <a:srgbClr val="17343C"/>
-                </a:solidFill>
-                <a:latin typeface="Arial"/>
-                <a:ea typeface="Arial"/>
-                <a:cs typeface="Arial"/>
-              </a:defRPr>
-            </a:pPr>
-            <a:r>
-              <a:rPr sz="2025" b="0">
-                <a:solidFill>
-                  <a:srgbClr val="17343C"/>
-                </a:solidFill>
-                <a:latin typeface="Arial"/>
-                <a:ea typeface="Arial"/>
-                <a:cs typeface="Arial"/>
-              </a:rPr>
-              <a:t>approvers and support roles</a:t>
-            </a:r>
-          </a:p>
-        </p:txBody>
-      </p:sp>
-      <p:sp>
-        <p:nvSpPr>
-          <p:cNvPr id="6" name="work-a">
+              <a:defRPr sz="2325" b="1">
+                <a:solidFill>
+                  <a:srgbClr val="26746D"/>
+                </a:solidFill>
+                <a:latin typeface="Arial"/>
+                <a:ea typeface="Arial"/>
+                <a:cs typeface="Arial"/>
+              </a:defRPr>
+            </a:pPr>
+            <a:r>
+              <a:rPr sz="2325" b="1">
+                <a:solidFill>
+                  <a:srgbClr val="26746D"/>
+                </a:solidFill>
+                <a:latin typeface="Arial"/>
+                <a:ea typeface="Arial"/>
+                <a:cs typeface="Arial"/>
+              </a:rPr>
+              <a:t>Then AI ranking</a:t>
+            </a:r>
+          </a:p>
+        </p:txBody>
+      </p:sp>
+      <p:sp>
+        <p:nvSpPr>
+          <p:cNvPr id="6" name="detail-1">
             <a:extLst xmlns:a="http://schemas.openxmlformats.org/drawingml/2006/main">
               <a:ext uri="{FF2B5EF4-FFF2-40B4-BE49-F238E27FC236}">
-                <a16:creationId xmlns:a16="http://schemas.microsoft.com/office/drawing/2014/main" id="{7750C6A7-F772-4FA4-B2BE-D32CEB77D225}"/>
+                <a16:creationId xmlns:a16="http://schemas.microsoft.com/office/drawing/2014/main" id="{F409C28B-2982-40AA-9F42-0BFBAED7A7F1}"/>
               </a:ext>
             </a:extLst>
           </p:cNvPr>
@@ -3722,8 +3696,8 @@
         </p:nvSpPr>
         <p:spPr>
           <a:xfrm xmlns:a="http://schemas.openxmlformats.org/drawingml/2006/main">
-            <a:off x="5429250" y="1866900"/>
-            <a:ext cx="6076950" cy="847725"/>
+            <a:off x="4476750" y="2733675"/>
+            <a:ext cx="7029450" cy="895350"/>
           </a:xfrm>
           <a:prstGeom xmlns:a="http://schemas.openxmlformats.org/drawingml/2006/main" prst="rect">
             <a:avLst/>
@@ -3740,35 +3714,58 @@
           <a:lstStyle xmlns:a="http://schemas.openxmlformats.org/drawingml/2006/main"/>
           <a:p xmlns:a="http://schemas.openxmlformats.org/drawingml/2006/main">
             <a:pPr algn="l">
-              <a:defRPr sz="2400" b="1">
-                <a:solidFill>
-                  <a:srgbClr val="17343C"/>
-                </a:solidFill>
-                <a:latin typeface="Arial"/>
-                <a:ea typeface="Arial"/>
-                <a:cs typeface="Arial"/>
-              </a:defRPr>
-            </a:pPr>
-            <a:r>
-              <a:rPr sz="2400" b="1">
-                <a:solidFill>
-                  <a:srgbClr val="17343C"/>
-                </a:solidFill>
-                <a:latin typeface="Arial"/>
-                <a:ea typeface="Arial"/>
-                <a:cs typeface="Arial"/>
-              </a:rPr>
-              <a:t>Mapped the process and approval owners</a:t>
-            </a:r>
-          </a:p>
-        </p:txBody>
-      </p:sp>
-      <p:sp>
-        <p:nvSpPr>
-          <p:cNvPr id="7" name="work-b">
+              <a:defRPr sz="2175" b="0">
+                <a:solidFill>
+                  <a:srgbClr val="17343C"/>
+                </a:solidFill>
+                <a:latin typeface="Arial"/>
+                <a:ea typeface="Arial"/>
+                <a:cs typeface="Arial"/>
+              </a:defRPr>
+            </a:pPr>
+            <a:r>
+              <a:rPr sz="2175" b="0">
+                <a:solidFill>
+                  <a:srgbClr val="17343C"/>
+                </a:solidFill>
+                <a:latin typeface="Arial"/>
+                <a:ea typeface="Arial"/>
+                <a:cs typeface="Arial"/>
+              </a:rPr>
+              <a:t>Rank eligible candidates and explain</a:t>
+            </a:r>
+          </a:p>
+          <a:p xmlns:a="http://schemas.openxmlformats.org/drawingml/2006/main">
+            <a:pPr algn="l">
+              <a:defRPr sz="2175" b="0">
+                <a:solidFill>
+                  <a:srgbClr val="17343C"/>
+                </a:solidFill>
+                <a:latin typeface="Arial"/>
+                <a:ea typeface="Arial"/>
+                <a:cs typeface="Arial"/>
+              </a:defRPr>
+            </a:pPr>
+            <a:r>
+              <a:rPr sz="2175" b="0">
+                <a:solidFill>
+                  <a:srgbClr val="17343C"/>
+                </a:solidFill>
+                <a:latin typeface="Arial"/>
+                <a:ea typeface="Arial"/>
+                <a:cs typeface="Arial"/>
+              </a:rPr>
+              <a:t>why each item was suggested</a:t>
+            </a:r>
+          </a:p>
+        </p:txBody>
+      </p:sp>
+      <p:sp>
+        <p:nvSpPr>
+          <p:cNvPr id="7" name="step-2">
             <a:extLst xmlns:a="http://schemas.openxmlformats.org/drawingml/2006/main">
               <a:ext uri="{FF2B5EF4-FFF2-40B4-BE49-F238E27FC236}">
-                <a16:creationId xmlns:a16="http://schemas.microsoft.com/office/drawing/2014/main" id="{27F1A9AD-E8C9-4F44-83C8-62D648D64AC3}"/>
+                <a16:creationId xmlns:a16="http://schemas.microsoft.com/office/drawing/2014/main" id="{21EC5514-4AA5-4115-8857-DD9E0BAB6747}"/>
               </a:ext>
             </a:extLst>
           </p:cNvPr>
@@ -3779,8 +3776,8 @@
         </p:nvSpPr>
         <p:spPr>
           <a:xfrm xmlns:a="http://schemas.openxmlformats.org/drawingml/2006/main">
-            <a:off x="5429250" y="2962275"/>
-            <a:ext cx="6076950" cy="904875"/>
+            <a:off x="685800" y="3790950"/>
+            <a:ext cx="3429000" cy="704850"/>
           </a:xfrm>
           <a:prstGeom xmlns:a="http://schemas.openxmlformats.org/drawingml/2006/main" prst="rect">
             <a:avLst/>
@@ -3797,35 +3794,35 @@
           <a:lstStyle xmlns:a="http://schemas.openxmlformats.org/drawingml/2006/main"/>
           <a:p xmlns:a="http://schemas.openxmlformats.org/drawingml/2006/main">
             <a:pPr algn="l">
-              <a:defRPr sz="2325" b="0">
-                <a:solidFill>
-                  <a:srgbClr val="17343C"/>
-                </a:solidFill>
-                <a:latin typeface="Arial"/>
-                <a:ea typeface="Arial"/>
-                <a:cs typeface="Arial"/>
-              </a:defRPr>
-            </a:pPr>
-            <a:r>
-              <a:rPr sz="2325" b="0">
-                <a:solidFill>
-                  <a:srgbClr val="17343C"/>
-                </a:solidFill>
-                <a:latin typeface="Arial"/>
-                <a:ea typeface="Arial"/>
-                <a:cs typeface="Arial"/>
-              </a:rPr>
-              <a:t>Analysed course documents and the scenario</a:t>
-            </a:r>
-          </a:p>
-        </p:txBody>
-      </p:sp>
-      <p:sp>
-        <p:nvSpPr>
-          <p:cNvPr id="8" name="work-c">
+              <a:defRPr sz="2325" b="1">
+                <a:solidFill>
+                  <a:srgbClr val="26746D"/>
+                </a:solidFill>
+                <a:latin typeface="Arial"/>
+                <a:ea typeface="Arial"/>
+                <a:cs typeface="Arial"/>
+              </a:defRPr>
+            </a:pPr>
+            <a:r>
+              <a:rPr sz="2325" b="1">
+                <a:solidFill>
+                  <a:srgbClr val="26746D"/>
+                </a:solidFill>
+                <a:latin typeface="Arial"/>
+                <a:ea typeface="Arial"/>
+                <a:cs typeface="Arial"/>
+              </a:rPr>
+              <a:t>Human decision</a:t>
+            </a:r>
+          </a:p>
+        </p:txBody>
+      </p:sp>
+      <p:sp>
+        <p:nvSpPr>
+          <p:cNvPr id="8" name="detail-2">
             <a:extLst xmlns:a="http://schemas.openxmlformats.org/drawingml/2006/main">
               <a:ext uri="{FF2B5EF4-FFF2-40B4-BE49-F238E27FC236}">
-                <a16:creationId xmlns:a16="http://schemas.microsoft.com/office/drawing/2014/main" id="{072658BE-FE4F-4BED-BB15-B4DE9371623E}"/>
+                <a16:creationId xmlns:a16="http://schemas.microsoft.com/office/drawing/2014/main" id="{22E08BA1-5D50-442B-9A9A-0926094246A4}"/>
               </a:ext>
             </a:extLst>
           </p:cNvPr>
@@ -3836,8 +3833,8 @@
         </p:nvSpPr>
         <p:spPr>
           <a:xfrm xmlns:a="http://schemas.openxmlformats.org/drawingml/2006/main">
-            <a:off x="5429250" y="4076700"/>
-            <a:ext cx="6076950" cy="866775"/>
+            <a:off x="4476750" y="3790950"/>
+            <a:ext cx="7029450" cy="895350"/>
           </a:xfrm>
           <a:prstGeom xmlns:a="http://schemas.openxmlformats.org/drawingml/2006/main" prst="rect">
             <a:avLst/>
@@ -3854,35 +3851,58 @@
           <a:lstStyle xmlns:a="http://schemas.openxmlformats.org/drawingml/2006/main"/>
           <a:p xmlns:a="http://schemas.openxmlformats.org/drawingml/2006/main">
             <a:pPr algn="l">
-              <a:defRPr sz="2325" b="0">
-                <a:solidFill>
-                  <a:srgbClr val="17343C"/>
-                </a:solidFill>
-                <a:latin typeface="Arial"/>
-                <a:ea typeface="Arial"/>
-                <a:cs typeface="Arial"/>
-              </a:defRPr>
-            </a:pPr>
-            <a:r>
-              <a:rPr sz="2325" b="0">
-                <a:solidFill>
-                  <a:srgbClr val="17343C"/>
-                </a:solidFill>
-                <a:latin typeface="Arial"/>
-                <a:ea typeface="Arial"/>
-                <a:cs typeface="Arial"/>
-              </a:rPr>
-              <a:t>Defined initial requirements and priorities</a:t>
-            </a:r>
-          </a:p>
-        </p:txBody>
-      </p:sp>
-      <p:sp>
-        <p:nvSpPr>
-          <p:cNvPr id="9" name="validation-next">
+              <a:defRPr sz="2175" b="0">
+                <a:solidFill>
+                  <a:srgbClr val="17343C"/>
+                </a:solidFill>
+                <a:latin typeface="Arial"/>
+                <a:ea typeface="Arial"/>
+                <a:cs typeface="Arial"/>
+              </a:defRPr>
+            </a:pPr>
+            <a:r>
+              <a:rPr sz="2175" b="0">
+                <a:solidFill>
+                  <a:srgbClr val="17343C"/>
+                </a:solidFill>
+                <a:latin typeface="Arial"/>
+                <a:ea typeface="Arial"/>
+                <a:cs typeface="Arial"/>
+              </a:rPr>
+              <a:t>Users choose an eligible option and</a:t>
+            </a:r>
+          </a:p>
+          <a:p xmlns:a="http://schemas.openxmlformats.org/drawingml/2006/main">
+            <a:pPr algn="l">
+              <a:defRPr sz="2175" b="0">
+                <a:solidFill>
+                  <a:srgbClr val="17343C"/>
+                </a:solidFill>
+                <a:latin typeface="Arial"/>
+                <a:ea typeface="Arial"/>
+                <a:cs typeface="Arial"/>
+              </a:defRPr>
+            </a:pPr>
+            <a:r>
+              <a:rPr sz="2175" b="0">
+                <a:solidFill>
+                  <a:srgbClr val="17343C"/>
+                </a:solidFill>
+                <a:latin typeface="Arial"/>
+                <a:ea typeface="Arial"/>
+                <a:cs typeface="Arial"/>
+              </a:rPr>
+              <a:t>follow the normal approval workflow</a:t>
+            </a:r>
+          </a:p>
+        </p:txBody>
+      </p:sp>
+      <p:sp>
+        <p:nvSpPr>
+          <p:cNvPr id="9" name="step-3">
             <a:extLst xmlns:a="http://schemas.openxmlformats.org/drawingml/2006/main">
               <a:ext uri="{FF2B5EF4-FFF2-40B4-BE49-F238E27FC236}">
-                <a16:creationId xmlns:a16="http://schemas.microsoft.com/office/drawing/2014/main" id="{6E8212E5-5DD5-41C7-B0E2-ECC43E4B4A69}"/>
+                <a16:creationId xmlns:a16="http://schemas.microsoft.com/office/drawing/2014/main" id="{E3C86BB1-7AE7-4528-8506-F47BE56CBF4E}"/>
               </a:ext>
             </a:extLst>
           </p:cNvPr>
@@ -3893,8 +3913,8 @@
         </p:nvSpPr>
         <p:spPr>
           <a:xfrm xmlns:a="http://schemas.openxmlformats.org/drawingml/2006/main">
-            <a:off x="685800" y="5657850"/>
-            <a:ext cx="10820400" cy="685800"/>
+            <a:off x="685800" y="4848225"/>
+            <a:ext cx="3429000" cy="704850"/>
           </a:xfrm>
           <a:prstGeom xmlns:a="http://schemas.openxmlformats.org/drawingml/2006/main" prst="rect">
             <a:avLst/>
@@ -3911,25 +3931,105 @@
           <a:lstStyle xmlns:a="http://schemas.openxmlformats.org/drawingml/2006/main"/>
           <a:p xmlns:a="http://schemas.openxmlformats.org/drawingml/2006/main">
             <a:pPr algn="l">
-              <a:defRPr sz="1875" b="0">
-                <a:solidFill>
-                  <a:srgbClr val="536466"/>
-                </a:solidFill>
-                <a:latin typeface="Arial"/>
-                <a:ea typeface="Arial"/>
-                <a:cs typeface="Arial"/>
-              </a:defRPr>
-            </a:pPr>
-            <a:r>
-              <a:rPr sz="1875" b="0">
-                <a:solidFill>
-                  <a:srgbClr val="536466"/>
-                </a:solidFill>
-                <a:latin typeface="Arial"/>
-                <a:ea typeface="Arial"/>
-                <a:cs typeface="Arial"/>
-              </a:rPr>
-              <a:t>Next: validate assumptions through interviews, a survey and a workshop</a:t>
+              <a:defRPr sz="2325" b="1">
+                <a:solidFill>
+                  <a:srgbClr val="26746D"/>
+                </a:solidFill>
+                <a:latin typeface="Arial"/>
+                <a:ea typeface="Arial"/>
+                <a:cs typeface="Arial"/>
+              </a:defRPr>
+            </a:pPr>
+            <a:r>
+              <a:rPr sz="2325" b="1">
+                <a:solidFill>
+                  <a:srgbClr val="26746D"/>
+                </a:solidFill>
+                <a:latin typeface="Arial"/>
+                <a:ea typeface="Arial"/>
+                <a:cs typeface="Arial"/>
+              </a:rPr>
+              <a:t>Classic fallback</a:t>
+            </a:r>
+          </a:p>
+        </p:txBody>
+      </p:sp>
+      <p:sp>
+        <p:nvSpPr>
+          <p:cNvPr id="10" name="detail-3">
+            <a:extLst xmlns:a="http://schemas.openxmlformats.org/drawingml/2006/main">
+              <a:ext uri="{FF2B5EF4-FFF2-40B4-BE49-F238E27FC236}">
+                <a16:creationId xmlns:a16="http://schemas.microsoft.com/office/drawing/2014/main" id="{FC106D50-CFE8-4BDF-8B2B-C62F389B78BD}"/>
+              </a:ext>
+            </a:extLst>
+          </p:cNvPr>
+          <p:cNvSpPr>
+            <a:spLocks xmlns:a="http://schemas.openxmlformats.org/drawingml/2006/main" noGrp="1"/>
+          </p:cNvSpPr>
+          <p:nvPr/>
+        </p:nvSpPr>
+        <p:spPr>
+          <a:xfrm xmlns:a="http://schemas.openxmlformats.org/drawingml/2006/main">
+            <a:off x="4476750" y="4848225"/>
+            <a:ext cx="7029450" cy="895350"/>
+          </a:xfrm>
+          <a:prstGeom xmlns:a="http://schemas.openxmlformats.org/drawingml/2006/main" prst="rect">
+            <a:avLst/>
+          </a:prstGeom>
+          <a:noFill xmlns:a="http://schemas.openxmlformats.org/drawingml/2006/main"/>
+          <a:ln xmlns:a="http://schemas.openxmlformats.org/drawingml/2006/main" w="0">
+            <a:noFill/>
+          </a:ln>
+        </p:spPr>
+        <p:txBody>
+          <a:bodyPr xmlns:a="http://schemas.openxmlformats.org/drawingml/2006/main" wrap="square" lIns="0" tIns="0" rIns="0" bIns="0" anchor="t">
+            <a:noAutofit/>
+          </a:bodyPr>
+          <a:lstStyle xmlns:a="http://schemas.openxmlformats.org/drawingml/2006/main"/>
+          <a:p xmlns:a="http://schemas.openxmlformats.org/drawingml/2006/main">
+            <a:pPr algn="l">
+              <a:defRPr sz="2175" b="0">
+                <a:solidFill>
+                  <a:srgbClr val="17343C"/>
+                </a:solidFill>
+                <a:latin typeface="Arial"/>
+                <a:ea typeface="Arial"/>
+                <a:cs typeface="Arial"/>
+              </a:defRPr>
+            </a:pPr>
+            <a:r>
+              <a:rPr sz="2175" b="0">
+                <a:solidFill>
+                  <a:srgbClr val="17343C"/>
+                </a:solidFill>
+                <a:latin typeface="Arial"/>
+                <a:ea typeface="Arial"/>
+                <a:cs typeface="Arial"/>
+              </a:rPr>
+              <a:t>Keep entered data and offer keyword</a:t>
+            </a:r>
+          </a:p>
+          <a:p xmlns:a="http://schemas.openxmlformats.org/drawingml/2006/main">
+            <a:pPr algn="l">
+              <a:defRPr sz="2175" b="0">
+                <a:solidFill>
+                  <a:srgbClr val="17343C"/>
+                </a:solidFill>
+                <a:latin typeface="Arial"/>
+                <a:ea typeface="Arial"/>
+                <a:cs typeface="Arial"/>
+              </a:defRPr>
+            </a:pPr>
+            <a:r>
+              <a:rPr sz="2175" b="0">
+                <a:solidFill>
+                  <a:srgbClr val="17343C"/>
+                </a:solidFill>
+                <a:latin typeface="Arial"/>
+                <a:ea typeface="Arial"/>
+                <a:cs typeface="Arial"/>
+              </a:rPr>
+              <a:t>search when AI is unavailable</a:t>
             </a:r>
           </a:p>
         </p:txBody>
@@ -3937,7 +4037,7 @@
     </p:spTree>
     <p:extLst>
       <p:ext uri="{BB962C8B-B14F-4D97-AF65-F5344CB8AC3E}">
-        <p14:creationId xmlns:p14="http://schemas.microsoft.com/office/powerpoint/2010/main" val="7067261"/>
+        <p14:creationId xmlns:p14="http://schemas.microsoft.com/office/powerpoint/2010/main" val="1253636544"/>
       </p:ext>
     </p:extLst>
   </p:cSld>
@@ -3965,10 +4065,10 @@
       </p:grpSpPr>
       <p:sp>
         <p:nvSpPr>
-          <p:cNvPr id="9" name="slide-title">
+          <p:cNvPr id="10" name="slide-title">
             <a:extLst xmlns:a="http://schemas.openxmlformats.org/drawingml/2006/main">
               <a:ext uri="{FF2B5EF4-FFF2-40B4-BE49-F238E27FC236}">
-                <a16:creationId xmlns:a16="http://schemas.microsoft.com/office/drawing/2014/main" id="{C89F975A-4A60-41A1-AC65-F1806053163C}"/>
+                <a16:creationId xmlns:a16="http://schemas.microsoft.com/office/drawing/2014/main" id="{C3C58017-2CC5-4889-A06E-1EB54E0C1BD2}"/>
               </a:ext>
             </a:extLst>
           </p:cNvPr>
@@ -4015,7 +4115,7 @@
                 <a:ea typeface="Arial"/>
                 <a:cs typeface="Arial"/>
               </a:rPr>
-              <a:t>Classic functions and AI support</a:t>
+              <a:t>How we will test our choices</a:t>
             </a:r>
           </a:p>
         </p:txBody>
@@ -4025,7 +4125,7 @@
           <p:cNvPr id="2" name="page-number">
             <a:extLst xmlns:a="http://schemas.openxmlformats.org/drawingml/2006/main">
               <a:ext uri="{FF2B5EF4-FFF2-40B4-BE49-F238E27FC236}">
-                <a16:creationId xmlns:a16="http://schemas.microsoft.com/office/drawing/2014/main" id="{CFC7C78F-842A-4170-81C8-FD7F4E930EA2}"/>
+                <a16:creationId xmlns:a16="http://schemas.microsoft.com/office/drawing/2014/main" id="{94871B75-4725-4F9A-B99D-E3373904B2E8}"/>
               </a:ext>
             </a:extLst>
           </p:cNvPr>
@@ -4079,10 +4179,10 @@
       </p:sp>
       <p:sp>
         <p:nvSpPr>
-          <p:cNvPr id="3" name="requirement-count">
+          <p:cNvPr id="3" name="prospective">
             <a:extLst xmlns:a="http://schemas.openxmlformats.org/drawingml/2006/main">
               <a:ext uri="{FF2B5EF4-FFF2-40B4-BE49-F238E27FC236}">
-                <a16:creationId xmlns:a16="http://schemas.microsoft.com/office/drawing/2014/main" id="{A596600E-33C2-486E-985C-D71307B55B51}"/>
+                <a16:creationId xmlns:a16="http://schemas.microsoft.com/office/drawing/2014/main" id="{9B96F55A-5D2B-4A8A-B01D-0E6FFD9E8EEB}"/>
               </a:ext>
             </a:extLst>
           </p:cNvPr>
@@ -4093,8 +4193,8 @@
         </p:nvSpPr>
         <p:spPr>
           <a:xfrm xmlns:a="http://schemas.openxmlformats.org/drawingml/2006/main">
-            <a:off x="685800" y="1428750"/>
-            <a:ext cx="10820400" cy="628650"/>
+            <a:off x="685800" y="1438275"/>
+            <a:ext cx="10820400" cy="590550"/>
           </a:xfrm>
           <a:prstGeom xmlns:a="http://schemas.openxmlformats.org/drawingml/2006/main" prst="rect">
             <a:avLst/>
@@ -4111,7 +4211,7 @@
           <a:lstStyle xmlns:a="http://schemas.openxmlformats.org/drawingml/2006/main"/>
           <a:p xmlns:a="http://schemas.openxmlformats.org/drawingml/2006/main">
             <a:pPr algn="l">
-              <a:defRPr sz="2100" b="0">
+              <a:defRPr sz="2025" b="0">
                 <a:solidFill>
                   <a:srgbClr val="536466"/>
                 </a:solidFill>
@@ -4121,7 +4221,7 @@
               </a:defRPr>
             </a:pPr>
             <a:r>
-              <a:rPr sz="2100" b="0">
+              <a:rPr sz="2025" b="0">
                 <a:solidFill>
                   <a:srgbClr val="536466"/>
                 </a:solidFill>
@@ -4129,17 +4229,17 @@
                 <a:ea typeface="Arial"/>
                 <a:cs typeface="Arial"/>
               </a:rPr>
-              <a:t>52 initial requirements across functions, AI, sustainability and quality</a:t>
-            </a:r>
-          </a:p>
-        </p:txBody>
-      </p:sp>
-      <p:sp>
-        <p:nvSpPr>
-          <p:cNvPr id="4" name="classic-title">
+              <a:t>Proposed evaluation using the same data and eligibility filters</a:t>
+            </a:r>
+          </a:p>
+        </p:txBody>
+      </p:sp>
+      <p:sp>
+        <p:nvSpPr>
+          <p:cNvPr id="4" name="request-count">
             <a:extLst xmlns:a="http://schemas.openxmlformats.org/drawingml/2006/main">
               <a:ext uri="{FF2B5EF4-FFF2-40B4-BE49-F238E27FC236}">
-                <a16:creationId xmlns:a16="http://schemas.microsoft.com/office/drawing/2014/main" id="{7DFBC914-D124-4696-B3C7-98273C6EB06E}"/>
+                <a16:creationId xmlns:a16="http://schemas.microsoft.com/office/drawing/2014/main" id="{E5D8192C-9E97-4B02-BEBA-5738ECB3A47C}"/>
               </a:ext>
             </a:extLst>
           </p:cNvPr>
@@ -4150,8 +4250,8 @@
         </p:nvSpPr>
         <p:spPr>
           <a:xfrm xmlns:a="http://schemas.openxmlformats.org/drawingml/2006/main">
-            <a:off x="685800" y="2457450"/>
-            <a:ext cx="4953000" cy="495300"/>
+            <a:off x="685800" y="2505075"/>
+            <a:ext cx="5372100" cy="819150"/>
           </a:xfrm>
           <a:prstGeom xmlns:a="http://schemas.openxmlformats.org/drawingml/2006/main" prst="rect">
             <a:avLst/>
@@ -4168,7 +4268,7 @@
           <a:lstStyle xmlns:a="http://schemas.openxmlformats.org/drawingml/2006/main"/>
           <a:p xmlns:a="http://schemas.openxmlformats.org/drawingml/2006/main">
             <a:pPr algn="l">
-              <a:defRPr sz="2550" b="1">
+              <a:defRPr sz="3825" b="1">
                 <a:solidFill>
                   <a:srgbClr val="26746D"/>
                 </a:solidFill>
@@ -4178,7 +4278,7 @@
               </a:defRPr>
             </a:pPr>
             <a:r>
-              <a:rPr sz="2550" b="1">
+              <a:rPr sz="3825" b="1">
                 <a:solidFill>
                   <a:srgbClr val="26746D"/>
                 </a:solidFill>
@@ -4186,17 +4286,17 @@
                 <a:ea typeface="Arial"/>
                 <a:cs typeface="Arial"/>
               </a:rPr>
-              <a:t>Classic functions</a:t>
-            </a:r>
-          </a:p>
-        </p:txBody>
-      </p:sp>
-      <p:sp>
-        <p:nvSpPr>
-          <p:cNvPr id="5" name="classic-body">
+              <a:t>20 fixed requests</a:t>
+            </a:r>
+          </a:p>
+        </p:txBody>
+      </p:sp>
+      <p:sp>
+        <p:nvSpPr>
+          <p:cNvPr id="5" name="labels">
             <a:extLst xmlns:a="http://schemas.openxmlformats.org/drawingml/2006/main">
               <a:ext uri="{FF2B5EF4-FFF2-40B4-BE49-F238E27FC236}">
-                <a16:creationId xmlns:a16="http://schemas.microsoft.com/office/drawing/2014/main" id="{24C28C5F-0ED1-47D3-B426-77D2DE51F6CA}"/>
+                <a16:creationId xmlns:a16="http://schemas.microsoft.com/office/drawing/2014/main" id="{E3B64788-5343-4E92-B6E1-733B2110DDDB}"/>
               </a:ext>
             </a:extLst>
           </p:cNvPr>
@@ -4207,8 +4307,8 @@
         </p:nvSpPr>
         <p:spPr>
           <a:xfrm xmlns:a="http://schemas.openxmlformats.org/drawingml/2006/main">
-            <a:off x="685800" y="3181350"/>
-            <a:ext cx="4933950" cy="1800225"/>
+            <a:off x="685800" y="3648075"/>
+            <a:ext cx="5238750" cy="1019175"/>
           </a:xfrm>
           <a:prstGeom xmlns:a="http://schemas.openxmlformats.org/drawingml/2006/main" prst="rect">
             <a:avLst/>
@@ -4225,81 +4325,58 @@
           <a:lstStyle xmlns:a="http://schemas.openxmlformats.org/drawingml/2006/main"/>
           <a:p xmlns:a="http://schemas.openxmlformats.org/drawingml/2006/main">
             <a:pPr algn="l">
-              <a:defRPr sz="2325" b="0">
-                <a:solidFill>
-                  <a:srgbClr val="17343C"/>
-                </a:solidFill>
-                <a:latin typeface="Arial"/>
-                <a:ea typeface="Arial"/>
-                <a:cs typeface="Arial"/>
-              </a:defRPr>
-            </a:pPr>
-            <a:r>
-              <a:rPr sz="2325" b="0">
-                <a:solidFill>
-                  <a:srgbClr val="17343C"/>
-                </a:solidFill>
-                <a:latin typeface="Arial"/>
-                <a:ea typeface="Arial"/>
-                <a:cs typeface="Arial"/>
-              </a:rPr>
-              <a:t>Asset records and availability</a:t>
-            </a:r>
-          </a:p>
-          <a:p xmlns:a="http://schemas.openxmlformats.org/drawingml/2006/main">
-            <a:pPr algn="l">
-              <a:defRPr sz="2325" b="0">
-                <a:solidFill>
-                  <a:srgbClr val="17343C"/>
-                </a:solidFill>
-                <a:latin typeface="Arial"/>
-                <a:ea typeface="Arial"/>
-                <a:cs typeface="Arial"/>
-              </a:defRPr>
-            </a:pPr>
-            <a:r>
-              <a:rPr sz="2325" b="0">
-                <a:solidFill>
-                  <a:srgbClr val="17343C"/>
-                </a:solidFill>
-                <a:latin typeface="Arial"/>
-                <a:ea typeface="Arial"/>
-                <a:cs typeface="Arial"/>
-              </a:rPr>
-              <a:t>Permissions and approvals</a:t>
-            </a:r>
-          </a:p>
-          <a:p xmlns:a="http://schemas.openxmlformats.org/drawingml/2006/main">
-            <a:pPr algn="l">
-              <a:defRPr sz="2325" b="0">
-                <a:solidFill>
-                  <a:srgbClr val="17343C"/>
-                </a:solidFill>
-                <a:latin typeface="Arial"/>
-                <a:ea typeface="Arial"/>
-                <a:cs typeface="Arial"/>
-              </a:defRPr>
-            </a:pPr>
-            <a:r>
-              <a:rPr sz="2325" b="0">
-                <a:solidFill>
-                  <a:srgbClr val="17343C"/>
-                </a:solidFill>
-                <a:latin typeface="Arial"/>
-                <a:ea typeface="Arial"/>
-                <a:cs typeface="Arial"/>
-              </a:rPr>
-              <a:t>Transfers and maintenance</a:t>
-            </a:r>
-          </a:p>
-        </p:txBody>
-      </p:sp>
-      <p:sp>
-        <p:nvSpPr>
-          <p:cNvPr id="6" name="ai-title">
+              <a:defRPr sz="2175" b="0">
+                <a:solidFill>
+                  <a:srgbClr val="17343C"/>
+                </a:solidFill>
+                <a:latin typeface="Arial"/>
+                <a:ea typeface="Arial"/>
+                <a:cs typeface="Arial"/>
+              </a:defRPr>
+            </a:pPr>
+            <a:r>
+              <a:rPr sz="2175" b="0">
+                <a:solidFill>
+                  <a:srgbClr val="17343C"/>
+                </a:solidFill>
+                <a:latin typeface="Arial"/>
+                <a:ea typeface="Arial"/>
+                <a:cs typeface="Arial"/>
+              </a:rPr>
+              <a:t>Two teammates independently label</a:t>
+            </a:r>
+          </a:p>
+          <a:p xmlns:a="http://schemas.openxmlformats.org/drawingml/2006/main">
+            <a:pPr algn="l">
+              <a:defRPr sz="2175" b="0">
+                <a:solidFill>
+                  <a:srgbClr val="17343C"/>
+                </a:solidFill>
+                <a:latin typeface="Arial"/>
+                <a:ea typeface="Arial"/>
+                <a:cs typeface="Arial"/>
+              </a:defRPr>
+            </a:pPr>
+            <a:r>
+              <a:rPr sz="2175" b="0">
+                <a:solidFill>
+                  <a:srgbClr val="17343C"/>
+                </a:solidFill>
+                <a:latin typeface="Arial"/>
+                <a:ea typeface="Arial"/>
+                <a:cs typeface="Arial"/>
+              </a:rPr>
+              <a:t>which assets are useful</a:t>
+            </a:r>
+          </a:p>
+        </p:txBody>
+      </p:sp>
+      <p:sp>
+        <p:nvSpPr>
+          <p:cNvPr id="6" name="target">
             <a:extLst xmlns:a="http://schemas.openxmlformats.org/drawingml/2006/main">
               <a:ext uri="{FF2B5EF4-FFF2-40B4-BE49-F238E27FC236}">
-                <a16:creationId xmlns:a16="http://schemas.microsoft.com/office/drawing/2014/main" id="{94FBB2E7-4023-40E7-A020-AC8294136650}"/>
+                <a16:creationId xmlns:a16="http://schemas.microsoft.com/office/drawing/2014/main" id="{69D91FB2-3127-4E02-8510-B08244BCDD3B}"/>
               </a:ext>
             </a:extLst>
           </p:cNvPr>
@@ -4310,8 +4387,8 @@
         </p:nvSpPr>
         <p:spPr>
           <a:xfrm xmlns:a="http://schemas.openxmlformats.org/drawingml/2006/main">
-            <a:off x="6572250" y="2457450"/>
-            <a:ext cx="4933950" cy="495300"/>
+            <a:off x="6705600" y="2505075"/>
+            <a:ext cx="4800600" cy="819150"/>
           </a:xfrm>
           <a:prstGeom xmlns:a="http://schemas.openxmlformats.org/drawingml/2006/main" prst="rect">
             <a:avLst/>
@@ -4328,7 +4405,7 @@
           <a:lstStyle xmlns:a="http://schemas.openxmlformats.org/drawingml/2006/main"/>
           <a:p xmlns:a="http://schemas.openxmlformats.org/drawingml/2006/main">
             <a:pPr algn="l">
-              <a:defRPr sz="2550" b="1">
+              <a:defRPr sz="4800" b="1">
                 <a:solidFill>
                   <a:srgbClr val="26746D"/>
                 </a:solidFill>
@@ -4338,7 +4415,7 @@
               </a:defRPr>
             </a:pPr>
             <a:r>
-              <a:rPr sz="2550" b="1">
+              <a:rPr sz="4800" b="1">
                 <a:solidFill>
                   <a:srgbClr val="26746D"/>
                 </a:solidFill>
@@ -4346,17 +4423,17 @@
                 <a:ea typeface="Arial"/>
                 <a:cs typeface="Arial"/>
               </a:rPr>
-              <a:t>AI support</a:t>
-            </a:r>
-          </a:p>
-        </p:txBody>
-      </p:sp>
-      <p:sp>
-        <p:nvSpPr>
-          <p:cNvPr id="7" name="ai-body">
+              <a:t>16 / 20</a:t>
+            </a:r>
+          </a:p>
+        </p:txBody>
+      </p:sp>
+      <p:sp>
+        <p:nvSpPr>
+          <p:cNvPr id="7" name="target-label">
             <a:extLst xmlns:a="http://schemas.openxmlformats.org/drawingml/2006/main">
               <a:ext uri="{FF2B5EF4-FFF2-40B4-BE49-F238E27FC236}">
-                <a16:creationId xmlns:a16="http://schemas.microsoft.com/office/drawing/2014/main" id="{2553C608-5105-4B37-9EBD-1AEE17931BD3}"/>
+                <a16:creationId xmlns:a16="http://schemas.microsoft.com/office/drawing/2014/main" id="{494F7188-014C-4D65-8A5B-676363F69C2F}"/>
               </a:ext>
             </a:extLst>
           </p:cNvPr>
@@ -4367,8 +4444,8 @@
         </p:nvSpPr>
         <p:spPr>
           <a:xfrm xmlns:a="http://schemas.openxmlformats.org/drawingml/2006/main">
-            <a:off x="6572250" y="3181350"/>
-            <a:ext cx="4933950" cy="1800225"/>
+            <a:off x="6705600" y="3648075"/>
+            <a:ext cx="4800600" cy="1000125"/>
           </a:xfrm>
           <a:prstGeom xmlns:a="http://schemas.openxmlformats.org/drawingml/2006/main" prst="rect">
             <a:avLst/>
@@ -4385,81 +4462,58 @@
           <a:lstStyle xmlns:a="http://schemas.openxmlformats.org/drawingml/2006/main"/>
           <a:p xmlns:a="http://schemas.openxmlformats.org/drawingml/2006/main">
             <a:pPr algn="l">
-              <a:defRPr sz="2325" b="0">
-                <a:solidFill>
-                  <a:srgbClr val="17343C"/>
-                </a:solidFill>
-                <a:latin typeface="Arial"/>
-                <a:ea typeface="Arial"/>
-                <a:cs typeface="Arial"/>
-              </a:defRPr>
-            </a:pPr>
-            <a:r>
-              <a:rPr sz="2325" b="0">
-                <a:solidFill>
-                  <a:srgbClr val="17343C"/>
-                </a:solidFill>
-                <a:latin typeface="Arial"/>
-                <a:ea typeface="Arial"/>
-                <a:cs typeface="Arial"/>
-              </a:rPr>
-              <a:t>Suggest asset categories</a:t>
-            </a:r>
-          </a:p>
-          <a:p xmlns:a="http://schemas.openxmlformats.org/drawingml/2006/main">
-            <a:pPr algn="l">
-              <a:defRPr sz="2325" b="0">
-                <a:solidFill>
-                  <a:srgbClr val="17343C"/>
-                </a:solidFill>
-                <a:latin typeface="Arial"/>
-                <a:ea typeface="Arial"/>
-                <a:cs typeface="Arial"/>
-              </a:defRPr>
-            </a:pPr>
-            <a:r>
-              <a:rPr sz="2325" b="0">
-                <a:solidFill>
-                  <a:srgbClr val="17343C"/>
-                </a:solidFill>
-                <a:latin typeface="Arial"/>
-                <a:ea typeface="Arial"/>
-                <a:cs typeface="Arial"/>
-              </a:rPr>
-              <a:t>Rank and explain matches</a:t>
-            </a:r>
-          </a:p>
-          <a:p xmlns:a="http://schemas.openxmlformats.org/drawingml/2006/main">
-            <a:pPr algn="l">
-              <a:defRPr sz="2325" b="0">
-                <a:solidFill>
-                  <a:srgbClr val="17343C"/>
-                </a:solidFill>
-                <a:latin typeface="Arial"/>
-                <a:ea typeface="Arial"/>
-                <a:cs typeface="Arial"/>
-              </a:defRPr>
-            </a:pPr>
-            <a:r>
-              <a:rPr sz="2325" b="0">
-                <a:solidFill>
-                  <a:srgbClr val="17343C"/>
-                </a:solidFill>
-                <a:latin typeface="Arial"/>
-                <a:ea typeface="Arial"/>
-                <a:cs typeface="Arial"/>
-              </a:rPr>
-              <a:t>Draft reports and summaries</a:t>
-            </a:r>
-          </a:p>
-        </p:txBody>
-      </p:sp>
-      <p:sp>
-        <p:nvSpPr>
-          <p:cNvPr id="8" name="human-control">
+              <a:defRPr sz="2175" b="0">
+                <a:solidFill>
+                  <a:srgbClr val="17343C"/>
+                </a:solidFill>
+                <a:latin typeface="Arial"/>
+                <a:ea typeface="Arial"/>
+                <a:cs typeface="Arial"/>
+              </a:defRPr>
+            </a:pPr>
+            <a:r>
+              <a:rPr sz="2175" b="0">
+                <a:solidFill>
+                  <a:srgbClr val="17343C"/>
+                </a:solidFill>
+                <a:latin typeface="Arial"/>
+                <a:ea typeface="Arial"/>
+                <a:cs typeface="Arial"/>
+              </a:rPr>
+              <a:t>Requests with a useful item</a:t>
+            </a:r>
+          </a:p>
+          <a:p xmlns:a="http://schemas.openxmlformats.org/drawingml/2006/main">
+            <a:pPr algn="l">
+              <a:defRPr sz="2175" b="0">
+                <a:solidFill>
+                  <a:srgbClr val="17343C"/>
+                </a:solidFill>
+                <a:latin typeface="Arial"/>
+                <a:ea typeface="Arial"/>
+                <a:cs typeface="Arial"/>
+              </a:defRPr>
+            </a:pPr>
+            <a:r>
+              <a:rPr sz="2175" b="0">
+                <a:solidFill>
+                  <a:srgbClr val="17343C"/>
+                </a:solidFill>
+                <a:latin typeface="Arial"/>
+                <a:ea typeface="Arial"/>
+                <a:cs typeface="Arial"/>
+              </a:rPr>
+              <a:t>in the top three AI results</a:t>
+            </a:r>
+          </a:p>
+        </p:txBody>
+      </p:sp>
+      <p:sp>
+        <p:nvSpPr>
+          <p:cNvPr id="8" name="comparison">
             <a:extLst xmlns:a="http://schemas.openxmlformats.org/drawingml/2006/main">
               <a:ext uri="{FF2B5EF4-FFF2-40B4-BE49-F238E27FC236}">
-                <a16:creationId xmlns:a16="http://schemas.microsoft.com/office/drawing/2014/main" id="{DE12F894-3242-481B-BB1C-1D231A627A4F}"/>
+                <a16:creationId xmlns:a16="http://schemas.microsoft.com/office/drawing/2014/main" id="{4EB1BD53-6DA2-4F2D-A9F0-9799DA6E0E67}"/>
               </a:ext>
             </a:extLst>
           </p:cNvPr>
@@ -4470,8 +4524,8 @@
         </p:nvSpPr>
         <p:spPr>
           <a:xfrm xmlns:a="http://schemas.openxmlformats.org/drawingml/2006/main">
-            <a:off x="685800" y="5505450"/>
-            <a:ext cx="10820400" cy="514350"/>
+            <a:off x="685800" y="5048250"/>
+            <a:ext cx="10820400" cy="685800"/>
           </a:xfrm>
           <a:prstGeom xmlns:a="http://schemas.openxmlformats.org/drawingml/2006/main" prst="rect">
             <a:avLst/>
@@ -4488,25 +4542,105 @@
           <a:lstStyle xmlns:a="http://schemas.openxmlformats.org/drawingml/2006/main"/>
           <a:p xmlns:a="http://schemas.openxmlformats.org/drawingml/2006/main">
             <a:pPr algn="l">
-              <a:defRPr sz="2550" b="1">
-                <a:solidFill>
-                  <a:srgbClr val="17343C"/>
-                </a:solidFill>
-                <a:latin typeface="Arial"/>
-                <a:ea typeface="Arial"/>
-                <a:cs typeface="Arial"/>
-              </a:defRPr>
-            </a:pPr>
-            <a:r>
-              <a:rPr sz="2550" b="1">
-                <a:solidFill>
-                  <a:srgbClr val="17343C"/>
-                </a:solidFill>
-                <a:latin typeface="Arial"/>
-                <a:ea typeface="Arial"/>
-                <a:cs typeface="Arial"/>
-              </a:rPr>
-              <a:t>AI recommends. Authorised people approve.</a:t>
+              <a:defRPr sz="2250" b="1">
+                <a:solidFill>
+                  <a:srgbClr val="17343C"/>
+                </a:solidFill>
+                <a:latin typeface="Arial"/>
+                <a:ea typeface="Arial"/>
+                <a:cs typeface="Arial"/>
+              </a:defRPr>
+            </a:pPr>
+            <a:r>
+              <a:rPr sz="2250" b="1">
+                <a:solidFill>
+                  <a:srgbClr val="17343C"/>
+                </a:solidFill>
+                <a:latin typeface="Arial"/>
+                <a:ea typeface="Arial"/>
+                <a:cs typeface="Arial"/>
+              </a:rPr>
+              <a:t>Target: at least 2 more successful requests than keyword search</a:t>
+            </a:r>
+          </a:p>
+        </p:txBody>
+      </p:sp>
+      <p:sp>
+        <p:nvSpPr>
+          <p:cNvPr id="9" name="other-checks">
+            <a:extLst xmlns:a="http://schemas.openxmlformats.org/drawingml/2006/main">
+              <a:ext uri="{FF2B5EF4-FFF2-40B4-BE49-F238E27FC236}">
+                <a16:creationId xmlns:a16="http://schemas.microsoft.com/office/drawing/2014/main" id="{A5844155-C95E-4172-8D55-A3359C113C6F}"/>
+              </a:ext>
+            </a:extLst>
+          </p:cNvPr>
+          <p:cNvSpPr>
+            <a:spLocks xmlns:a="http://schemas.openxmlformats.org/drawingml/2006/main" noGrp="1"/>
+          </p:cNvSpPr>
+          <p:nvPr/>
+        </p:nvSpPr>
+        <p:spPr>
+          <a:xfrm xmlns:a="http://schemas.openxmlformats.org/drawingml/2006/main">
+            <a:off x="685800" y="5886450"/>
+            <a:ext cx="10820400" cy="638175"/>
+          </a:xfrm>
+          <a:prstGeom xmlns:a="http://schemas.openxmlformats.org/drawingml/2006/main" prst="rect">
+            <a:avLst/>
+          </a:prstGeom>
+          <a:noFill xmlns:a="http://schemas.openxmlformats.org/drawingml/2006/main"/>
+          <a:ln xmlns:a="http://schemas.openxmlformats.org/drawingml/2006/main" w="0">
+            <a:noFill/>
+          </a:ln>
+        </p:spPr>
+        <p:txBody>
+          <a:bodyPr xmlns:a="http://schemas.openxmlformats.org/drawingml/2006/main" wrap="square" lIns="0" tIns="0" rIns="0" bIns="0" anchor="t">
+            <a:noAutofit/>
+          </a:bodyPr>
+          <a:lstStyle xmlns:a="http://schemas.openxmlformats.org/drawingml/2006/main"/>
+          <a:p xmlns:a="http://schemas.openxmlformats.org/drawingml/2006/main">
+            <a:pPr algn="l">
+              <a:defRPr sz="1725" b="0">
+                <a:solidFill>
+                  <a:srgbClr val="536466"/>
+                </a:solidFill>
+                <a:latin typeface="Arial"/>
+                <a:ea typeface="Arial"/>
+                <a:cs typeface="Arial"/>
+              </a:defRPr>
+            </a:pPr>
+            <a:r>
+              <a:rPr sz="1725" b="0">
+                <a:solidFill>
+                  <a:srgbClr val="536466"/>
+                </a:solidFill>
+                <a:latin typeface="Arial"/>
+                <a:ea typeface="Arial"/>
+                <a:cs typeface="Arial"/>
+              </a:rPr>
+              <a:t>Also test approvals, simultaneous reservations, sustainability calculations</a:t>
+            </a:r>
+          </a:p>
+          <a:p xmlns:a="http://schemas.openxmlformats.org/drawingml/2006/main">
+            <a:pPr algn="l">
+              <a:defRPr sz="1725" b="0">
+                <a:solidFill>
+                  <a:srgbClr val="536466"/>
+                </a:solidFill>
+                <a:latin typeface="Arial"/>
+                <a:ea typeface="Arial"/>
+                <a:cs typeface="Arial"/>
+              </a:defRPr>
+            </a:pPr>
+            <a:r>
+              <a:rPr sz="1725" b="0">
+                <a:solidFill>
+                  <a:srgbClr val="536466"/>
+                </a:solidFill>
+                <a:latin typeface="Arial"/>
+                <a:ea typeface="Arial"/>
+                <a:cs typeface="Arial"/>
+              </a:rPr>
+              <a:t>and a fresh deployment with AI fallback</a:t>
             </a:r>
           </a:p>
         </p:txBody>
@@ -4514,7 +4648,7 @@
     </p:spTree>
     <p:extLst>
       <p:ext uri="{BB962C8B-B14F-4D97-AF65-F5344CB8AC3E}">
-        <p14:creationId xmlns:p14="http://schemas.microsoft.com/office/powerpoint/2010/main" val="149734839"/>
+        <p14:creationId xmlns:p14="http://schemas.microsoft.com/office/powerpoint/2010/main" val="193387989"/>
       </p:ext>
     </p:extLst>
   </p:cSld>
@@ -4542,10 +4676,10 @@
       </p:grpSpPr>
       <p:sp>
         <p:nvSpPr>
-          <p:cNvPr id="14" name="slide-title">
+          <p:cNvPr id="7" name="slide-title">
             <a:extLst xmlns:a="http://schemas.openxmlformats.org/drawingml/2006/main">
               <a:ext uri="{FF2B5EF4-FFF2-40B4-BE49-F238E27FC236}">
-                <a16:creationId xmlns:a16="http://schemas.microsoft.com/office/drawing/2014/main" id="{C594320D-9A7E-4306-B4A6-3A12DA96647B}"/>
+                <a16:creationId xmlns:a16="http://schemas.microsoft.com/office/drawing/2014/main" id="{5BE6869A-2D16-4A55-AB3D-68965EA1F107}"/>
               </a:ext>
             </a:extLst>
           </p:cNvPr>
@@ -4592,7 +4726,7 @@
                 <a:ea typeface="Arial"/>
                 <a:cs typeface="Arial"/>
               </a:rPr>
-              <a:t>Proposed success targets</a:t>
+              <a:t>Next: feasibility and delivery</a:t>
             </a:r>
           </a:p>
         </p:txBody>
@@ -4602,7 +4736,7 @@
           <p:cNvPr id="2" name="page-number">
             <a:extLst xmlns:a="http://schemas.openxmlformats.org/drawingml/2006/main">
               <a:ext uri="{FF2B5EF4-FFF2-40B4-BE49-F238E27FC236}">
-                <a16:creationId xmlns:a16="http://schemas.microsoft.com/office/drawing/2014/main" id="{6641AF2F-E8F9-4D76-8B4A-0DE40FA3A2AF}"/>
+                <a16:creationId xmlns:a16="http://schemas.microsoft.com/office/drawing/2014/main" id="{2326091A-4A5F-46E2-9B36-F64F084A4FDF}"/>
               </a:ext>
             </a:extLst>
           </p:cNvPr>
@@ -4656,10 +4790,10 @@
       </p:sp>
       <p:sp>
         <p:nvSpPr>
-          <p:cNvPr id="3" name="test-context">
+          <p:cNvPr id="3" name="next-goal">
             <a:extLst xmlns:a="http://schemas.openxmlformats.org/drawingml/2006/main">
               <a:ext uri="{FF2B5EF4-FFF2-40B4-BE49-F238E27FC236}">
-                <a16:creationId xmlns:a16="http://schemas.microsoft.com/office/drawing/2014/main" id="{2DE294C6-2F58-4FF9-87B6-A536462D8827}"/>
+                <a16:creationId xmlns:a16="http://schemas.microsoft.com/office/drawing/2014/main" id="{76AD6C66-A989-4E7E-BC68-A0BDEA85DE91}"/>
               </a:ext>
             </a:extLst>
           </p:cNvPr>
@@ -4671,7 +4805,7 @@
         <p:spPr>
           <a:xfrm xmlns:a="http://schemas.openxmlformats.org/drawingml/2006/main">
             <a:off x="685800" y="1438275"/>
-            <a:ext cx="10820400" cy="476250"/>
+            <a:ext cx="10820400" cy="666750"/>
           </a:xfrm>
           <a:prstGeom xmlns:a="http://schemas.openxmlformats.org/drawingml/2006/main" prst="rect">
             <a:avLst/>
@@ -4706,815 +4840,33 @@
                 <a:ea typeface="Arial"/>
                 <a:cs typeface="Arial"/>
               </a:rPr>
-              <a:t>Prototype evaluation using synthetic data</a:t>
-            </a:r>
-          </a:p>
-        </p:txBody>
-      </p:sp>
-      <p:sp>
-        <p:nvSpPr>
-          <p:cNvPr id="4" name="metric-0">
-            <a:extLst xmlns:a="http://schemas.openxmlformats.org/drawingml/2006/main">
-              <a:ext uri="{FF2B5EF4-FFF2-40B4-BE49-F238E27FC236}">
-                <a16:creationId xmlns:a16="http://schemas.microsoft.com/office/drawing/2014/main" id="{381EF58F-63CA-4A22-BF0D-80374C030211}"/>
-              </a:ext>
-            </a:extLst>
-          </p:cNvPr>
-          <p:cNvSpPr>
-            <a:spLocks xmlns:a="http://schemas.openxmlformats.org/drawingml/2006/main" noGrp="1"/>
-          </p:cNvSpPr>
-          <p:nvPr/>
-        </p:nvSpPr>
-        <p:spPr>
-          <a:xfrm xmlns:a="http://schemas.openxmlformats.org/drawingml/2006/main">
-            <a:off x="685800" y="2514600"/>
-            <a:ext cx="3333750" cy="952500"/>
-          </a:xfrm>
-          <a:prstGeom xmlns:a="http://schemas.openxmlformats.org/drawingml/2006/main" prst="rect">
-            <a:avLst/>
-          </a:prstGeom>
-          <a:noFill xmlns:a="http://schemas.openxmlformats.org/drawingml/2006/main"/>
-          <a:ln xmlns:a="http://schemas.openxmlformats.org/drawingml/2006/main" w="0">
-            <a:noFill/>
-          </a:ln>
-        </p:spPr>
-        <p:txBody>
-          <a:bodyPr xmlns:a="http://schemas.openxmlformats.org/drawingml/2006/main" wrap="square" lIns="0" tIns="0" rIns="0" bIns="0" anchor="t">
-            <a:noAutofit/>
-          </a:bodyPr>
-          <a:lstStyle xmlns:a="http://schemas.openxmlformats.org/drawingml/2006/main"/>
-          <a:p xmlns:a="http://schemas.openxmlformats.org/drawingml/2006/main">
-            <a:pPr algn="l">
-              <a:defRPr sz="4875" b="1">
-                <a:solidFill>
-                  <a:srgbClr val="26746D"/>
-                </a:solidFill>
-                <a:latin typeface="Arial"/>
-                <a:ea typeface="Arial"/>
-                <a:cs typeface="Arial"/>
-              </a:defRPr>
-            </a:pPr>
-            <a:r>
-              <a:rPr sz="4875" b="1">
-                <a:solidFill>
-                  <a:srgbClr val="26746D"/>
-                </a:solidFill>
-                <a:latin typeface="Arial"/>
-                <a:ea typeface="Arial"/>
-                <a:cs typeface="Arial"/>
-              </a:rPr>
-              <a:t>16 / 20</a:t>
-            </a:r>
-          </a:p>
-        </p:txBody>
-      </p:sp>
-      <p:sp>
-        <p:nvSpPr>
-          <p:cNvPr id="5" name="metric-label-0">
-            <a:extLst xmlns:a="http://schemas.openxmlformats.org/drawingml/2006/main">
-              <a:ext uri="{FF2B5EF4-FFF2-40B4-BE49-F238E27FC236}">
-                <a16:creationId xmlns:a16="http://schemas.microsoft.com/office/drawing/2014/main" id="{165CB1FF-3222-42A3-B0D0-705E4F893706}"/>
-              </a:ext>
-            </a:extLst>
-          </p:cNvPr>
-          <p:cNvSpPr>
-            <a:spLocks xmlns:a="http://schemas.openxmlformats.org/drawingml/2006/main" noGrp="1"/>
-          </p:cNvSpPr>
-          <p:nvPr/>
-        </p:nvSpPr>
-        <p:spPr>
-          <a:xfrm xmlns:a="http://schemas.openxmlformats.org/drawingml/2006/main">
-            <a:off x="685800" y="3667125"/>
-            <a:ext cx="3333750" cy="666750"/>
-          </a:xfrm>
-          <a:prstGeom xmlns:a="http://schemas.openxmlformats.org/drawingml/2006/main" prst="rect">
-            <a:avLst/>
-          </a:prstGeom>
-          <a:noFill xmlns:a="http://schemas.openxmlformats.org/drawingml/2006/main"/>
-          <a:ln xmlns:a="http://schemas.openxmlformats.org/drawingml/2006/main" w="0">
-            <a:noFill/>
-          </a:ln>
-        </p:spPr>
-        <p:txBody>
-          <a:bodyPr xmlns:a="http://schemas.openxmlformats.org/drawingml/2006/main" wrap="square" lIns="0" tIns="0" rIns="0" bIns="0" anchor="t">
-            <a:noAutofit/>
-          </a:bodyPr>
-          <a:lstStyle xmlns:a="http://schemas.openxmlformats.org/drawingml/2006/main"/>
-          <a:p xmlns:a="http://schemas.openxmlformats.org/drawingml/2006/main">
-            <a:pPr algn="l">
-              <a:defRPr sz="2100" b="1">
-                <a:solidFill>
-                  <a:srgbClr val="17343C"/>
-                </a:solidFill>
-                <a:latin typeface="Arial"/>
-                <a:ea typeface="Arial"/>
-                <a:cs typeface="Arial"/>
-              </a:defRPr>
-            </a:pPr>
-            <a:r>
-              <a:rPr sz="2100" b="1">
-                <a:solidFill>
-                  <a:srgbClr val="17343C"/>
-                </a:solidFill>
-                <a:latin typeface="Arial"/>
-                <a:ea typeface="Arial"/>
-                <a:cs typeface="Arial"/>
-              </a:rPr>
-              <a:t>Useful AI matches</a:t>
-            </a:r>
-          </a:p>
-        </p:txBody>
-      </p:sp>
-      <p:sp>
-        <p:nvSpPr>
-          <p:cNvPr id="6" name="metric-description-0">
-            <a:extLst xmlns:a="http://schemas.openxmlformats.org/drawingml/2006/main">
-              <a:ext uri="{FF2B5EF4-FFF2-40B4-BE49-F238E27FC236}">
-                <a16:creationId xmlns:a16="http://schemas.microsoft.com/office/drawing/2014/main" id="{7F6DF818-C90A-4255-B4BE-27D4943EFED0}"/>
-              </a:ext>
-            </a:extLst>
-          </p:cNvPr>
-          <p:cNvSpPr>
-            <a:spLocks xmlns:a="http://schemas.openxmlformats.org/drawingml/2006/main" noGrp="1"/>
-          </p:cNvSpPr>
-          <p:nvPr/>
-        </p:nvSpPr>
-        <p:spPr>
-          <a:xfrm xmlns:a="http://schemas.openxmlformats.org/drawingml/2006/main">
-            <a:off x="685800" y="4514850"/>
-            <a:ext cx="3333750" cy="1066800"/>
-          </a:xfrm>
-          <a:prstGeom xmlns:a="http://schemas.openxmlformats.org/drawingml/2006/main" prst="rect">
-            <a:avLst/>
-          </a:prstGeom>
-          <a:noFill xmlns:a="http://schemas.openxmlformats.org/drawingml/2006/main"/>
-          <a:ln xmlns:a="http://schemas.openxmlformats.org/drawingml/2006/main" w="0">
-            <a:noFill/>
-          </a:ln>
-        </p:spPr>
-        <p:txBody>
-          <a:bodyPr xmlns:a="http://schemas.openxmlformats.org/drawingml/2006/main" wrap="square" lIns="0" tIns="0" rIns="0" bIns="0" anchor="t">
-            <a:noAutofit/>
-          </a:bodyPr>
-          <a:lstStyle xmlns:a="http://schemas.openxmlformats.org/drawingml/2006/main"/>
-          <a:p xmlns:a="http://schemas.openxmlformats.org/drawingml/2006/main">
-            <a:pPr algn="l">
-              <a:defRPr sz="1725" b="0">
-                <a:solidFill>
-                  <a:srgbClr val="17343C"/>
-                </a:solidFill>
-                <a:latin typeface="Arial"/>
-                <a:ea typeface="Arial"/>
-                <a:cs typeface="Arial"/>
-              </a:defRPr>
-            </a:pPr>
-            <a:r>
-              <a:rPr sz="1725" b="0">
-                <a:solidFill>
-                  <a:srgbClr val="17343C"/>
-                </a:solidFill>
-                <a:latin typeface="Arial"/>
-                <a:ea typeface="Arial"/>
-                <a:cs typeface="Arial"/>
-              </a:rPr>
-              <a:t>A useful item in the top three</a:t>
-            </a:r>
-          </a:p>
-          <a:p xmlns:a="http://schemas.openxmlformats.org/drawingml/2006/main">
-            <a:pPr algn="l">
-              <a:defRPr sz="1725" b="0">
-                <a:solidFill>
-                  <a:srgbClr val="17343C"/>
-                </a:solidFill>
-                <a:latin typeface="Arial"/>
-                <a:ea typeface="Arial"/>
-                <a:cs typeface="Arial"/>
-              </a:defRPr>
-            </a:pPr>
-            <a:r>
-              <a:rPr sz="1725" b="0">
-                <a:solidFill>
-                  <a:srgbClr val="17343C"/>
-                </a:solidFill>
-                <a:latin typeface="Arial"/>
-                <a:ea typeface="Arial"/>
-                <a:cs typeface="Arial"/>
-              </a:rPr>
-              <a:t>for at least 16 of 20 requests</a:t>
-            </a:r>
-          </a:p>
-        </p:txBody>
-      </p:sp>
-      <p:sp>
-        <p:nvSpPr>
-          <p:cNvPr id="7" name="metric-1">
-            <a:extLst xmlns:a="http://schemas.openxmlformats.org/drawingml/2006/main">
-              <a:ext uri="{FF2B5EF4-FFF2-40B4-BE49-F238E27FC236}">
-                <a16:creationId xmlns:a16="http://schemas.microsoft.com/office/drawing/2014/main" id="{69F68D3A-9629-4881-B64E-1B11088F2088}"/>
-              </a:ext>
-            </a:extLst>
-          </p:cNvPr>
-          <p:cNvSpPr>
-            <a:spLocks xmlns:a="http://schemas.openxmlformats.org/drawingml/2006/main" noGrp="1"/>
-          </p:cNvSpPr>
-          <p:nvPr/>
-        </p:nvSpPr>
-        <p:spPr>
-          <a:xfrm xmlns:a="http://schemas.openxmlformats.org/drawingml/2006/main">
-            <a:off x="4429125" y="2514600"/>
-            <a:ext cx="3333750" cy="952500"/>
-          </a:xfrm>
-          <a:prstGeom xmlns:a="http://schemas.openxmlformats.org/drawingml/2006/main" prst="rect">
-            <a:avLst/>
-          </a:prstGeom>
-          <a:noFill xmlns:a="http://schemas.openxmlformats.org/drawingml/2006/main"/>
-          <a:ln xmlns:a="http://schemas.openxmlformats.org/drawingml/2006/main" w="0">
-            <a:noFill/>
-          </a:ln>
-        </p:spPr>
-        <p:txBody>
-          <a:bodyPr xmlns:a="http://schemas.openxmlformats.org/drawingml/2006/main" wrap="square" lIns="0" tIns="0" rIns="0" bIns="0" anchor="t">
-            <a:noAutofit/>
-          </a:bodyPr>
-          <a:lstStyle xmlns:a="http://schemas.openxmlformats.org/drawingml/2006/main"/>
-          <a:p xmlns:a="http://schemas.openxmlformats.org/drawingml/2006/main">
-            <a:pPr algn="l">
-              <a:defRPr sz="4875" b="1">
-                <a:solidFill>
-                  <a:srgbClr val="26746D"/>
-                </a:solidFill>
-                <a:latin typeface="Arial"/>
-                <a:ea typeface="Arial"/>
-                <a:cs typeface="Arial"/>
-              </a:defRPr>
-            </a:pPr>
-            <a:r>
-              <a:rPr sz="4875" b="1">
-                <a:solidFill>
-                  <a:srgbClr val="26746D"/>
-                </a:solidFill>
-                <a:latin typeface="Arial"/>
-                <a:ea typeface="Arial"/>
-                <a:cs typeface="Arial"/>
-              </a:rPr>
-              <a:t>4 / 5</a:t>
-            </a:r>
-          </a:p>
-        </p:txBody>
-      </p:sp>
-      <p:sp>
-        <p:nvSpPr>
-          <p:cNvPr id="8" name="metric-label-1">
-            <a:extLst xmlns:a="http://schemas.openxmlformats.org/drawingml/2006/main">
-              <a:ext uri="{FF2B5EF4-FFF2-40B4-BE49-F238E27FC236}">
-                <a16:creationId xmlns:a16="http://schemas.microsoft.com/office/drawing/2014/main" id="{18F3EC9C-23D9-43F3-A8B7-151E9706949D}"/>
-              </a:ext>
-            </a:extLst>
-          </p:cNvPr>
-          <p:cNvSpPr>
-            <a:spLocks xmlns:a="http://schemas.openxmlformats.org/drawingml/2006/main" noGrp="1"/>
-          </p:cNvSpPr>
-          <p:nvPr/>
-        </p:nvSpPr>
-        <p:spPr>
-          <a:xfrm xmlns:a="http://schemas.openxmlformats.org/drawingml/2006/main">
-            <a:off x="4429125" y="3667125"/>
-            <a:ext cx="3333750" cy="666750"/>
-          </a:xfrm>
-          <a:prstGeom xmlns:a="http://schemas.openxmlformats.org/drawingml/2006/main" prst="rect">
-            <a:avLst/>
-          </a:prstGeom>
-          <a:noFill xmlns:a="http://schemas.openxmlformats.org/drawingml/2006/main"/>
-          <a:ln xmlns:a="http://schemas.openxmlformats.org/drawingml/2006/main" w="0">
-            <a:noFill/>
-          </a:ln>
-        </p:spPr>
-        <p:txBody>
-          <a:bodyPr xmlns:a="http://schemas.openxmlformats.org/drawingml/2006/main" wrap="square" lIns="0" tIns="0" rIns="0" bIns="0" anchor="t">
-            <a:noAutofit/>
-          </a:bodyPr>
-          <a:lstStyle xmlns:a="http://schemas.openxmlformats.org/drawingml/2006/main"/>
-          <a:p xmlns:a="http://schemas.openxmlformats.org/drawingml/2006/main">
-            <a:pPr algn="l">
-              <a:defRPr sz="2100" b="1">
-                <a:solidFill>
-                  <a:srgbClr val="17343C"/>
-                </a:solidFill>
-                <a:latin typeface="Arial"/>
-                <a:ea typeface="Arial"/>
-                <a:cs typeface="Arial"/>
-              </a:defRPr>
-            </a:pPr>
-            <a:r>
-              <a:rPr sz="2100" b="1">
-                <a:solidFill>
-                  <a:srgbClr val="17343C"/>
-                </a:solidFill>
-                <a:latin typeface="Arial"/>
-                <a:ea typeface="Arial"/>
-                <a:cs typeface="Arial"/>
-              </a:rPr>
-              <a:t>Users complete tasks</a:t>
-            </a:r>
-          </a:p>
-        </p:txBody>
-      </p:sp>
-      <p:sp>
-        <p:nvSpPr>
-          <p:cNvPr id="9" name="metric-description-1">
-            <a:extLst xmlns:a="http://schemas.openxmlformats.org/drawingml/2006/main">
-              <a:ext uri="{FF2B5EF4-FFF2-40B4-BE49-F238E27FC236}">
-                <a16:creationId xmlns:a16="http://schemas.microsoft.com/office/drawing/2014/main" id="{5D9A180A-A043-44B1-90CB-36B5D21EB20A}"/>
-              </a:ext>
-            </a:extLst>
-          </p:cNvPr>
-          <p:cNvSpPr>
-            <a:spLocks xmlns:a="http://schemas.openxmlformats.org/drawingml/2006/main" noGrp="1"/>
-          </p:cNvSpPr>
-          <p:nvPr/>
-        </p:nvSpPr>
-        <p:spPr>
-          <a:xfrm xmlns:a="http://schemas.openxmlformats.org/drawingml/2006/main">
-            <a:off x="4429125" y="4514850"/>
-            <a:ext cx="3333750" cy="1066800"/>
-          </a:xfrm>
-          <a:prstGeom xmlns:a="http://schemas.openxmlformats.org/drawingml/2006/main" prst="rect">
-            <a:avLst/>
-          </a:prstGeom>
-          <a:noFill xmlns:a="http://schemas.openxmlformats.org/drawingml/2006/main"/>
-          <a:ln xmlns:a="http://schemas.openxmlformats.org/drawingml/2006/main" w="0">
-            <a:noFill/>
-          </a:ln>
-        </p:spPr>
-        <p:txBody>
-          <a:bodyPr xmlns:a="http://schemas.openxmlformats.org/drawingml/2006/main" wrap="square" lIns="0" tIns="0" rIns="0" bIns="0" anchor="t">
-            <a:noAutofit/>
-          </a:bodyPr>
-          <a:lstStyle xmlns:a="http://schemas.openxmlformats.org/drawingml/2006/main"/>
-          <a:p xmlns:a="http://schemas.openxmlformats.org/drawingml/2006/main">
-            <a:pPr algn="l">
-              <a:defRPr sz="1725" b="0">
-                <a:solidFill>
-                  <a:srgbClr val="17343C"/>
-                </a:solidFill>
-                <a:latin typeface="Arial"/>
-                <a:ea typeface="Arial"/>
-                <a:cs typeface="Arial"/>
-              </a:defRPr>
-            </a:pPr>
-            <a:r>
-              <a:rPr sz="1725" b="0">
-                <a:solidFill>
-                  <a:srgbClr val="17343C"/>
-                </a:solidFill>
-                <a:latin typeface="Arial"/>
-                <a:ea typeface="Arial"/>
-                <a:cs typeface="Arial"/>
-              </a:rPr>
-              <a:t>At least four of five users</a:t>
-            </a:r>
-          </a:p>
-          <a:p xmlns:a="http://schemas.openxmlformats.org/drawingml/2006/main">
-            <a:pPr algn="l">
-              <a:defRPr sz="1725" b="0">
-                <a:solidFill>
-                  <a:srgbClr val="17343C"/>
-                </a:solidFill>
-                <a:latin typeface="Arial"/>
-                <a:ea typeface="Arial"/>
-                <a:cs typeface="Arial"/>
-              </a:defRPr>
-            </a:pPr>
-            <a:r>
-              <a:rPr sz="1725" b="0">
-                <a:solidFill>
-                  <a:srgbClr val="17343C"/>
-                </a:solidFill>
-                <a:latin typeface="Arial"/>
-                <a:ea typeface="Arial"/>
-                <a:cs typeface="Arial"/>
-              </a:rPr>
-              <a:t>finish main tasks unaided</a:t>
-            </a:r>
-          </a:p>
-        </p:txBody>
-      </p:sp>
-      <p:sp>
-        <p:nvSpPr>
-          <p:cNvPr id="10" name="metric-2">
-            <a:extLst xmlns:a="http://schemas.openxmlformats.org/drawingml/2006/main">
-              <a:ext uri="{FF2B5EF4-FFF2-40B4-BE49-F238E27FC236}">
-                <a16:creationId xmlns:a16="http://schemas.microsoft.com/office/drawing/2014/main" id="{3C5C5CDD-FD53-4EFD-936F-787D843420D9}"/>
-              </a:ext>
-            </a:extLst>
-          </p:cNvPr>
-          <p:cNvSpPr>
-            <a:spLocks xmlns:a="http://schemas.openxmlformats.org/drawingml/2006/main" noGrp="1"/>
-          </p:cNvSpPr>
-          <p:nvPr/>
-        </p:nvSpPr>
-        <p:spPr>
-          <a:xfrm xmlns:a="http://schemas.openxmlformats.org/drawingml/2006/main">
-            <a:off x="8172450" y="2514600"/>
-            <a:ext cx="3333750" cy="952500"/>
-          </a:xfrm>
-          <a:prstGeom xmlns:a="http://schemas.openxmlformats.org/drawingml/2006/main" prst="rect">
-            <a:avLst/>
-          </a:prstGeom>
-          <a:noFill xmlns:a="http://schemas.openxmlformats.org/drawingml/2006/main"/>
-          <a:ln xmlns:a="http://schemas.openxmlformats.org/drawingml/2006/main" w="0">
-            <a:noFill/>
-          </a:ln>
-        </p:spPr>
-        <p:txBody>
-          <a:bodyPr xmlns:a="http://schemas.openxmlformats.org/drawingml/2006/main" wrap="square" lIns="0" tIns="0" rIns="0" bIns="0" anchor="t">
-            <a:noAutofit/>
-          </a:bodyPr>
-          <a:lstStyle xmlns:a="http://schemas.openxmlformats.org/drawingml/2006/main"/>
-          <a:p xmlns:a="http://schemas.openxmlformats.org/drawingml/2006/main">
-            <a:pPr algn="l">
-              <a:defRPr sz="4875" b="1">
-                <a:solidFill>
-                  <a:srgbClr val="26746D"/>
-                </a:solidFill>
-                <a:latin typeface="Arial"/>
-                <a:ea typeface="Arial"/>
-                <a:cs typeface="Arial"/>
-              </a:defRPr>
-            </a:pPr>
-            <a:r>
-              <a:rPr sz="4875" b="1">
-                <a:solidFill>
-                  <a:srgbClr val="26746D"/>
-                </a:solidFill>
-                <a:latin typeface="Arial"/>
-                <a:ea typeface="Arial"/>
-                <a:cs typeface="Arial"/>
-              </a:rPr>
-              <a:t>2 sec</a:t>
-            </a:r>
-          </a:p>
-        </p:txBody>
-      </p:sp>
-      <p:sp>
-        <p:nvSpPr>
-          <p:cNvPr id="11" name="metric-label-2">
-            <a:extLst xmlns:a="http://schemas.openxmlformats.org/drawingml/2006/main">
-              <a:ext uri="{FF2B5EF4-FFF2-40B4-BE49-F238E27FC236}">
-                <a16:creationId xmlns:a16="http://schemas.microsoft.com/office/drawing/2014/main" id="{9ED2611F-2BB8-47C5-9ED8-6777D80995BF}"/>
-              </a:ext>
-            </a:extLst>
-          </p:cNvPr>
-          <p:cNvSpPr>
-            <a:spLocks xmlns:a="http://schemas.openxmlformats.org/drawingml/2006/main" noGrp="1"/>
-          </p:cNvSpPr>
-          <p:nvPr/>
-        </p:nvSpPr>
-        <p:spPr>
-          <a:xfrm xmlns:a="http://schemas.openxmlformats.org/drawingml/2006/main">
-            <a:off x="8172450" y="3667125"/>
-            <a:ext cx="3333750" cy="666750"/>
-          </a:xfrm>
-          <a:prstGeom xmlns:a="http://schemas.openxmlformats.org/drawingml/2006/main" prst="rect">
-            <a:avLst/>
-          </a:prstGeom>
-          <a:noFill xmlns:a="http://schemas.openxmlformats.org/drawingml/2006/main"/>
-          <a:ln xmlns:a="http://schemas.openxmlformats.org/drawingml/2006/main" w="0">
-            <a:noFill/>
-          </a:ln>
-        </p:spPr>
-        <p:txBody>
-          <a:bodyPr xmlns:a="http://schemas.openxmlformats.org/drawingml/2006/main" wrap="square" lIns="0" tIns="0" rIns="0" bIns="0" anchor="t">
-            <a:noAutofit/>
-          </a:bodyPr>
-          <a:lstStyle xmlns:a="http://schemas.openxmlformats.org/drawingml/2006/main"/>
-          <a:p xmlns:a="http://schemas.openxmlformats.org/drawingml/2006/main">
-            <a:pPr algn="l">
-              <a:defRPr sz="2100" b="1">
-                <a:solidFill>
-                  <a:srgbClr val="17343C"/>
-                </a:solidFill>
-                <a:latin typeface="Arial"/>
-                <a:ea typeface="Arial"/>
-                <a:cs typeface="Arial"/>
-              </a:defRPr>
-            </a:pPr>
-            <a:r>
-              <a:rPr sz="2100" b="1">
-                <a:solidFill>
-                  <a:srgbClr val="17343C"/>
-                </a:solidFill>
-                <a:latin typeface="Arial"/>
-                <a:ea typeface="Arial"/>
-                <a:cs typeface="Arial"/>
-              </a:rPr>
-              <a:t>Classic search speed</a:t>
-            </a:r>
-          </a:p>
-        </p:txBody>
-      </p:sp>
-      <p:sp>
-        <p:nvSpPr>
-          <p:cNvPr id="12" name="metric-description-2">
-            <a:extLst xmlns:a="http://schemas.openxmlformats.org/drawingml/2006/main">
-              <a:ext uri="{FF2B5EF4-FFF2-40B4-BE49-F238E27FC236}">
-                <a16:creationId xmlns:a16="http://schemas.microsoft.com/office/drawing/2014/main" id="{3D679530-783A-422B-B933-464ADD09A2E4}"/>
-              </a:ext>
-            </a:extLst>
-          </p:cNvPr>
-          <p:cNvSpPr>
-            <a:spLocks xmlns:a="http://schemas.openxmlformats.org/drawingml/2006/main" noGrp="1"/>
-          </p:cNvSpPr>
-          <p:nvPr/>
-        </p:nvSpPr>
-        <p:spPr>
-          <a:xfrm xmlns:a="http://schemas.openxmlformats.org/drawingml/2006/main">
-            <a:off x="8172450" y="4514850"/>
-            <a:ext cx="3333750" cy="1066800"/>
-          </a:xfrm>
-          <a:prstGeom xmlns:a="http://schemas.openxmlformats.org/drawingml/2006/main" prst="rect">
-            <a:avLst/>
-          </a:prstGeom>
-          <a:noFill xmlns:a="http://schemas.openxmlformats.org/drawingml/2006/main"/>
-          <a:ln xmlns:a="http://schemas.openxmlformats.org/drawingml/2006/main" w="0">
-            <a:noFill/>
-          </a:ln>
-        </p:spPr>
-        <p:txBody>
-          <a:bodyPr xmlns:a="http://schemas.openxmlformats.org/drawingml/2006/main" wrap="square" lIns="0" tIns="0" rIns="0" bIns="0" anchor="t">
-            <a:noAutofit/>
-          </a:bodyPr>
-          <a:lstStyle xmlns:a="http://schemas.openxmlformats.org/drawingml/2006/main"/>
-          <a:p xmlns:a="http://schemas.openxmlformats.org/drawingml/2006/main">
-            <a:pPr algn="l">
-              <a:defRPr sz="1725" b="0">
-                <a:solidFill>
-                  <a:srgbClr val="17343C"/>
-                </a:solidFill>
-                <a:latin typeface="Arial"/>
-                <a:ea typeface="Arial"/>
-                <a:cs typeface="Arial"/>
-              </a:defRPr>
-            </a:pPr>
-            <a:r>
-              <a:rPr sz="1725" b="0">
-                <a:solidFill>
-                  <a:srgbClr val="17343C"/>
-                </a:solidFill>
-                <a:latin typeface="Arial"/>
-                <a:ea typeface="Arial"/>
-                <a:cs typeface="Arial"/>
-              </a:rPr>
-              <a:t>At least 95 of 100 searches</a:t>
-            </a:r>
-          </a:p>
-          <a:p xmlns:a="http://schemas.openxmlformats.org/drawingml/2006/main">
-            <a:pPr algn="l">
-              <a:defRPr sz="1725" b="0">
-                <a:solidFill>
-                  <a:srgbClr val="17343C"/>
-                </a:solidFill>
-                <a:latin typeface="Arial"/>
-                <a:ea typeface="Arial"/>
-                <a:cs typeface="Arial"/>
-              </a:defRPr>
-            </a:pPr>
-            <a:r>
-              <a:rPr sz="1725" b="0">
-                <a:solidFill>
-                  <a:srgbClr val="17343C"/>
-                </a:solidFill>
-                <a:latin typeface="Arial"/>
-                <a:ea typeface="Arial"/>
-                <a:cs typeface="Arial"/>
-              </a:rPr>
-              <a:t>finish within two seconds</a:t>
-            </a:r>
-          </a:p>
-        </p:txBody>
-      </p:sp>
-      <p:sp>
-        <p:nvSpPr>
-          <p:cNvPr id="13" name="metric-context">
-            <a:extLst xmlns:a="http://schemas.openxmlformats.org/drawingml/2006/main">
-              <a:ext uri="{FF2B5EF4-FFF2-40B4-BE49-F238E27FC236}">
-                <a16:creationId xmlns:a16="http://schemas.microsoft.com/office/drawing/2014/main" id="{3C4403E8-F70A-45C8-BD84-AF4D4605AAF8}"/>
-              </a:ext>
-            </a:extLst>
-          </p:cNvPr>
-          <p:cNvSpPr>
-            <a:spLocks xmlns:a="http://schemas.openxmlformats.org/drawingml/2006/main" noGrp="1"/>
-          </p:cNvSpPr>
-          <p:nvPr/>
-        </p:nvSpPr>
-        <p:spPr>
-          <a:xfrm xmlns:a="http://schemas.openxmlformats.org/drawingml/2006/main">
-            <a:off x="685800" y="5895975"/>
-            <a:ext cx="10820400" cy="361950"/>
-          </a:xfrm>
-          <a:prstGeom xmlns:a="http://schemas.openxmlformats.org/drawingml/2006/main" prst="rect">
-            <a:avLst/>
-          </a:prstGeom>
-          <a:noFill xmlns:a="http://schemas.openxmlformats.org/drawingml/2006/main"/>
-          <a:ln xmlns:a="http://schemas.openxmlformats.org/drawingml/2006/main" w="0">
-            <a:noFill/>
-          </a:ln>
-        </p:spPr>
-        <p:txBody>
-          <a:bodyPr xmlns:a="http://schemas.openxmlformats.org/drawingml/2006/main" wrap="square" lIns="0" tIns="0" rIns="0" bIns="0" anchor="t">
-            <a:noAutofit/>
-          </a:bodyPr>
-          <a:lstStyle xmlns:a="http://schemas.openxmlformats.org/drawingml/2006/main"/>
-          <a:p xmlns:a="http://schemas.openxmlformats.org/drawingml/2006/main">
-            <a:pPr algn="l">
-              <a:defRPr sz="1725" b="0">
-                <a:solidFill>
-                  <a:srgbClr val="536466"/>
-                </a:solidFill>
-                <a:latin typeface="Arial"/>
-                <a:ea typeface="Arial"/>
-                <a:cs typeface="Arial"/>
-              </a:defRPr>
-            </a:pPr>
-            <a:r>
-              <a:rPr sz="1725" b="0">
-                <a:solidFill>
-                  <a:srgbClr val="536466"/>
-                </a:solidFill>
-                <a:latin typeface="Arial"/>
-                <a:ea typeface="Arial"/>
-                <a:cs typeface="Arial"/>
-              </a:rPr>
-              <a:t>Search test: 500 synthetic assets and 5 concurrent users</a:t>
-            </a:r>
-          </a:p>
-        </p:txBody>
-      </p:sp>
-    </p:spTree>
-    <p:extLst>
-      <p:ext uri="{BB962C8B-B14F-4D97-AF65-F5344CB8AC3E}">
-        <p14:creationId xmlns:p14="http://schemas.microsoft.com/office/powerpoint/2010/main" val="1795847366"/>
-      </p:ext>
-    </p:extLst>
-  </p:cSld>
-</p:sld>
-</file>
-
-<file path=ppt/slides/slide7.xml><?xml version="1.0" encoding="utf-8"?>
-<p:sld xmlns:p="http://schemas.openxmlformats.org/presentationml/2006/main">
-  <p:cSld>
-    <p:bg>
-      <p:bgPr>
-        <a:solidFill xmlns:a="http://schemas.openxmlformats.org/drawingml/2006/main">
-          <a:srgbClr val="FAFAF7"/>
-        </a:solidFill>
-      </p:bgPr>
-    </p:bg>
-    <p:spTree>
-      <p:nvGrpSpPr>
-        <p:cNvPr id="1" name=""/>
-        <p:cNvGrpSpPr/>
-        <p:nvPr/>
-      </p:nvGrpSpPr>
-      <p:grpSpPr>
-        <a:xfrm xmlns:a="http://schemas.openxmlformats.org/drawingml/2006/main"/>
-      </p:grpSpPr>
-      <p:sp>
-        <p:nvSpPr>
-          <p:cNvPr id="6" name="slide-title">
-            <a:extLst xmlns:a="http://schemas.openxmlformats.org/drawingml/2006/main">
-              <a:ext uri="{FF2B5EF4-FFF2-40B4-BE49-F238E27FC236}">
-                <a16:creationId xmlns:a16="http://schemas.microsoft.com/office/drawing/2014/main" id="{D6FB272B-2A57-4CEF-AB6E-0B851E3BB0A9}"/>
-              </a:ext>
-            </a:extLst>
-          </p:cNvPr>
-          <p:cNvSpPr>
-            <a:spLocks xmlns:a="http://schemas.openxmlformats.org/drawingml/2006/main" noGrp="1"/>
-          </p:cNvSpPr>
-          <p:nvPr/>
-        </p:nvSpPr>
-        <p:spPr>
-          <a:xfrm xmlns:a="http://schemas.openxmlformats.org/drawingml/2006/main">
-            <a:off x="685800" y="552450"/>
-            <a:ext cx="10820400" cy="685800"/>
-          </a:xfrm>
-          <a:prstGeom xmlns:a="http://schemas.openxmlformats.org/drawingml/2006/main" prst="rect">
-            <a:avLst/>
-          </a:prstGeom>
-          <a:noFill xmlns:a="http://schemas.openxmlformats.org/drawingml/2006/main"/>
-          <a:ln xmlns:a="http://schemas.openxmlformats.org/drawingml/2006/main" w="0">
-            <a:noFill/>
-          </a:ln>
-        </p:spPr>
-        <p:txBody>
-          <a:bodyPr xmlns:a="http://schemas.openxmlformats.org/drawingml/2006/main" wrap="square" lIns="0" tIns="0" rIns="0" bIns="0" anchor="t">
-            <a:noAutofit/>
-          </a:bodyPr>
-          <a:lstStyle xmlns:a="http://schemas.openxmlformats.org/drawingml/2006/main"/>
-          <a:p xmlns:a="http://schemas.openxmlformats.org/drawingml/2006/main">
-            <a:pPr algn="l">
-              <a:defRPr sz="3450" b="1">
-                <a:solidFill>
-                  <a:srgbClr val="17343C"/>
-                </a:solidFill>
-                <a:latin typeface="Arial"/>
-                <a:ea typeface="Arial"/>
-                <a:cs typeface="Arial"/>
-              </a:defRPr>
-            </a:pPr>
-            <a:r>
-              <a:rPr sz="3450" b="1">
-                <a:solidFill>
-                  <a:srgbClr val="17343C"/>
-                </a:solidFill>
-                <a:latin typeface="Arial"/>
-                <a:ea typeface="Arial"/>
-                <a:cs typeface="Arial"/>
-              </a:rPr>
-              <a:t>Delivery plan</a:t>
-            </a:r>
-          </a:p>
-        </p:txBody>
-      </p:sp>
-      <p:sp>
-        <p:nvSpPr>
-          <p:cNvPr id="2" name="page-number">
-            <a:extLst xmlns:a="http://schemas.openxmlformats.org/drawingml/2006/main">
-              <a:ext uri="{FF2B5EF4-FFF2-40B4-BE49-F238E27FC236}">
-                <a16:creationId xmlns:a16="http://schemas.microsoft.com/office/drawing/2014/main" id="{2E81808A-8151-46A0-9BF3-D6F6FA12F39B}"/>
-              </a:ext>
-            </a:extLst>
-          </p:cNvPr>
-          <p:cNvSpPr>
-            <a:spLocks xmlns:a="http://schemas.openxmlformats.org/drawingml/2006/main" noGrp="1"/>
-          </p:cNvSpPr>
-          <p:nvPr/>
-        </p:nvSpPr>
-        <p:spPr>
-          <a:xfrm xmlns:a="http://schemas.openxmlformats.org/drawingml/2006/main">
-            <a:off x="11049000" y="6372225"/>
-            <a:ext cx="457200" cy="247650"/>
-          </a:xfrm>
-          <a:prstGeom xmlns:a="http://schemas.openxmlformats.org/drawingml/2006/main" prst="rect">
-            <a:avLst/>
-          </a:prstGeom>
-          <a:noFill xmlns:a="http://schemas.openxmlformats.org/drawingml/2006/main"/>
-          <a:ln xmlns:a="http://schemas.openxmlformats.org/drawingml/2006/main" w="0">
-            <a:noFill/>
-          </a:ln>
-        </p:spPr>
-        <p:txBody>
-          <a:bodyPr xmlns:a="http://schemas.openxmlformats.org/drawingml/2006/main" wrap="square" lIns="0" tIns="0" rIns="0" bIns="0" anchor="t">
-            <a:noAutofit/>
-          </a:bodyPr>
-          <a:lstStyle xmlns:a="http://schemas.openxmlformats.org/drawingml/2006/main"/>
-          <a:p xmlns:a="http://schemas.openxmlformats.org/drawingml/2006/main">
-            <a:pPr algn="l">
-              <a:defRPr sz="1350" b="0">
-                <a:solidFill>
-                  <a:srgbClr val="536466"/>
-                </a:solidFill>
-                <a:latin typeface="Arial"/>
-                <a:ea typeface="Arial"/>
-                <a:cs typeface="Arial"/>
-              </a:defRPr>
-            </a:pPr>
-            <a:r>
-              <a:rPr sz="1350" b="0">
-                <a:solidFill>
-                  <a:srgbClr val="536466"/>
-                </a:solidFill>
-                <a:latin typeface="Arial"/>
-                <a:ea typeface="Arial"/>
-                <a:cs typeface="Arial"/>
-              </a:rPr>
-              <a:t>7</a:t>
+              <a:t>Choose technology and hosting after testing the main uncertainties</a:t>
             </a:r>
           </a:p>
         </p:txBody>
       </p:sp>
       <p:graphicFrame>
         <p:nvGraphicFramePr>
-          <p:cNvPr id="8" name=""/>
+          <p:cNvPr id="10" name=""/>
           <p:cNvGraphicFramePr/>
           <p:nvPr/>
         </p:nvGraphicFramePr>
         <p:xfrm>
-          <a:off xmlns:a="http://schemas.openxmlformats.org/drawingml/2006/main" x="685800" y="1676400"/>
-          <a:ext xmlns:a="http://schemas.openxmlformats.org/drawingml/2006/main" cx="10820400" cy="2952750"/>
+          <a:off xmlns:a="http://schemas.openxmlformats.org/drawingml/2006/main" x="685800" y="2266950"/>
+          <a:ext xmlns:a="http://schemas.openxmlformats.org/drawingml/2006/main" cx="10820400" cy="2895600"/>
         </p:xfrm>
         <a:graphic xmlns:a="http://schemas.openxmlformats.org/drawingml/2006/main">
           <a:graphicData uri="http://schemas.openxmlformats.org/drawingml/2006/table">
             <a:tbl>
               <a:tblPr firstRow="0" firstCol="0" bandRow="0"/>
               <a:tblGrid>
-                <a:gridCol w="4114800"/>
-                <a:gridCol w="6705600"/>
+                <a:gridCol w="2324100"/>
+                <a:gridCol w="8496300"/>
               </a:tblGrid>
-              <a:tr h="552450">
+              <a:tr h="533400">
                 <a:tc>
                   <a:txBody>
-                    <a:bodyPr lIns="0" tIns="57150" rIns="114300" bIns="57150">
+                    <a:bodyPr lIns="76200" tIns="57150" rIns="114300" bIns="57150">
                       <a:noAutofit/>
                     </a:bodyPr>
                     <a:lstStyle/>
@@ -5528,7 +4880,7 @@
                           <a:ea typeface="Arial"/>
                           <a:cs typeface="Arial"/>
                         </a:rPr>
-                        <a:t>Phase</a:t>
+                        <a:t>Owner</a:t>
                       </a:r>
                     </a:p>
                   </a:txBody>
@@ -5540,7 +4892,7 @@
                 </a:tc>
                 <a:tc>
                   <a:txBody>
-                    <a:bodyPr lIns="0" tIns="57150" rIns="114300" bIns="57150">
+                    <a:bodyPr lIns="76200" tIns="57150" rIns="114300" bIns="57150">
                       <a:noAutofit/>
                     </a:bodyPr>
                     <a:lstStyle/>
@@ -5554,7 +4906,7 @@
                           <a:ea typeface="Arial"/>
                           <a:cs typeface="Arial"/>
                         </a:rPr>
-                        <a:t>Next deliverable</a:t>
+                        <a:t>Next responsibility</a:t>
                       </a:r>
                     </a:p>
                   </a:txBody>
@@ -5565,10 +4917,10 @@
                   </a:tcPr>
                 </a:tc>
               </a:tr>
-              <a:tr h="800100">
+              <a:tr h="723900">
                 <a:tc>
                   <a:txBody>
-                    <a:bodyPr lIns="0" tIns="57150" rIns="114300" bIns="57150">
+                    <a:bodyPr lIns="76200" tIns="57150" rIns="114300" bIns="57150">
                       <a:noAutofit/>
                     </a:bodyPr>
                     <a:lstStyle/>
@@ -5582,7 +4934,7 @@
                           <a:ea typeface="Arial"/>
                           <a:cs typeface="Arial"/>
                         </a:rPr>
-                        <a:t>2  Feasibility</a:t>
+                        <a:t>Sultan</a:t>
                       </a:r>
                     </a:p>
                   </a:txBody>
@@ -5594,7 +4946,7 @@
                 </a:tc>
                 <a:tc>
                   <a:txBody>
-                    <a:bodyPr lIns="0" tIns="57150" rIns="114300" bIns="57150">
+                    <a:bodyPr lIns="76200" tIns="57150" rIns="114300" bIns="57150">
                       <a:noAutofit/>
                     </a:bodyPr>
                     <a:lstStyle/>
@@ -5608,7 +4960,7 @@
                           <a:ea typeface="Arial"/>
                           <a:cs typeface="Arial"/>
                         </a:rPr>
-                        <a:t>Choose technology, AI access and hosting</a:t>
+                        <a:t>Coordinate the plan and backend dependencies</a:t>
                       </a:r>
                     </a:p>
                   </a:txBody>
@@ -5619,10 +4971,10 @@
                   </a:tcPr>
                 </a:tc>
               </a:tr>
-              <a:tr h="800100">
+              <a:tr h="723900">
                 <a:tc>
                   <a:txBody>
-                    <a:bodyPr lIns="0" tIns="57150" rIns="114300" bIns="57150">
+                    <a:bodyPr lIns="76200" tIns="57150" rIns="114300" bIns="57150">
                       <a:noAutofit/>
                     </a:bodyPr>
                     <a:lstStyle/>
@@ -5636,7 +4988,7 @@
                           <a:ea typeface="Arial"/>
                           <a:cs typeface="Arial"/>
                         </a:rPr>
-                        <a:t>3–5  Requirements and design</a:t>
+                        <a:t>Zayed</a:t>
                       </a:r>
                     </a:p>
                   </a:txBody>
@@ -5648,7 +5000,7 @@
                 </a:tc>
                 <a:tc>
                   <a:txBody>
-                    <a:bodyPr lIns="0" tIns="57150" rIns="114300" bIns="57150">
+                    <a:bodyPr lIns="76200" tIns="57150" rIns="114300" bIns="57150">
                       <a:noAutofit/>
                     </a:bodyPr>
                     <a:lstStyle/>
@@ -5662,7 +5014,7 @@
                           <a:ea typeface="Arial"/>
                           <a:cs typeface="Arial"/>
                         </a:rPr>
-                        <a:t>Validate needs and define the architecture</a:t>
+                        <a:t>Draft feasibility and plan stakeholder validation</a:t>
                       </a:r>
                     </a:p>
                   </a:txBody>
@@ -5673,10 +5025,10 @@
                   </a:tcPr>
                 </a:tc>
               </a:tr>
-              <a:tr h="800100">
+              <a:tr h="914400">
                 <a:tc>
                   <a:txBody>
-                    <a:bodyPr lIns="0" tIns="57150" rIns="114300" bIns="57150">
+                    <a:bodyPr lIns="76200" tIns="57150" rIns="114300" bIns="57150">
                       <a:noAutofit/>
                     </a:bodyPr>
                     <a:lstStyle/>
@@ -5690,7 +5042,7 @@
                           <a:ea typeface="Arial"/>
                           <a:cs typeface="Arial"/>
                         </a:rPr>
-                        <a:t>6–8  Build, deploy and test</a:t>
+                        <a:t>Ghith</a:t>
                       </a:r>
                     </a:p>
                   </a:txBody>
@@ -5702,7 +5054,7 @@
                 </a:tc>
                 <a:tc>
                   <a:txBody>
-                    <a:bodyPr lIns="0" tIns="57150" rIns="114300" bIns="57150">
+                    <a:bodyPr lIns="76200" tIns="57150" rIns="114300" bIns="57150">
                       <a:noAutofit/>
                     </a:bodyPr>
                     <a:lstStyle/>
@@ -5716,7 +5068,20 @@
                           <a:ea typeface="Arial"/>
                           <a:cs typeface="Arial"/>
                         </a:rPr>
-                        <a:t>Hosted application, evaluation and final demo</a:t>
+                        <a:t>Evaluate two AI providers and propose</a:t>
+                      </a:r>
+                    </a:p>
+                    <a:p>
+                      <a:r>
+                        <a:rPr sz="2025" b="0">
+                          <a:solidFill>
+                            <a:srgbClr val="17343C"/>
+                          </a:solidFill>
+                          <a:latin typeface="Arial"/>
+                          <a:ea typeface="Arial"/>
+                          <a:cs typeface="Arial"/>
+                        </a:rPr>
+                        <a:t>the stack and hosting</a:t>
                       </a:r>
                     </a:p>
                   </a:txBody>
@@ -5733,10 +5098,10 @@
       </p:graphicFrame>
       <p:sp>
         <p:nvSpPr>
-          <p:cNvPr id="4" name="iteration">
+          <p:cNvPr id="5" name="working-method">
             <a:extLst xmlns:a="http://schemas.openxmlformats.org/drawingml/2006/main">
               <a:ext uri="{FF2B5EF4-FFF2-40B4-BE49-F238E27FC236}">
-                <a16:creationId xmlns:a16="http://schemas.microsoft.com/office/drawing/2014/main" id="{140A2C3F-6D54-4477-B31C-94053F70F1F3}"/>
+                <a16:creationId xmlns:a16="http://schemas.microsoft.com/office/drawing/2014/main" id="{86A17F7E-4FDD-49F1-A638-8502608F0D80}"/>
               </a:ext>
             </a:extLst>
           </p:cNvPr>
@@ -5747,8 +5112,8 @@
         </p:nvSpPr>
         <p:spPr>
           <a:xfrm xmlns:a="http://schemas.openxmlformats.org/drawingml/2006/main">
-            <a:off x="685800" y="5048250"/>
-            <a:ext cx="10820400" cy="628650"/>
+            <a:off x="685800" y="5476875"/>
+            <a:ext cx="10820400" cy="542925"/>
           </a:xfrm>
           <a:prstGeom xmlns:a="http://schemas.openxmlformats.org/drawingml/2006/main" prst="rect">
             <a:avLst/>
@@ -5765,17 +5130,17 @@
           <a:lstStyle xmlns:a="http://schemas.openxmlformats.org/drawingml/2006/main"/>
           <a:p xmlns:a="http://schemas.openxmlformats.org/drawingml/2006/main">
             <a:pPr algn="l">
-              <a:defRPr sz="2325" b="1">
-                <a:solidFill>
-                  <a:srgbClr val="17343C"/>
-                </a:solidFill>
-                <a:latin typeface="Arial"/>
-                <a:ea typeface="Arial"/>
-                <a:cs typeface="Arial"/>
-              </a:defRPr>
-            </a:pPr>
-            <a:r>
-              <a:rPr sz="2325" b="1">
+              <a:defRPr sz="2250" b="1">
+                <a:solidFill>
+                  <a:srgbClr val="17343C"/>
+                </a:solidFill>
+                <a:latin typeface="Arial"/>
+                <a:ea typeface="Arial"/>
+                <a:cs typeface="Arial"/>
+              </a:defRPr>
+            </a:pPr>
+            <a:r>
+              <a:rPr sz="2250" b="1">
                 <a:solidFill>
                   <a:srgbClr val="17343C"/>
                 </a:solidFill>
@@ -5790,10 +5155,10 @@
       </p:sp>
       <p:sp>
         <p:nvSpPr>
-          <p:cNvPr id="5" name="ownership">
+          <p:cNvPr id="6" name="later">
             <a:extLst xmlns:a="http://schemas.openxmlformats.org/drawingml/2006/main">
               <a:ext uri="{FF2B5EF4-FFF2-40B4-BE49-F238E27FC236}">
-                <a16:creationId xmlns:a16="http://schemas.microsoft.com/office/drawing/2014/main" id="{966F85A5-5145-4E82-9AD3-DF69790E20E0}"/>
+                <a16:creationId xmlns:a16="http://schemas.microsoft.com/office/drawing/2014/main" id="{6D0BE914-49BA-48D5-BF82-B5028C574DA9}"/>
               </a:ext>
             </a:extLst>
           </p:cNvPr>
@@ -5804,8 +5169,8 @@
         </p:nvSpPr>
         <p:spPr>
           <a:xfrm xmlns:a="http://schemas.openxmlformats.org/drawingml/2006/main">
-            <a:off x="685800" y="5895975"/>
-            <a:ext cx="10820400" cy="533400"/>
+            <a:off x="685800" y="6115050"/>
+            <a:ext cx="10820400" cy="342900"/>
           </a:xfrm>
           <a:prstGeom xmlns:a="http://schemas.openxmlformats.org/drawingml/2006/main" prst="rect">
             <a:avLst/>
@@ -5822,7 +5187,7 @@
           <a:lstStyle xmlns:a="http://schemas.openxmlformats.org/drawingml/2006/main"/>
           <a:p xmlns:a="http://schemas.openxmlformats.org/drawingml/2006/main">
             <a:pPr algn="l">
-              <a:defRPr sz="1725" b="0">
+              <a:defRPr sz="1875" b="0">
                 <a:solidFill>
                   <a:srgbClr val="536466"/>
                 </a:solidFill>
@@ -5832,7 +5197,7 @@
               </a:defRPr>
             </a:pPr>
             <a:r>
-              <a:rPr sz="1725" b="0">
+              <a:rPr sz="1875" b="0">
                 <a:solidFill>
                   <a:srgbClr val="536466"/>
                 </a:solidFill>
@@ -5840,7 +5205,7 @@
                 <a:ea typeface="Arial"/>
                 <a:cs typeface="Arial"/>
               </a:rPr>
-              <a:t>Sultan: planning and backend    Zayed: requirements and UX    Ghith: AI and architecture</a:t>
+              <a:t>Then refine requirements, design, build, deploy and test</a:t>
             </a:r>
           </a:p>
         </p:txBody>
@@ -5848,7 +5213,7 @@
     </p:spTree>
     <p:extLst>
       <p:ext uri="{BB962C8B-B14F-4D97-AF65-F5344CB8AC3E}">
-        <p14:creationId xmlns:p14="http://schemas.microsoft.com/office/powerpoint/2010/main" val="1389617761"/>
+        <p14:creationId xmlns:p14="http://schemas.microsoft.com/office/powerpoint/2010/main" val="462551477"/>
       </p:ext>
     </p:extLst>
   </p:cSld>

</xml_diff>